<commit_message>
Translate presentation slides to Thai for oral defense
Team will present in Thai, so all descriptive content (headings,
body text, chart legends/categories, callouts, limitations) is now
Thai — model names, metric names, and code/feature identifiers
(XGBoost, ROC-AUC, ret_1d, etc.) stay in English per standard Thai
academic-presentation convention. Switched fonts from Cambria/
Calibri to Leelawadee UI, which ships with Windows 10/11 and renders
both Thai and Latin script; the earlier fonts have no Thai glyphs.

Co-Authored-By: Claude Sonnet 5 <noreply@anthropic.com>
</commit_message>
<xml_diff>
--- a/ml/stock_direction_presentation.pptx
+++ b/ml/stock_direction_presentation.pptx
@@ -700,7 +700,7 @@
               <c:strCache>
                 <c:ptCount val="1"/>
                 <c:pt idx="0">
-                  <c:v>XGBoost Accuracy</c:v>
+                  <c:v>ความแม่นยำ XGBoost</c:v>
                 </c:pt>
               </c:strCache>
             </c:strRef>
@@ -723,7 +723,7 @@
                     <a:solidFill>
                       <a:srgbClr val="F5F5F5"/>
                     </a:solidFill>
-                    <a:latin typeface="Arial"/>
+                    <a:latin typeface="Leelawadee UI"/>
                   </a:defRPr>
                 </a:pPr>
               </a:p>
@@ -743,13 +743,13 @@
                 <c:ptCount val="3"/>
                 <c:lvl>
                   <c:pt idx="0">
-                    <c:v>1 day</c:v>
+                    <c:v>1 วัน</c:v>
                   </c:pt>
                   <c:pt idx="1">
-                    <c:v>5 days</c:v>
+                    <c:v>5 วัน</c:v>
                   </c:pt>
                   <c:pt idx="2">
-                    <c:v>10 days</c:v>
+                    <c:v>10 วัน</c:v>
                   </c:pt>
                 </c:lvl>
               </c:multiLvlStrCache>
@@ -783,7 +783,7 @@
               <c:strCache>
                 <c:ptCount val="1"/>
                 <c:pt idx="0">
-                  <c:v>Majority Baseline</c:v>
+                  <c:v>Baseline (ทายกลุ่มมากสุด)</c:v>
                 </c:pt>
               </c:strCache>
             </c:strRef>
@@ -806,7 +806,7 @@
                     <a:solidFill>
                       <a:srgbClr val="F5F5F5"/>
                     </a:solidFill>
-                    <a:latin typeface="Arial"/>
+                    <a:latin typeface="Leelawadee UI"/>
                   </a:defRPr>
                 </a:pPr>
               </a:p>
@@ -826,13 +826,13 @@
                 <c:ptCount val="3"/>
                 <c:lvl>
                   <c:pt idx="0">
-                    <c:v>1 day</c:v>
+                    <c:v>1 วัน</c:v>
                   </c:pt>
                   <c:pt idx="1">
-                    <c:v>5 days</c:v>
+                    <c:v>5 วัน</c:v>
                   </c:pt>
                   <c:pt idx="2">
-                    <c:v>10 days</c:v>
+                    <c:v>10 วัน</c:v>
                   </c:pt>
                 </c:lvl>
               </c:multiLvlStrCache>
@@ -868,7 +868,7 @@
                   <a:solidFill>
                     <a:srgbClr val="F5F5F5"/>
                   </a:solidFill>
-                  <a:latin typeface="Arial"/>
+                  <a:latin typeface="Leelawadee UI"/>
                 </a:defRPr>
               </a:pPr>
             </a:p>
@@ -916,7 +916,7 @@
                 <a:solidFill>
                   <a:srgbClr val="9AA5B1"/>
                 </a:solidFill>
-                <a:latin typeface="Arial"/>
+                <a:latin typeface="Leelawadee UI"/>
               </a:defRPr>
             </a:pPr>
             <a:endParaRPr lang="en-US"/>
@@ -987,6 +987,8 @@
               <a:solidFill>
                 <a:srgbClr val="9AA5B1"/>
               </a:solidFill>
+              <a:latin typeface="Leelawadee UI"/>
+              <a:cs typeface="Leelawadee UI"/>
             </a:defRPr>
           </a:pPr>
           <a:endParaRPr lang="en-US"/>
@@ -3417,9 +3419,9 @@
                 <a:solidFill>
                   <a:srgbClr val="A3E635"/>
                 </a:solidFill>
-                <a:latin typeface="Calibri" pitchFamily="34" charset="0"/>
-                <a:ea typeface="Calibri" pitchFamily="34" charset="-122"/>
-                <a:cs typeface="Calibri" pitchFamily="34" charset="-120"/>
+                <a:latin typeface="Leelawadee UI" pitchFamily="34" charset="0"/>
+                <a:ea typeface="Leelawadee UI" pitchFamily="34" charset="-122"/>
+                <a:cs typeface="Leelawadee UI" pitchFamily="34" charset="-120"/>
               </a:rPr>
               <a:t>STOCKSCOPE AI</a:t>
             </a:r>
@@ -3450,7 +3452,7 @@
           <a:p>
             <a:pPr indent="0" marL="0">
               <a:lnSpc>
-                <a:spcPts val="5200"/>
+                <a:spcPts val="5600"/>
               </a:lnSpc>
               <a:buNone/>
             </a:pPr>
@@ -3459,18 +3461,18 @@
                 <a:solidFill>
                   <a:srgbClr val="F5F5F5"/>
                 </a:solidFill>
-                <a:latin typeface="Cambria" pitchFamily="34" charset="0"/>
-                <a:ea typeface="Cambria" pitchFamily="34" charset="-122"/>
-                <a:cs typeface="Cambria" pitchFamily="34" charset="-120"/>
-              </a:rPr>
-              <a:t>Stock Direction Prediction</a:t>
+                <a:latin typeface="Leelawadee UI" pitchFamily="34" charset="0"/>
+                <a:ea typeface="Leelawadee UI" pitchFamily="34" charset="-122"/>
+                <a:cs typeface="Leelawadee UI" pitchFamily="34" charset="-120"/>
+              </a:rPr>
+              <a:t>ทำนายทิศทางหุ้น</a:t>
             </a:r>
             <a:endParaRPr lang="en-US" sz="4600" dirty="0"/>
           </a:p>
           <a:p>
             <a:pPr indent="0" marL="0">
               <a:lnSpc>
-                <a:spcPts val="5200"/>
+                <a:spcPts val="5600"/>
               </a:lnSpc>
               <a:buNone/>
             </a:pPr>
@@ -3479,11 +3481,11 @@
                 <a:solidFill>
                   <a:srgbClr val="F5F5F5"/>
                 </a:solidFill>
-                <a:latin typeface="Cambria" pitchFamily="34" charset="0"/>
-                <a:ea typeface="Cambria" pitchFamily="34" charset="-122"/>
-                <a:cs typeface="Cambria" pitchFamily="34" charset="-120"/>
-              </a:rPr>
-              <a:t>with XGBoost</a:t>
+                <a:latin typeface="Leelawadee UI" pitchFamily="34" charset="0"/>
+                <a:ea typeface="Leelawadee UI" pitchFamily="34" charset="-122"/>
+                <a:cs typeface="Leelawadee UI" pitchFamily="34" charset="-120"/>
+              </a:rPr>
+              <a:t>ด้วย XGBoost</a:t>
             </a:r>
             <a:endParaRPr lang="en-US" sz="4600" dirty="0"/>
           </a:p>
@@ -3498,7 +3500,7 @@
         <p:spPr>
           <a:xfrm>
             <a:off x="822960" y="4160520"/>
-            <a:ext cx="7772400" cy="457200"/>
+            <a:ext cx="8412480" cy="457200"/>
           </a:xfrm>
           <a:prstGeom prst="rect">
             <a:avLst/>
@@ -3514,17 +3516,17 @@
               <a:buNone/>
             </a:pPr>
             <a:r>
-              <a:rPr lang="en-US" sz="1800" dirty="0">
+              <a:rPr lang="en-US" sz="1700" dirty="0">
                 <a:solidFill>
                   <a:srgbClr val="9AA5B1"/>
                 </a:solidFill>
-                <a:latin typeface="Calibri" pitchFamily="34" charset="0"/>
-                <a:ea typeface="Calibri" pitchFamily="34" charset="-122"/>
-                <a:cs typeface="Calibri" pitchFamily="34" charset="-120"/>
-              </a:rPr>
-              <a:t>A leakage-free machine learning pipeline extending our live dashboard</a:t>
-            </a:r>
-            <a:endParaRPr lang="en-US" sz="1800" dirty="0"/>
+                <a:latin typeface="Leelawadee UI" pitchFamily="34" charset="0"/>
+                <a:ea typeface="Leelawadee UI" pitchFamily="34" charset="-122"/>
+                <a:cs typeface="Leelawadee UI" pitchFamily="34" charset="-120"/>
+              </a:rPr>
+              <a:t>ไปป์ไลน์ Machine Learning แบบไม่รั่วไหลข้อมูล ต่อยอดจากแดชบอร์ดที่ใช้งานจริง</a:t>
+            </a:r>
+            <a:endParaRPr lang="en-US" sz="1700" dirty="0"/>
           </a:p>
         </p:txBody>
       </p:sp>
@@ -3579,11 +3581,11 @@
                 <a:solidFill>
                   <a:srgbClr val="F5F5F5"/>
                 </a:solidFill>
-                <a:latin typeface="Calibri" pitchFamily="34" charset="0"/>
-                <a:ea typeface="Calibri" pitchFamily="34" charset="-122"/>
-                <a:cs typeface="Calibri" pitchFamily="34" charset="-120"/>
-              </a:rPr>
-              <a:t>Group ___  ·  [Team Name Here]</a:t>
+                <a:latin typeface="Leelawadee UI" pitchFamily="34" charset="0"/>
+                <a:ea typeface="Leelawadee UI" pitchFamily="34" charset="-122"/>
+                <a:cs typeface="Leelawadee UI" pitchFamily="34" charset="-120"/>
+              </a:rPr>
+              <a:t>กลุ่ม ___  ·  [ชื่อทีมที่นี่]</a:t>
             </a:r>
             <a:endParaRPr lang="en-US" sz="1300" dirty="0"/>
           </a:p>
@@ -3598,7 +3600,7 @@
         <p:spPr>
           <a:xfrm>
             <a:off x="822960" y="6217920"/>
-            <a:ext cx="8229600" cy="320040"/>
+            <a:ext cx="9144000" cy="320040"/>
           </a:xfrm>
           <a:prstGeom prst="rect">
             <a:avLst/>
@@ -3618,11 +3620,11 @@
                 <a:solidFill>
                   <a:srgbClr val="5B6B7C"/>
                 </a:solidFill>
-                <a:latin typeface="Calibri" pitchFamily="34" charset="0"/>
-                <a:ea typeface="Calibri" pitchFamily="34" charset="-122"/>
-                <a:cs typeface="Calibri" pitchFamily="34" charset="-120"/>
-              </a:rPr>
-              <a:t>CP020003 · Artificial Intelligence · Final Project · Khon Kaen University 2026</a:t>
+                <a:latin typeface="Leelawadee UI" pitchFamily="34" charset="0"/>
+                <a:ea typeface="Leelawadee UI" pitchFamily="34" charset="-122"/>
+                <a:cs typeface="Leelawadee UI" pitchFamily="34" charset="-120"/>
+              </a:rPr>
+              <a:t>CP020003 · ปัญญาประดิษฐ์ · โปรเจกต์จบภาคการศึกษา · มหาวิทยาลัยขอนแก่น 2026</a:t>
             </a:r>
             <a:endParaRPr lang="en-US" sz="1100" dirty="0"/>
           </a:p>
@@ -3865,9 +3867,9 @@
                 <a:solidFill>
                   <a:srgbClr val="5B6B7C"/>
                 </a:solidFill>
-                <a:latin typeface="Calibri" pitchFamily="34" charset="0"/>
-                <a:ea typeface="Calibri" pitchFamily="34" charset="-122"/>
-                <a:cs typeface="Calibri" pitchFamily="34" charset="-120"/>
+                <a:latin typeface="Leelawadee UI" pitchFamily="34" charset="0"/>
+                <a:ea typeface="Leelawadee UI" pitchFamily="34" charset="-122"/>
+                <a:cs typeface="Leelawadee UI" pitchFamily="34" charset="-120"/>
               </a:rPr>
               <a:t>10</a:t>
             </a:r>
@@ -3904,9 +3906,9 @@
                 <a:solidFill>
                   <a:srgbClr val="5B6B7C"/>
                 </a:solidFill>
-                <a:latin typeface="Calibri" pitchFamily="34" charset="0"/>
-                <a:ea typeface="Calibri" pitchFamily="34" charset="-122"/>
-                <a:cs typeface="Calibri" pitchFamily="34" charset="-120"/>
+                <a:latin typeface="Leelawadee UI" pitchFamily="34" charset="0"/>
+                <a:ea typeface="Leelawadee UI" pitchFamily="34" charset="-122"/>
+                <a:cs typeface="Leelawadee UI" pitchFamily="34" charset="-120"/>
               </a:rPr>
               <a:t>Stockscope AI · CP020003</a:t>
             </a:r>
@@ -3943,11 +3945,11 @@
                 <a:solidFill>
                   <a:srgbClr val="A3E635"/>
                 </a:solidFill>
-                <a:latin typeface="Calibri" pitchFamily="34" charset="0"/>
-                <a:ea typeface="Calibri" pitchFamily="34" charset="-122"/>
-                <a:cs typeface="Calibri" pitchFamily="34" charset="-120"/>
-              </a:rPr>
-              <a:t>RESULTS &amp; EVALUATION</a:t>
+                <a:latin typeface="Leelawadee UI" pitchFamily="34" charset="0"/>
+                <a:ea typeface="Leelawadee UI" pitchFamily="34" charset="-122"/>
+                <a:cs typeface="Leelawadee UI" pitchFamily="34" charset="-120"/>
+              </a:rPr>
+              <a:t>ผลลัพธ์และการประเมิน</a:t>
             </a:r>
             <a:endParaRPr lang="en-US" sz="1300" dirty="0"/>
           </a:p>
@@ -3982,11 +3984,11 @@
                 <a:solidFill>
                   <a:srgbClr val="F5F5F5"/>
                 </a:solidFill>
-                <a:latin typeface="Cambria" pitchFamily="34" charset="0"/>
-                <a:ea typeface="Cambria" pitchFamily="34" charset="-122"/>
-                <a:cs typeface="Cambria" pitchFamily="34" charset="-120"/>
-              </a:rPr>
-              <a:t>Does the Prediction Horizon Matter?</a:t>
+                <a:latin typeface="Leelawadee UI" pitchFamily="34" charset="0"/>
+                <a:ea typeface="Leelawadee UI" pitchFamily="34" charset="-122"/>
+                <a:cs typeface="Leelawadee UI" pitchFamily="34" charset="-120"/>
+              </a:rPr>
+              <a:t>ระยะเวลาทำนายมีผลไหม?</a:t>
             </a:r>
             <a:endParaRPr lang="en-US" sz="3200" dirty="0"/>
           </a:p>
@@ -4021,11 +4023,11 @@
                 <a:solidFill>
                   <a:srgbClr val="9AA5B1"/>
                 </a:solidFill>
-                <a:latin typeface="Calibri" pitchFamily="34" charset="0"/>
-                <a:ea typeface="Calibri" pitchFamily="34" charset="-122"/>
-                <a:cs typeface="Calibri" pitchFamily="34" charset="-120"/>
-              </a:rPr>
-              <a:t>Same leakage-free pipeline, repeated at three horizons — 1, 5, and 10 trading days ahead.</a:t>
+                <a:latin typeface="Leelawadee UI" pitchFamily="34" charset="0"/>
+                <a:ea typeface="Leelawadee UI" pitchFamily="34" charset="-122"/>
+                <a:cs typeface="Leelawadee UI" pitchFamily="34" charset="-120"/>
+              </a:rPr>
+              <a:t>ใช้ไปป์ไลน์เดียวกัน ทดสอบ 3 ระยะเวลา — 1, 5 และ 10 วันทำการข้างหน้า</a:t>
             </a:r>
             <a:endParaRPr lang="en-US" sz="1300" dirty="0"/>
           </a:p>
@@ -4105,11 +4107,11 @@
                 <a:solidFill>
                   <a:srgbClr val="9AA5B1"/>
                 </a:solidFill>
-                <a:latin typeface="Calibri" pitchFamily="34" charset="0"/>
-                <a:ea typeface="Calibri" pitchFamily="34" charset="-122"/>
-                <a:cs typeface="Calibri" pitchFamily="34" charset="-120"/>
-              </a:rPr>
-              <a:t>ROC-AUC BY HORIZON</a:t>
+                <a:latin typeface="Leelawadee UI" pitchFamily="34" charset="0"/>
+                <a:ea typeface="Leelawadee UI" pitchFamily="34" charset="-122"/>
+                <a:cs typeface="Leelawadee UI" pitchFamily="34" charset="-120"/>
+              </a:rPr>
+              <a:t>ROC-AUC ตามระยะเวลา</a:t>
             </a:r>
             <a:endParaRPr lang="en-US" sz="1100" dirty="0"/>
           </a:p>
@@ -4144,11 +4146,11 @@
                 <a:solidFill>
                   <a:srgbClr val="F5F5F5"/>
                 </a:solidFill>
-                <a:latin typeface="Calibri" pitchFamily="34" charset="0"/>
-                <a:ea typeface="Calibri" pitchFamily="34" charset="-122"/>
-                <a:cs typeface="Calibri" pitchFamily="34" charset="-120"/>
-              </a:rPr>
-              <a:t>1 day</a:t>
+                <a:latin typeface="Leelawadee UI" pitchFamily="34" charset="0"/>
+                <a:ea typeface="Leelawadee UI" pitchFamily="34" charset="-122"/>
+                <a:cs typeface="Leelawadee UI" pitchFamily="34" charset="-120"/>
+              </a:rPr>
+              <a:t>1 วัน</a:t>
             </a:r>
             <a:endParaRPr lang="en-US" sz="1400" dirty="0"/>
           </a:p>
@@ -4183,9 +4185,9 @@
                 <a:solidFill>
                   <a:srgbClr val="9AA5B1"/>
                 </a:solidFill>
-                <a:latin typeface="Cambria" pitchFamily="34" charset="0"/>
-                <a:ea typeface="Cambria" pitchFamily="34" charset="-122"/>
-                <a:cs typeface="Cambria" pitchFamily="34" charset="-120"/>
+                <a:latin typeface="Leelawadee UI" pitchFamily="34" charset="0"/>
+                <a:ea typeface="Leelawadee UI" pitchFamily="34" charset="-122"/>
+                <a:cs typeface="Leelawadee UI" pitchFamily="34" charset="-120"/>
               </a:rPr>
               <a:t>0.505</a:t>
             </a:r>
@@ -4222,11 +4224,11 @@
                 <a:solidFill>
                   <a:srgbClr val="F5F5F5"/>
                 </a:solidFill>
-                <a:latin typeface="Calibri" pitchFamily="34" charset="0"/>
-                <a:ea typeface="Calibri" pitchFamily="34" charset="-122"/>
-                <a:cs typeface="Calibri" pitchFamily="34" charset="-120"/>
-              </a:rPr>
-              <a:t>5 days</a:t>
+                <a:latin typeface="Leelawadee UI" pitchFamily="34" charset="0"/>
+                <a:ea typeface="Leelawadee UI" pitchFamily="34" charset="-122"/>
+                <a:cs typeface="Leelawadee UI" pitchFamily="34" charset="-120"/>
+              </a:rPr>
+              <a:t>5 วัน</a:t>
             </a:r>
             <a:endParaRPr lang="en-US" sz="1400" dirty="0"/>
           </a:p>
@@ -4261,9 +4263,9 @@
                 <a:solidFill>
                   <a:srgbClr val="9AA5B1"/>
                 </a:solidFill>
-                <a:latin typeface="Cambria" pitchFamily="34" charset="0"/>
-                <a:ea typeface="Cambria" pitchFamily="34" charset="-122"/>
-                <a:cs typeface="Cambria" pitchFamily="34" charset="-120"/>
+                <a:latin typeface="Leelawadee UI" pitchFamily="34" charset="0"/>
+                <a:ea typeface="Leelawadee UI" pitchFamily="34" charset="-122"/>
+                <a:cs typeface="Leelawadee UI" pitchFamily="34" charset="-120"/>
               </a:rPr>
               <a:t>0.507</a:t>
             </a:r>
@@ -4300,11 +4302,11 @@
                 <a:solidFill>
                   <a:srgbClr val="F5F5F5"/>
                 </a:solidFill>
-                <a:latin typeface="Calibri" pitchFamily="34" charset="0"/>
-                <a:ea typeface="Calibri" pitchFamily="34" charset="-122"/>
-                <a:cs typeface="Calibri" pitchFamily="34" charset="-120"/>
-              </a:rPr>
-              <a:t>10 days</a:t>
+                <a:latin typeface="Leelawadee UI" pitchFamily="34" charset="0"/>
+                <a:ea typeface="Leelawadee UI" pitchFamily="34" charset="-122"/>
+                <a:cs typeface="Leelawadee UI" pitchFamily="34" charset="-120"/>
+              </a:rPr>
+              <a:t>10 วัน</a:t>
             </a:r>
             <a:endParaRPr lang="en-US" sz="1400" dirty="0"/>
           </a:p>
@@ -4339,9 +4341,9 @@
                 <a:solidFill>
                   <a:srgbClr val="A3E635"/>
                 </a:solidFill>
-                <a:latin typeface="Cambria" pitchFamily="34" charset="0"/>
-                <a:ea typeface="Cambria" pitchFamily="34" charset="-122"/>
-                <a:cs typeface="Cambria" pitchFamily="34" charset="-120"/>
+                <a:latin typeface="Leelawadee UI" pitchFamily="34" charset="0"/>
+                <a:ea typeface="Leelawadee UI" pitchFamily="34" charset="-122"/>
+                <a:cs typeface="Leelawadee UI" pitchFamily="34" charset="-120"/>
               </a:rPr>
               <a:t>0.526</a:t>
             </a:r>
@@ -4378,11 +4380,11 @@
                 <a:solidFill>
                   <a:srgbClr val="5B6B7C"/>
                 </a:solidFill>
-                <a:latin typeface="Calibri" pitchFamily="34" charset="0"/>
-                <a:ea typeface="Calibri" pitchFamily="34" charset="-122"/>
-                <a:cs typeface="Calibri" pitchFamily="34" charset="-120"/>
-              </a:rPr>
-              <a:t>Random = 0.500</a:t>
+                <a:latin typeface="Leelawadee UI" pitchFamily="34" charset="0"/>
+                <a:ea typeface="Leelawadee UI" pitchFamily="34" charset="-122"/>
+                <a:cs typeface="Leelawadee UI" pitchFamily="34" charset="-120"/>
+              </a:rPr>
+              <a:t>สุ่มล้วนๆ = 0.500</a:t>
             </a:r>
             <a:endParaRPr lang="en-US" sz="1000" dirty="0"/>
           </a:p>
@@ -4417,11 +4419,11 @@
                 <a:solidFill>
                   <a:srgbClr val="F5F5F5"/>
                 </a:solidFill>
-                <a:latin typeface="Calibri" pitchFamily="34" charset="0"/>
-                <a:ea typeface="Calibri" pitchFamily="34" charset="-122"/>
-                <a:cs typeface="Calibri" pitchFamily="34" charset="-120"/>
-              </a:rPr>
-              <a:t>Short-term moves are close to random. A small, real edge appears at 10 trading days — consistent with market-efficiency theory.</a:t>
+                <a:latin typeface="Leelawadee UI" pitchFamily="34" charset="0"/>
+                <a:ea typeface="Leelawadee UI" pitchFamily="34" charset="-122"/>
+                <a:cs typeface="Leelawadee UI" pitchFamily="34" charset="-120"/>
+              </a:rPr>
+              <a:t>การเคลื่อนไหวระยะสั้นใกล้เคียงการสุ่ม แต่เริ่มมีความได้เปรียบเล็กน้อยที่ระยะ 10 วัน — สอดคล้องกับทฤษฎีตลาดมีประสิทธิภาพ (Market Efficiency)</a:t>
             </a:r>
             <a:endParaRPr lang="en-US" sz="1200" dirty="0"/>
           </a:p>
@@ -4488,9 +4490,9 @@
                 <a:solidFill>
                   <a:srgbClr val="5B6B7C"/>
                 </a:solidFill>
-                <a:latin typeface="Calibri" pitchFamily="34" charset="0"/>
-                <a:ea typeface="Calibri" pitchFamily="34" charset="-122"/>
-                <a:cs typeface="Calibri" pitchFamily="34" charset="-120"/>
+                <a:latin typeface="Leelawadee UI" pitchFamily="34" charset="0"/>
+                <a:ea typeface="Leelawadee UI" pitchFamily="34" charset="-122"/>
+                <a:cs typeface="Leelawadee UI" pitchFamily="34" charset="-120"/>
               </a:rPr>
               <a:t>11</a:t>
             </a:r>
@@ -4527,9 +4529,9 @@
                 <a:solidFill>
                   <a:srgbClr val="5B6B7C"/>
                 </a:solidFill>
-                <a:latin typeface="Calibri" pitchFamily="34" charset="0"/>
-                <a:ea typeface="Calibri" pitchFamily="34" charset="-122"/>
-                <a:cs typeface="Calibri" pitchFamily="34" charset="-120"/>
+                <a:latin typeface="Leelawadee UI" pitchFamily="34" charset="0"/>
+                <a:ea typeface="Leelawadee UI" pitchFamily="34" charset="-122"/>
+                <a:cs typeface="Leelawadee UI" pitchFamily="34" charset="-120"/>
               </a:rPr>
               <a:t>Stockscope AI · CP020003</a:t>
             </a:r>
@@ -4566,11 +4568,11 @@
                 <a:solidFill>
                   <a:srgbClr val="A3E635"/>
                 </a:solidFill>
-                <a:latin typeface="Calibri" pitchFamily="34" charset="0"/>
-                <a:ea typeface="Calibri" pitchFamily="34" charset="-122"/>
-                <a:cs typeface="Calibri" pitchFamily="34" charset="-120"/>
-              </a:rPr>
-              <a:t>RESULTS &amp; EVALUATION</a:t>
+                <a:latin typeface="Leelawadee UI" pitchFamily="34" charset="0"/>
+                <a:ea typeface="Leelawadee UI" pitchFamily="34" charset="-122"/>
+                <a:cs typeface="Leelawadee UI" pitchFamily="34" charset="-120"/>
+              </a:rPr>
+              <a:t>ผลลัพธ์และการประเมิน</a:t>
             </a:r>
             <a:endParaRPr lang="en-US" sz="1300" dirty="0"/>
           </a:p>
@@ -4605,11 +4607,11 @@
                 <a:solidFill>
                   <a:srgbClr val="F5F5F5"/>
                 </a:solidFill>
-                <a:latin typeface="Cambria" pitchFamily="34" charset="0"/>
-                <a:ea typeface="Cambria" pitchFamily="34" charset="-122"/>
-                <a:cs typeface="Cambria" pitchFamily="34" charset="-120"/>
-              </a:rPr>
-              <a:t>What Does the Model Look At?</a:t>
+                <a:latin typeface="Leelawadee UI" pitchFamily="34" charset="0"/>
+                <a:ea typeface="Leelawadee UI" pitchFamily="34" charset="-122"/>
+                <a:cs typeface="Leelawadee UI" pitchFamily="34" charset="-120"/>
+              </a:rPr>
+              <a:t>โมเดลให้ความสำคัญกับอะไรบ้าง?</a:t>
             </a:r>
             <a:endParaRPr lang="en-US" sz="3200" dirty="0"/>
           </a:p>
@@ -4713,11 +4715,11 @@
                 <a:solidFill>
                   <a:srgbClr val="A3E635"/>
                 </a:solidFill>
-                <a:latin typeface="Calibri" pitchFamily="34" charset="0"/>
-                <a:ea typeface="Calibri" pitchFamily="34" charset="-122"/>
-                <a:cs typeface="Calibri" pitchFamily="34" charset="-120"/>
-              </a:rPr>
-              <a:t>Key Insight</a:t>
+                <a:latin typeface="Leelawadee UI" pitchFamily="34" charset="0"/>
+                <a:ea typeface="Leelawadee UI" pitchFamily="34" charset="-122"/>
+                <a:cs typeface="Leelawadee UI" pitchFamily="34" charset="-120"/>
+              </a:rPr>
+              <a:t>ข้อค้นพบสำคัญ</a:t>
             </a:r>
             <a:endParaRPr lang="en-US" sz="1500" dirty="0"/>
           </a:p>
@@ -4755,11 +4757,11 @@
                 <a:solidFill>
                   <a:srgbClr val="F5F5F5"/>
                 </a:solidFill>
-                <a:latin typeface="Calibri" pitchFamily="34" charset="0"/>
-                <a:ea typeface="Calibri" pitchFamily="34" charset="-122"/>
-                <a:cs typeface="Calibri" pitchFamily="34" charset="-120"/>
-              </a:rPr>
-              <a:t>Medium-term trend and volatility signals (volatility_20d, dist_sma20/50, macd_hist) matter most.</a:t>
+                <a:latin typeface="Leelawadee UI" pitchFamily="34" charset="0"/>
+                <a:ea typeface="Leelawadee UI" pitchFamily="34" charset="-122"/>
+                <a:cs typeface="Leelawadee UI" pitchFamily="34" charset="-120"/>
+              </a:rPr>
+              <a:t>สัญญาณเทรนด์ระยะกลางและความผันผวน (volatility_20d, dist_sma20/50, macd_hist) สำคัญที่สุด</a:t>
             </a:r>
             <a:endParaRPr lang="en-US" sz="1300" dirty="0"/>
           </a:p>
@@ -4784,11 +4786,11 @@
                 <a:solidFill>
                   <a:srgbClr val="F5F5F5"/>
                 </a:solidFill>
-                <a:latin typeface="Calibri" pitchFamily="34" charset="0"/>
-                <a:ea typeface="Calibri" pitchFamily="34" charset="-122"/>
-                <a:cs typeface="Calibri" pitchFamily="34" charset="-120"/>
-              </a:rPr>
-              <a:t>Single-day return (ret_1d) matters least — the noisiest, least-informative feature, exactly as expected.</a:t>
+                <a:latin typeface="Leelawadee UI" pitchFamily="34" charset="0"/>
+                <a:ea typeface="Leelawadee UI" pitchFamily="34" charset="-122"/>
+                <a:cs typeface="Leelawadee UI" pitchFamily="34" charset="-120"/>
+              </a:rPr>
+              <a:t>ผลตอบแทนรายวัน (ret_1d) สำคัญน้อยที่สุด — เป็นฟีเจอร์ที่มี noise มากและให้ข้อมูลน้อยที่สุด ตรงตามที่คาดไว้</a:t>
             </a:r>
             <a:endParaRPr lang="en-US" sz="1300" dirty="0"/>
           </a:p>
@@ -4855,9 +4857,9 @@
                 <a:solidFill>
                   <a:srgbClr val="5B6B7C"/>
                 </a:solidFill>
-                <a:latin typeface="Calibri" pitchFamily="34" charset="0"/>
-                <a:ea typeface="Calibri" pitchFamily="34" charset="-122"/>
-                <a:cs typeface="Calibri" pitchFamily="34" charset="-120"/>
+                <a:latin typeface="Leelawadee UI" pitchFamily="34" charset="0"/>
+                <a:ea typeface="Leelawadee UI" pitchFamily="34" charset="-122"/>
+                <a:cs typeface="Leelawadee UI" pitchFamily="34" charset="-120"/>
               </a:rPr>
               <a:t>12</a:t>
             </a:r>
@@ -4894,9 +4896,9 @@
                 <a:solidFill>
                   <a:srgbClr val="5B6B7C"/>
                 </a:solidFill>
-                <a:latin typeface="Calibri" pitchFamily="34" charset="0"/>
-                <a:ea typeface="Calibri" pitchFamily="34" charset="-122"/>
-                <a:cs typeface="Calibri" pitchFamily="34" charset="-120"/>
+                <a:latin typeface="Leelawadee UI" pitchFamily="34" charset="0"/>
+                <a:ea typeface="Leelawadee UI" pitchFamily="34" charset="-122"/>
+                <a:cs typeface="Leelawadee UI" pitchFamily="34" charset="-120"/>
               </a:rPr>
               <a:t>Stockscope AI · CP020003</a:t>
             </a:r>
@@ -4933,11 +4935,11 @@
                 <a:solidFill>
                   <a:srgbClr val="A3E635"/>
                 </a:solidFill>
-                <a:latin typeface="Calibri" pitchFamily="34" charset="0"/>
-                <a:ea typeface="Calibri" pitchFamily="34" charset="-122"/>
-                <a:cs typeface="Calibri" pitchFamily="34" charset="-120"/>
-              </a:rPr>
-              <a:t>RESULTS &amp; EVALUATION</a:t>
+                <a:latin typeface="Leelawadee UI" pitchFamily="34" charset="0"/>
+                <a:ea typeface="Leelawadee UI" pitchFamily="34" charset="-122"/>
+                <a:cs typeface="Leelawadee UI" pitchFamily="34" charset="-120"/>
+              </a:rPr>
+              <a:t>ผลลัพธ์และการประเมิน</a:t>
             </a:r>
             <a:endParaRPr lang="en-US" sz="1300" dirty="0"/>
           </a:p>
@@ -4968,17 +4970,17 @@
               <a:buNone/>
             </a:pPr>
             <a:r>
-              <a:rPr lang="en-US" sz="3200" b="1" dirty="0">
+              <a:rPr lang="en-US" sz="2800" b="1" dirty="0">
                 <a:solidFill>
                   <a:srgbClr val="F5F5F5"/>
                 </a:solidFill>
-                <a:latin typeface="Cambria" pitchFamily="34" charset="0"/>
-                <a:ea typeface="Cambria" pitchFamily="34" charset="-122"/>
-                <a:cs typeface="Cambria" pitchFamily="34" charset="-120"/>
-              </a:rPr>
-              <a:t>Illustrative Strategy Backtest</a:t>
-            </a:r>
-            <a:endParaRPr lang="en-US" sz="3200" dirty="0"/>
+                <a:latin typeface="Leelawadee UI" pitchFamily="34" charset="0"/>
+                <a:ea typeface="Leelawadee UI" pitchFamily="34" charset="-122"/>
+                <a:cs typeface="Leelawadee UI" pitchFamily="34" charset="-120"/>
+              </a:rPr>
+              <a:t>ทดสอบกลยุทธ์ย้อนหลัง (เพื่อการศึกษา)</a:t>
+            </a:r>
+            <a:endParaRPr lang="en-US" sz="2800" dirty="0"/>
           </a:p>
         </p:txBody>
       </p:sp>
@@ -5062,11 +5064,11 @@
                 <a:solidFill>
                   <a:srgbClr val="FF6B6B"/>
                 </a:solidFill>
-                <a:latin typeface="Calibri" pitchFamily="34" charset="0"/>
-                <a:ea typeface="Calibri" pitchFamily="34" charset="-122"/>
-                <a:cs typeface="Calibri" pitchFamily="34" charset="-120"/>
-              </a:rPr>
-              <a:t>Academic illustration only — not investment advice</a:t>
+                <a:latin typeface="Leelawadee UI" pitchFamily="34" charset="0"/>
+                <a:ea typeface="Leelawadee UI" pitchFamily="34" charset="-122"/>
+                <a:cs typeface="Leelawadee UI" pitchFamily="34" charset="-120"/>
+              </a:rPr>
+              <a:t>เพื่อการศึกษาเท่านั้น — ไม่ใช่คำแนะนำการลงทุน</a:t>
             </a:r>
             <a:endParaRPr lang="en-US" sz="1200" dirty="0"/>
           </a:p>
@@ -5101,11 +5103,11 @@
                 <a:solidFill>
                   <a:srgbClr val="9AA5B1"/>
                 </a:solidFill>
-                <a:latin typeface="Calibri" pitchFamily="34" charset="0"/>
-                <a:ea typeface="Calibri" pitchFamily="34" charset="-122"/>
-                <a:cs typeface="Calibri" pitchFamily="34" charset="-120"/>
-              </a:rPr>
-              <a:t>Rule: go long only when P(up) &gt; 0.55, otherwise hold cash. Equal-weighted across all 20 tickers, test period only, no transaction costs.</a:t>
+                <a:latin typeface="Leelawadee UI" pitchFamily="34" charset="0"/>
+                <a:ea typeface="Leelawadee UI" pitchFamily="34" charset="-122"/>
+                <a:cs typeface="Leelawadee UI" pitchFamily="34" charset="-120"/>
+              </a:rPr>
+              <a:t>กติกา: ซื้อเมื่อ P(ขึ้น) &gt; 0.55 เท่านั้น นอกนั้นถือเงินสด น้ำหนักเท่ากันทั้ง 20 หุ้น เฉพาะช่วง test ไม่รวมค่าธรรมเนียม</a:t>
             </a:r>
             <a:endParaRPr lang="en-US" sz="1300" dirty="0"/>
           </a:p>
@@ -5169,9 +5171,9 @@
                 <a:solidFill>
                   <a:srgbClr val="F5F5F5"/>
                 </a:solidFill>
-                <a:latin typeface="Cambria" pitchFamily="34" charset="0"/>
-                <a:ea typeface="Cambria" pitchFamily="34" charset="-122"/>
-                <a:cs typeface="Cambria" pitchFamily="34" charset="-120"/>
+                <a:latin typeface="Leelawadee UI" pitchFamily="34" charset="0"/>
+                <a:ea typeface="Leelawadee UI" pitchFamily="34" charset="-122"/>
+                <a:cs typeface="Leelawadee UI" pitchFamily="34" charset="-120"/>
               </a:rPr>
               <a:t>3.86x</a:t>
             </a:r>
@@ -5208,11 +5210,11 @@
                 <a:solidFill>
                   <a:srgbClr val="9AA5B1"/>
                 </a:solidFill>
-                <a:latin typeface="Calibri" pitchFamily="34" charset="0"/>
-                <a:ea typeface="Calibri" pitchFamily="34" charset="-122"/>
-                <a:cs typeface="Calibri" pitchFamily="34" charset="-120"/>
-              </a:rPr>
-              <a:t>MODEL-GATED STRATEGY</a:t>
+                <a:latin typeface="Leelawadee UI" pitchFamily="34" charset="0"/>
+                <a:ea typeface="Leelawadee UI" pitchFamily="34" charset="-122"/>
+                <a:cs typeface="Leelawadee UI" pitchFamily="34" charset="-120"/>
+              </a:rPr>
+              <a:t>กลยุทธ์ตามสัญญาณโมเดล</a:t>
             </a:r>
             <a:endParaRPr lang="en-US" sz="1200" dirty="0"/>
           </a:p>
@@ -5276,9 +5278,9 @@
                 <a:solidFill>
                   <a:srgbClr val="A3E635"/>
                 </a:solidFill>
-                <a:latin typeface="Cambria" pitchFamily="34" charset="0"/>
-                <a:ea typeface="Cambria" pitchFamily="34" charset="-122"/>
-                <a:cs typeface="Cambria" pitchFamily="34" charset="-120"/>
+                <a:latin typeface="Leelawadee UI" pitchFamily="34" charset="0"/>
+                <a:ea typeface="Leelawadee UI" pitchFamily="34" charset="-122"/>
+                <a:cs typeface="Leelawadee UI" pitchFamily="34" charset="-120"/>
               </a:rPr>
               <a:t>12.46x</a:t>
             </a:r>
@@ -5315,11 +5317,11 @@
                 <a:solidFill>
                   <a:srgbClr val="9AA5B1"/>
                 </a:solidFill>
-                <a:latin typeface="Calibri" pitchFamily="34" charset="0"/>
-                <a:ea typeface="Calibri" pitchFamily="34" charset="-122"/>
-                <a:cs typeface="Calibri" pitchFamily="34" charset="-120"/>
-              </a:rPr>
-              <a:t>BUY &amp; HOLD (EQUAL-WEIGHT)</a:t>
+                <a:latin typeface="Leelawadee UI" pitchFamily="34" charset="0"/>
+                <a:ea typeface="Leelawadee UI" pitchFamily="34" charset="-122"/>
+                <a:cs typeface="Leelawadee UI" pitchFamily="34" charset="-120"/>
+              </a:rPr>
+              <a:t>ซื้อแล้วถือ (น้ำหนักเท่ากัน)</a:t>
             </a:r>
             <a:endParaRPr lang="en-US" sz="1200" dirty="0"/>
           </a:p>
@@ -5354,11 +5356,11 @@
                 <a:solidFill>
                   <a:srgbClr val="5B6B7C"/>
                 </a:solidFill>
-                <a:latin typeface="Calibri" pitchFamily="34" charset="0"/>
-                <a:ea typeface="Calibri" pitchFamily="34" charset="-122"/>
-                <a:cs typeface="Calibri" pitchFamily="34" charset="-120"/>
-              </a:rPr>
-              <a:t>growth of $1 over the test period</a:t>
+                <a:latin typeface="Leelawadee UI" pitchFamily="34" charset="0"/>
+                <a:ea typeface="Leelawadee UI" pitchFamily="34" charset="-122"/>
+                <a:cs typeface="Leelawadee UI" pitchFamily="34" charset="-120"/>
+              </a:rPr>
+              <a:t>มูลค่าจาก $1 ตลอดช่วง test</a:t>
             </a:r>
             <a:endParaRPr lang="en-US" sz="1100" dirty="0"/>
           </a:p>
@@ -5393,11 +5395,11 @@
                 <a:solidFill>
                   <a:srgbClr val="5B6B7C"/>
                 </a:solidFill>
-                <a:latin typeface="Calibri" pitchFamily="34" charset="0"/>
-                <a:ea typeface="Calibri" pitchFamily="34" charset="-122"/>
-                <a:cs typeface="Calibri" pitchFamily="34" charset="-120"/>
-              </a:rPr>
-              <a:t>growth of $1 over the test period</a:t>
+                <a:latin typeface="Leelawadee UI" pitchFamily="34" charset="0"/>
+                <a:ea typeface="Leelawadee UI" pitchFamily="34" charset="-122"/>
+                <a:cs typeface="Leelawadee UI" pitchFamily="34" charset="-120"/>
+              </a:rPr>
+              <a:t>มูลค่าจาก $1 ตลอดช่วง test</a:t>
             </a:r>
             <a:endParaRPr lang="en-US" sz="1100" dirty="0"/>
           </a:p>
@@ -5485,11 +5487,11 @@
                 <a:solidFill>
                   <a:srgbClr val="F5F5F5"/>
                 </a:solidFill>
-                <a:latin typeface="Calibri" pitchFamily="34" charset="0"/>
-                <a:ea typeface="Calibri" pitchFamily="34" charset="-122"/>
-                <a:cs typeface="Calibri" pitchFamily="34" charset="-120"/>
-              </a:rPr>
-              <a:t>Why buy-and-hold wins here</a:t>
+                <a:latin typeface="Leelawadee UI" pitchFamily="34" charset="0"/>
+                <a:ea typeface="Leelawadee UI" pitchFamily="34" charset="-122"/>
+                <a:cs typeface="Leelawadee UI" pitchFamily="34" charset="-120"/>
+              </a:rPr>
+              <a:t>ทำไมซื้อแล้วถือถึงชนะ</a:t>
             </a:r>
             <a:endParaRPr lang="en-US" sz="1400" dirty="0"/>
           </a:p>
@@ -5524,11 +5526,11 @@
                 <a:solidFill>
                   <a:srgbClr val="9AA5B1"/>
                 </a:solidFill>
-                <a:latin typeface="Calibri" pitchFamily="34" charset="0"/>
-                <a:ea typeface="Calibri" pitchFamily="34" charset="-122"/>
-                <a:cs typeface="Calibri" pitchFamily="34" charset="-120"/>
-              </a:rPr>
-              <a:t>The test window contains a strong bull run. Sitting in cash whenever confidence dips costs more than a ~0.53 AUC edge can recover. A statistical edge is not automatically a profitable trading strategy — timing has a real opportunity cost.</a:t>
+                <a:latin typeface="Leelawadee UI" pitchFamily="34" charset="0"/>
+                <a:ea typeface="Leelawadee UI" pitchFamily="34" charset="-122"/>
+                <a:cs typeface="Leelawadee UI" pitchFamily="34" charset="-120"/>
+              </a:rPr>
+              <a:t>ช่วง test เป็นตลาดขาขึ้นแรง การถือเงินสดทุกครั้งที่โมเดลไม่มั่นใจ ทำให้เสียโอกาสมากกว่าความได้เปรียบเล็กน้อยจาก AUC ~0.53 จะชดเชยได้ — ความได้เปรียบทางสถิติไม่ได้แปลว่าจะทำกำไรได้จริงเสมอไป การจับจังหวะตลาดมีต้นทุนค่าเสียโอกาสจริง</a:t>
             </a:r>
             <a:endParaRPr lang="en-US" sz="1300" dirty="0"/>
           </a:p>
@@ -5595,9 +5597,9 @@
                 <a:solidFill>
                   <a:srgbClr val="5B6B7C"/>
                 </a:solidFill>
-                <a:latin typeface="Calibri" pitchFamily="34" charset="0"/>
-                <a:ea typeface="Calibri" pitchFamily="34" charset="-122"/>
-                <a:cs typeface="Calibri" pitchFamily="34" charset="-120"/>
+                <a:latin typeface="Leelawadee UI" pitchFamily="34" charset="0"/>
+                <a:ea typeface="Leelawadee UI" pitchFamily="34" charset="-122"/>
+                <a:cs typeface="Leelawadee UI" pitchFamily="34" charset="-120"/>
               </a:rPr>
               <a:t>13</a:t>
             </a:r>
@@ -5634,9 +5636,9 @@
                 <a:solidFill>
                   <a:srgbClr val="5B6B7C"/>
                 </a:solidFill>
-                <a:latin typeface="Calibri" pitchFamily="34" charset="0"/>
-                <a:ea typeface="Calibri" pitchFamily="34" charset="-122"/>
-                <a:cs typeface="Calibri" pitchFamily="34" charset="-120"/>
+                <a:latin typeface="Leelawadee UI" pitchFamily="34" charset="0"/>
+                <a:ea typeface="Leelawadee UI" pitchFamily="34" charset="-122"/>
+                <a:cs typeface="Leelawadee UI" pitchFamily="34" charset="-120"/>
               </a:rPr>
               <a:t>Stockscope AI · CP020003</a:t>
             </a:r>
@@ -5673,11 +5675,11 @@
                 <a:solidFill>
                   <a:srgbClr val="A3E635"/>
                 </a:solidFill>
-                <a:latin typeface="Calibri" pitchFamily="34" charset="0"/>
-                <a:ea typeface="Calibri" pitchFamily="34" charset="-122"/>
-                <a:cs typeface="Calibri" pitchFamily="34" charset="-120"/>
-              </a:rPr>
-              <a:t>DISCUSSION</a:t>
+                <a:latin typeface="Leelawadee UI" pitchFamily="34" charset="0"/>
+                <a:ea typeface="Leelawadee UI" pitchFamily="34" charset="-122"/>
+                <a:cs typeface="Leelawadee UI" pitchFamily="34" charset="-120"/>
+              </a:rPr>
+              <a:t>อภิปราย</a:t>
             </a:r>
             <a:endParaRPr lang="en-US" sz="1300" dirty="0"/>
           </a:p>
@@ -5708,17 +5710,17 @@
               <a:buNone/>
             </a:pPr>
             <a:r>
-              <a:rPr lang="en-US" sz="3200" b="1" dirty="0">
+              <a:rPr lang="en-US" sz="3000" b="1" dirty="0">
                 <a:solidFill>
                   <a:srgbClr val="F5F5F5"/>
                 </a:solidFill>
-                <a:latin typeface="Cambria" pitchFamily="34" charset="0"/>
-                <a:ea typeface="Cambria" pitchFamily="34" charset="-122"/>
-                <a:cs typeface="Cambria" pitchFamily="34" charset="-120"/>
-              </a:rPr>
-              <a:t>Limitations — What This Model Doesn't Capture</a:t>
-            </a:r>
-            <a:endParaRPr lang="en-US" sz="3200" dirty="0"/>
+                <a:latin typeface="Leelawadee UI" pitchFamily="34" charset="0"/>
+                <a:ea typeface="Leelawadee UI" pitchFamily="34" charset="-122"/>
+                <a:cs typeface="Leelawadee UI" pitchFamily="34" charset="-120"/>
+              </a:rPr>
+              <a:t>ข้อจำกัด — สิ่งที่โมเดลนี้ยังทำไม่ได้</a:t>
+            </a:r>
+            <a:endParaRPr lang="en-US" sz="3000" dirty="0"/>
           </a:p>
         </p:txBody>
       </p:sp>
@@ -5795,11 +5797,11 @@
                 <a:solidFill>
                   <a:srgbClr val="F5F5F5"/>
                 </a:solidFill>
-                <a:latin typeface="Calibri" pitchFamily="34" charset="0"/>
-                <a:ea typeface="Calibri" pitchFamily="34" charset="-122"/>
-                <a:cs typeface="Calibri" pitchFamily="34" charset="-120"/>
-              </a:rPr>
-              <a:t>Modest signal</a:t>
+                <a:latin typeface="Leelawadee UI" pitchFamily="34" charset="0"/>
+                <a:ea typeface="Leelawadee UI" pitchFamily="34" charset="-122"/>
+                <a:cs typeface="Leelawadee UI" pitchFamily="34" charset="-120"/>
+              </a:rPr>
+              <a:t>สัญญาณยังไม่ชัดเจนมาก</a:t>
             </a:r>
             <a:endParaRPr lang="en-US" sz="1500" dirty="0"/>
           </a:p>
@@ -5834,11 +5836,11 @@
                 <a:solidFill>
                   <a:srgbClr val="9AA5B1"/>
                 </a:solidFill>
-                <a:latin typeface="Calibri" pitchFamily="34" charset="0"/>
-                <a:ea typeface="Calibri" pitchFamily="34" charset="-122"/>
-                <a:cs typeface="Calibri" pitchFamily="34" charset="-120"/>
-              </a:rPr>
-              <a:t>ROC-AUC ≈ 0.50–0.53, close to random — reported honestly, not tuned to look better.</a:t>
+                <a:latin typeface="Leelawadee UI" pitchFamily="34" charset="0"/>
+                <a:ea typeface="Leelawadee UI" pitchFamily="34" charset="-122"/>
+                <a:cs typeface="Leelawadee UI" pitchFamily="34" charset="-120"/>
+              </a:rPr>
+              <a:t>ROC-AUC ≈ 0.50–0.53 ใกล้เคียงการสุ่ม — รายงานตามจริง ไม่ได้ปรับแต่งให้ดูดีเกินจริง</a:t>
             </a:r>
             <a:endParaRPr lang="en-US" sz="1200" dirty="0"/>
           </a:p>
@@ -5917,11 +5919,11 @@
                 <a:solidFill>
                   <a:srgbClr val="F5F5F5"/>
                 </a:solidFill>
-                <a:latin typeface="Calibri" pitchFamily="34" charset="0"/>
-                <a:ea typeface="Calibri" pitchFamily="34" charset="-122"/>
-                <a:cs typeface="Calibri" pitchFamily="34" charset="-120"/>
-              </a:rPr>
-              <a:t>No fundamentals or macro data</a:t>
+                <a:latin typeface="Leelawadee UI" pitchFamily="34" charset="0"/>
+                <a:ea typeface="Leelawadee UI" pitchFamily="34" charset="-122"/>
+                <a:cs typeface="Leelawadee UI" pitchFamily="34" charset="-120"/>
+              </a:rPr>
+              <a:t>ไม่มีข้อมูลปัจจัยพื้นฐานหรือเศรษฐกิจมหภาค</a:t>
             </a:r>
             <a:endParaRPr lang="en-US" sz="1500" dirty="0"/>
           </a:p>
@@ -5956,11 +5958,11 @@
                 <a:solidFill>
                   <a:srgbClr val="9AA5B1"/>
                 </a:solidFill>
-                <a:latin typeface="Calibri" pitchFamily="34" charset="0"/>
-                <a:ea typeface="Calibri" pitchFamily="34" charset="-122"/>
-                <a:cs typeface="Calibri" pitchFamily="34" charset="-120"/>
-              </a:rPr>
-              <a:t>Earnings, interest rates, and news events aren't in the feature set.</a:t>
+                <a:latin typeface="Leelawadee UI" pitchFamily="34" charset="0"/>
+                <a:ea typeface="Leelawadee UI" pitchFamily="34" charset="-122"/>
+                <a:cs typeface="Leelawadee UI" pitchFamily="34" charset="-120"/>
+              </a:rPr>
+              <a:t>ไม่มีผลประกอบการ อัตราดอกเบี้ย หรือข่าวสารอยู่ในชุดฟีเจอร์</a:t>
             </a:r>
             <a:endParaRPr lang="en-US" sz="1200" dirty="0"/>
           </a:p>
@@ -6039,11 +6041,11 @@
                 <a:solidFill>
                   <a:srgbClr val="F5F5F5"/>
                 </a:solidFill>
-                <a:latin typeface="Calibri" pitchFamily="34" charset="0"/>
-                <a:ea typeface="Calibri" pitchFamily="34" charset="-122"/>
-                <a:cs typeface="Calibri" pitchFamily="34" charset="-120"/>
-              </a:rPr>
-              <a:t>Survivorship bias</a:t>
+                <a:latin typeface="Leelawadee UI" pitchFamily="34" charset="0"/>
+                <a:ea typeface="Leelawadee UI" pitchFamily="34" charset="-122"/>
+                <a:cs typeface="Leelawadee UI" pitchFamily="34" charset="-120"/>
+              </a:rPr>
+              <a:t>Survivorship Bias</a:t>
             </a:r>
             <a:endParaRPr lang="en-US" sz="1500" dirty="0"/>
           </a:p>
@@ -6078,11 +6080,11 @@
                 <a:solidFill>
                   <a:srgbClr val="9AA5B1"/>
                 </a:solidFill>
-                <a:latin typeface="Calibri" pitchFamily="34" charset="0"/>
-                <a:ea typeface="Calibri" pitchFamily="34" charset="-122"/>
-                <a:cs typeface="Calibri" pitchFamily="34" charset="-120"/>
-              </a:rPr>
-              <a:t>Only large, currently-listed companies — delistings are excluded.</a:t>
+                <a:latin typeface="Leelawadee UI" pitchFamily="34" charset="0"/>
+                <a:ea typeface="Leelawadee UI" pitchFamily="34" charset="-122"/>
+                <a:cs typeface="Leelawadee UI" pitchFamily="34" charset="-120"/>
+              </a:rPr>
+              <a:t>ใช้เฉพาะบริษัทใหญ่ที่ยังจดทะเบียนอยู่ — ไม่รวมหุ้นที่ถูกถอดออกจากตลาด</a:t>
             </a:r>
             <a:endParaRPr lang="en-US" sz="1200" dirty="0"/>
           </a:p>
@@ -6161,11 +6163,11 @@
                 <a:solidFill>
                   <a:srgbClr val="F5F5F5"/>
                 </a:solidFill>
-                <a:latin typeface="Calibri" pitchFamily="34" charset="0"/>
-                <a:ea typeface="Calibri" pitchFamily="34" charset="-122"/>
-                <a:cs typeface="Calibri" pitchFamily="34" charset="-120"/>
-              </a:rPr>
-              <a:t>No transaction costs</a:t>
+                <a:latin typeface="Leelawadee UI" pitchFamily="34" charset="0"/>
+                <a:ea typeface="Leelawadee UI" pitchFamily="34" charset="-122"/>
+                <a:cs typeface="Leelawadee UI" pitchFamily="34" charset="-120"/>
+              </a:rPr>
+              <a:t>ไม่รวมต้นทุนการซื้อขาย</a:t>
             </a:r>
             <a:endParaRPr lang="en-US" sz="1500" dirty="0"/>
           </a:p>
@@ -6200,11 +6202,11 @@
                 <a:solidFill>
                   <a:srgbClr val="9AA5B1"/>
                 </a:solidFill>
-                <a:latin typeface="Calibri" pitchFamily="34" charset="0"/>
-                <a:ea typeface="Calibri" pitchFamily="34" charset="-122"/>
-                <a:cs typeface="Calibri" pitchFamily="34" charset="-120"/>
-              </a:rPr>
-              <a:t>The backtest ignores fees, slippage, and taxes.</a:t>
+                <a:latin typeface="Leelawadee UI" pitchFamily="34" charset="0"/>
+                <a:ea typeface="Leelawadee UI" pitchFamily="34" charset="-122"/>
+                <a:cs typeface="Leelawadee UI" pitchFamily="34" charset="-120"/>
+              </a:rPr>
+              <a:t>การทดสอบย้อนหลังไม่ได้รวมค่าธรรมเนียม ส่วนต่างราคา หรือภาษี</a:t>
             </a:r>
             <a:endParaRPr lang="en-US" sz="1200" dirty="0"/>
           </a:p>
@@ -6283,11 +6285,11 @@
                 <a:solidFill>
                   <a:srgbClr val="F5F5F5"/>
                 </a:solidFill>
-                <a:latin typeface="Calibri" pitchFamily="34" charset="0"/>
-                <a:ea typeface="Calibri" pitchFamily="34" charset="-122"/>
-                <a:cs typeface="Calibri" pitchFamily="34" charset="-120"/>
-              </a:rPr>
-              <a:t>Sentiment isn't backtestable</a:t>
+                <a:latin typeface="Leelawadee UI" pitchFamily="34" charset="0"/>
+                <a:ea typeface="Leelawadee UI" pitchFamily="34" charset="-122"/>
+                <a:cs typeface="Leelawadee UI" pitchFamily="34" charset="-120"/>
+              </a:rPr>
+              <a:t>ทดสอบย้อนหลังด้าน Sentiment ไม่ได้</a:t>
             </a:r>
             <a:endParaRPr lang="en-US" sz="1500" dirty="0"/>
           </a:p>
@@ -6322,11 +6324,11 @@
                 <a:solidFill>
                   <a:srgbClr val="9AA5B1"/>
                 </a:solidFill>
-                <a:latin typeface="Calibri" pitchFamily="34" charset="0"/>
-                <a:ea typeface="Calibri" pitchFamily="34" charset="-122"/>
-                <a:cs typeface="Calibri" pitchFamily="34" charset="-120"/>
-              </a:rPr>
-              <a:t>Stockscope's live news scraper has no historical archive to align to past dates.</a:t>
+                <a:latin typeface="Leelawadee UI" pitchFamily="34" charset="0"/>
+                <a:ea typeface="Leelawadee UI" pitchFamily="34" charset="-122"/>
+                <a:cs typeface="Leelawadee UI" pitchFamily="34" charset="-120"/>
+              </a:rPr>
+              <a:t>ระบบดึงข่าวของ Stockscope ไม่มีข้อมูลข่าวย้อนหลังให้จับคู่กับวันที่ในอดีต</a:t>
             </a:r>
             <a:endParaRPr lang="en-US" sz="1200" dirty="0"/>
           </a:p>
@@ -6393,9 +6395,9 @@
                 <a:solidFill>
                   <a:srgbClr val="5B6B7C"/>
                 </a:solidFill>
-                <a:latin typeface="Calibri" pitchFamily="34" charset="0"/>
-                <a:ea typeface="Calibri" pitchFamily="34" charset="-122"/>
-                <a:cs typeface="Calibri" pitchFamily="34" charset="-120"/>
+                <a:latin typeface="Leelawadee UI" pitchFamily="34" charset="0"/>
+                <a:ea typeface="Leelawadee UI" pitchFamily="34" charset="-122"/>
+                <a:cs typeface="Leelawadee UI" pitchFamily="34" charset="-120"/>
               </a:rPr>
               <a:t>14</a:t>
             </a:r>
@@ -6432,9 +6434,9 @@
                 <a:solidFill>
                   <a:srgbClr val="5B6B7C"/>
                 </a:solidFill>
-                <a:latin typeface="Calibri" pitchFamily="34" charset="0"/>
-                <a:ea typeface="Calibri" pitchFamily="34" charset="-122"/>
-                <a:cs typeface="Calibri" pitchFamily="34" charset="-120"/>
+                <a:latin typeface="Leelawadee UI" pitchFamily="34" charset="0"/>
+                <a:ea typeface="Leelawadee UI" pitchFamily="34" charset="-122"/>
+                <a:cs typeface="Leelawadee UI" pitchFamily="34" charset="-120"/>
               </a:rPr>
               <a:t>Stockscope AI · CP020003</a:t>
             </a:r>
@@ -6471,11 +6473,11 @@
                 <a:solidFill>
                   <a:srgbClr val="A3E635"/>
                 </a:solidFill>
-                <a:latin typeface="Calibri" pitchFamily="34" charset="0"/>
-                <a:ea typeface="Calibri" pitchFamily="34" charset="-122"/>
-                <a:cs typeface="Calibri" pitchFamily="34" charset="-120"/>
-              </a:rPr>
-              <a:t>IMPACT &amp; CONCLUSION</a:t>
+                <a:latin typeface="Leelawadee UI" pitchFamily="34" charset="0"/>
+                <a:ea typeface="Leelawadee UI" pitchFamily="34" charset="-122"/>
+                <a:cs typeface="Leelawadee UI" pitchFamily="34" charset="-120"/>
+              </a:rPr>
+              <a:t>ผลกระทบและบทสรุป</a:t>
             </a:r>
             <a:endParaRPr lang="en-US" sz="1300" dirty="0"/>
           </a:p>
@@ -6510,11 +6512,11 @@
                 <a:solidFill>
                   <a:srgbClr val="F5F5F5"/>
                 </a:solidFill>
-                <a:latin typeface="Cambria" pitchFamily="34" charset="0"/>
-                <a:ea typeface="Cambria" pitchFamily="34" charset="-122"/>
-                <a:cs typeface="Cambria" pitchFamily="34" charset="-120"/>
-              </a:rPr>
-              <a:t>Connecting Back to Stockscope</a:t>
+                <a:latin typeface="Leelawadee UI" pitchFamily="34" charset="0"/>
+                <a:ea typeface="Leelawadee UI" pitchFamily="34" charset="-122"/>
+                <a:cs typeface="Leelawadee UI" pitchFamily="34" charset="-120"/>
+              </a:rPr>
+              <a:t>เชื่อมโยงกลับสู่ Stockscope</a:t>
             </a:r>
             <a:endParaRPr lang="en-US" sz="3200" dirty="0"/>
           </a:p>
@@ -6578,11 +6580,11 @@
                 <a:solidFill>
                   <a:srgbClr val="A3E635"/>
                 </a:solidFill>
-                <a:latin typeface="Calibri" pitchFamily="34" charset="0"/>
-                <a:ea typeface="Calibri" pitchFamily="34" charset="-122"/>
-                <a:cs typeface="Calibri" pitchFamily="34" charset="-120"/>
-              </a:rPr>
-              <a:t>KEY INSIGHTS</a:t>
+                <a:latin typeface="Leelawadee UI" pitchFamily="34" charset="0"/>
+                <a:ea typeface="Leelawadee UI" pitchFamily="34" charset="-122"/>
+                <a:cs typeface="Leelawadee UI" pitchFamily="34" charset="-120"/>
+              </a:rPr>
+              <a:t>ข้อค้นพบสำคัญ</a:t>
             </a:r>
             <a:endParaRPr lang="en-US" sz="1200" dirty="0"/>
           </a:p>
@@ -6637,11 +6639,11 @@
                 <a:solidFill>
                   <a:srgbClr val="F5F5F5"/>
                 </a:solidFill>
-                <a:latin typeface="Calibri" pitchFamily="34" charset="0"/>
-                <a:ea typeface="Calibri" pitchFamily="34" charset="-122"/>
-                <a:cs typeface="Calibri" pitchFamily="34" charset="-120"/>
-              </a:rPr>
-              <a:t>Fully leakage-free pipeline: backward-looking features, forward-looking label kept strictly separate</a:t>
+                <a:latin typeface="Leelawadee UI" pitchFamily="34" charset="0"/>
+                <a:ea typeface="Leelawadee UI" pitchFamily="34" charset="-122"/>
+                <a:cs typeface="Leelawadee UI" pitchFamily="34" charset="-120"/>
+              </a:rPr>
+              <a:t>ไปป์ไลน์ไม่รั่วไหลข้อมูลอย่างสมบูรณ์: ฟีเจอร์มองย้อนหลัง label มองไปข้างหน้า แยกกันเด็ดขาด</a:t>
             </a:r>
             <a:endParaRPr lang="en-US" sz="1300" dirty="0"/>
           </a:p>
@@ -6696,11 +6698,11 @@
                 <a:solidFill>
                   <a:srgbClr val="F5F5F5"/>
                 </a:solidFill>
-                <a:latin typeface="Calibri" pitchFamily="34" charset="0"/>
-                <a:ea typeface="Calibri" pitchFamily="34" charset="-122"/>
-                <a:cs typeface="Calibri" pitchFamily="34" charset="-120"/>
-              </a:rPr>
-              <a:t>XGBoost modestly beats the naive baseline at longer horizons, not at 1 day</a:t>
+                <a:latin typeface="Leelawadee UI" pitchFamily="34" charset="0"/>
+                <a:ea typeface="Leelawadee UI" pitchFamily="34" charset="-122"/>
+                <a:cs typeface="Leelawadee UI" pitchFamily="34" charset="-120"/>
+              </a:rPr>
+              <a:t>XGBoost ชนะ baseline เล็กน้อยที่ระยะยาว แต่ไม่ชนะที่ระยะ 1 วัน</a:t>
             </a:r>
             <a:endParaRPr lang="en-US" sz="1300" dirty="0"/>
           </a:p>
@@ -6755,11 +6757,11 @@
                 <a:solidFill>
                   <a:srgbClr val="F5F5F5"/>
                 </a:solidFill>
-                <a:latin typeface="Calibri" pitchFamily="34" charset="0"/>
-                <a:ea typeface="Calibri" pitchFamily="34" charset="-122"/>
-                <a:cs typeface="Calibri" pitchFamily="34" charset="-120"/>
-              </a:rPr>
-              <a:t>macd_hist, dist_sma50/20, and volatility are the most informative features</a:t>
+                <a:latin typeface="Leelawadee UI" pitchFamily="34" charset="0"/>
+                <a:ea typeface="Leelawadee UI" pitchFamily="34" charset="-122"/>
+                <a:cs typeface="Leelawadee UI" pitchFamily="34" charset="-120"/>
+              </a:rPr>
+              <a:t>macd_hist, dist_sma50/20 และ volatility เป็นฟีเจอร์ที่ให้ข้อมูลมากที่สุด</a:t>
             </a:r>
             <a:endParaRPr lang="en-US" sz="1300" dirty="0"/>
           </a:p>
@@ -6814,11 +6816,11 @@
                 <a:solidFill>
                   <a:srgbClr val="F5F5F5"/>
                 </a:solidFill>
-                <a:latin typeface="Calibri" pitchFamily="34" charset="0"/>
-                <a:ea typeface="Calibri" pitchFamily="34" charset="-122"/>
-                <a:cs typeface="Calibri" pitchFamily="34" charset="-120"/>
-              </a:rPr>
-              <a:t>A small statistical edge ≠ a profitable trading strategy</a:t>
+                <a:latin typeface="Leelawadee UI" pitchFamily="34" charset="0"/>
+                <a:ea typeface="Leelawadee UI" pitchFamily="34" charset="-122"/>
+                <a:cs typeface="Leelawadee UI" pitchFamily="34" charset="-120"/>
+              </a:rPr>
+              <a:t>ความได้เปรียบทางสถิติเล็กน้อย ≠ กลยุทธ์ที่ทำกำไรได้จริง</a:t>
             </a:r>
             <a:endParaRPr lang="en-US" sz="1300" dirty="0"/>
           </a:p>
@@ -6906,11 +6908,11 @@
                 <a:solidFill>
                   <a:srgbClr val="A3E635"/>
                 </a:solidFill>
-                <a:latin typeface="Calibri" pitchFamily="34" charset="0"/>
-                <a:ea typeface="Calibri" pitchFamily="34" charset="-122"/>
-                <a:cs typeface="Calibri" pitchFamily="34" charset="-120"/>
-              </a:rPr>
-              <a:t>Next Step: Ship It in the Live App</a:t>
+                <a:latin typeface="Leelawadee UI" pitchFamily="34" charset="0"/>
+                <a:ea typeface="Leelawadee UI" pitchFamily="34" charset="-122"/>
+                <a:cs typeface="Leelawadee UI" pitchFamily="34" charset="-120"/>
+              </a:rPr>
+              <a:t>ขั้นต่อไป: นำไปใช้งานจริงในแอป</a:t>
             </a:r>
             <a:endParaRPr lang="en-US" sz="1600" dirty="0"/>
           </a:p>
@@ -6974,11 +6976,11 @@
                 <a:solidFill>
                   <a:srgbClr val="A3E635"/>
                 </a:solidFill>
-                <a:latin typeface="Calibri" pitchFamily="34" charset="0"/>
-                <a:ea typeface="Calibri" pitchFamily="34" charset="-122"/>
-                <a:cs typeface="Calibri" pitchFamily="34" charset="-120"/>
-              </a:rPr>
-              <a:t>AI: 61% probability of higher</a:t>
+                <a:latin typeface="Leelawadee UI" pitchFamily="34" charset="0"/>
+                <a:ea typeface="Leelawadee UI" pitchFamily="34" charset="-122"/>
+                <a:cs typeface="Leelawadee UI" pitchFamily="34" charset="-120"/>
+              </a:rPr>
+              <a:t>AI: มีโอกาส 61% ที่ราคาจะปิดสูงขึ้น</a:t>
             </a:r>
             <a:endParaRPr lang="en-US" sz="1600" dirty="0"/>
           </a:p>
@@ -6991,11 +6993,11 @@
                 <a:solidFill>
                   <a:srgbClr val="A3E635"/>
                 </a:solidFill>
-                <a:latin typeface="Calibri" pitchFamily="34" charset="0"/>
-                <a:ea typeface="Calibri" pitchFamily="34" charset="-122"/>
-                <a:cs typeface="Calibri" pitchFamily="34" charset="-120"/>
-              </a:rPr>
-              <a:t>close in 10 trading days</a:t>
+                <a:latin typeface="Leelawadee UI" pitchFamily="34" charset="0"/>
+                <a:ea typeface="Leelawadee UI" pitchFamily="34" charset="-122"/>
+                <a:cs typeface="Leelawadee UI" pitchFamily="34" charset="-120"/>
+              </a:rPr>
+              <a:t>ในอีก 10 วันทำการ</a:t>
             </a:r>
             <a:endParaRPr lang="en-US" sz="1600" dirty="0"/>
           </a:p>
@@ -7030,11 +7032,11 @@
                 <a:solidFill>
                   <a:srgbClr val="5B6B7C"/>
                 </a:solidFill>
-                <a:latin typeface="Calibri" pitchFamily="34" charset="0"/>
-                <a:ea typeface="Calibri" pitchFamily="34" charset="-122"/>
-                <a:cs typeface="Calibri" pitchFamily="34" charset="-120"/>
-              </a:rPr>
-              <a:t>statistical estimate, not financial advice</a:t>
+                <a:latin typeface="Leelawadee UI" pitchFamily="34" charset="0"/>
+                <a:ea typeface="Leelawadee UI" pitchFamily="34" charset="-122"/>
+                <a:cs typeface="Leelawadee UI" pitchFamily="34" charset="-120"/>
+              </a:rPr>
+              <a:t>เป็นการประมาณค่าทางสถิติ ไม่ใช่คำแนะนำทางการเงิน</a:t>
             </a:r>
             <a:endParaRPr lang="en-US" sz="1000" dirty="0"/>
           </a:p>
@@ -7069,11 +7071,11 @@
                 <a:solidFill>
                   <a:srgbClr val="F5F5F5"/>
                 </a:solidFill>
-                <a:latin typeface="Calibri" pitchFamily="34" charset="0"/>
-                <a:ea typeface="Calibri" pitchFamily="34" charset="-122"/>
-                <a:cs typeface="Calibri" pitchFamily="34" charset="-120"/>
-              </a:rPr>
-              <a:t>Serialize the trained model and load it in the Streamlit app, next to the existing technical view Stockscope already shows for any ticker.</a:t>
+                <a:latin typeface="Leelawadee UI" pitchFamily="34" charset="0"/>
+                <a:ea typeface="Leelawadee UI" pitchFamily="34" charset="-122"/>
+                <a:cs typeface="Leelawadee UI" pitchFamily="34" charset="-120"/>
+              </a:rPr>
+              <a:t>บันทึกโมเดลที่เทรนแล้วและโหลดเข้าแอป Streamlit วางคู่กับมุมมองทางเทคนิคที่ Stockscope แสดงอยู่แล้วสำหรับทุกหุ้น</a:t>
             </a:r>
             <a:endParaRPr lang="en-US" sz="1300" dirty="0"/>
           </a:p>
@@ -7140,9 +7142,9 @@
                 <a:solidFill>
                   <a:srgbClr val="5B6B7C"/>
                 </a:solidFill>
-                <a:latin typeface="Calibri" pitchFamily="34" charset="0"/>
-                <a:ea typeface="Calibri" pitchFamily="34" charset="-122"/>
-                <a:cs typeface="Calibri" pitchFamily="34" charset="-120"/>
+                <a:latin typeface="Leelawadee UI" pitchFamily="34" charset="0"/>
+                <a:ea typeface="Leelawadee UI" pitchFamily="34" charset="-122"/>
+                <a:cs typeface="Leelawadee UI" pitchFamily="34" charset="-120"/>
               </a:rPr>
               <a:t>15</a:t>
             </a:r>
@@ -7179,9 +7181,9 @@
                 <a:solidFill>
                   <a:srgbClr val="5B6B7C"/>
                 </a:solidFill>
-                <a:latin typeface="Calibri" pitchFamily="34" charset="0"/>
-                <a:ea typeface="Calibri" pitchFamily="34" charset="-122"/>
-                <a:cs typeface="Calibri" pitchFamily="34" charset="-120"/>
+                <a:latin typeface="Leelawadee UI" pitchFamily="34" charset="0"/>
+                <a:ea typeface="Leelawadee UI" pitchFamily="34" charset="-122"/>
+                <a:cs typeface="Leelawadee UI" pitchFamily="34" charset="-120"/>
               </a:rPr>
               <a:t>Stockscope AI · CP020003</a:t>
             </a:r>
@@ -7242,11 +7244,11 @@
                 <a:solidFill>
                   <a:srgbClr val="F5F5F5"/>
                 </a:solidFill>
-                <a:latin typeface="Cambria" pitchFamily="34" charset="0"/>
-                <a:ea typeface="Cambria" pitchFamily="34" charset="-122"/>
-                <a:cs typeface="Cambria" pitchFamily="34" charset="-120"/>
-              </a:rPr>
-              <a:t>Thank You</a:t>
+                <a:latin typeface="Leelawadee UI" pitchFamily="34" charset="0"/>
+                <a:ea typeface="Leelawadee UI" pitchFamily="34" charset="-122"/>
+                <a:cs typeface="Leelawadee UI" pitchFamily="34" charset="-120"/>
+              </a:rPr>
+              <a:t>ขอบคุณ</a:t>
             </a:r>
             <a:endParaRPr lang="en-US" sz="4800" dirty="0"/>
           </a:p>
@@ -7281,11 +7283,11 @@
                 <a:solidFill>
                   <a:srgbClr val="A3E635"/>
                 </a:solidFill>
-                <a:latin typeface="Calibri" pitchFamily="34" charset="0"/>
-                <a:ea typeface="Calibri" pitchFamily="34" charset="-122"/>
-                <a:cs typeface="Calibri" pitchFamily="34" charset="-120"/>
-              </a:rPr>
-              <a:t>Questions &amp; Discussion</a:t>
+                <a:latin typeface="Leelawadee UI" pitchFamily="34" charset="0"/>
+                <a:ea typeface="Leelawadee UI" pitchFamily="34" charset="-122"/>
+                <a:cs typeface="Leelawadee UI" pitchFamily="34" charset="-120"/>
+              </a:rPr>
+              <a:t>ถาม-ตอบ (Q&amp;A)</a:t>
             </a:r>
             <a:endParaRPr lang="en-US" sz="1800" dirty="0"/>
           </a:p>
@@ -7320,11 +7322,11 @@
                 <a:solidFill>
                   <a:srgbClr val="5B6B7C"/>
                 </a:solidFill>
-                <a:latin typeface="Calibri" pitchFamily="34" charset="0"/>
-                <a:ea typeface="Calibri" pitchFamily="34" charset="-122"/>
-                <a:cs typeface="Calibri" pitchFamily="34" charset="-120"/>
-              </a:rPr>
-              <a:t>Stockscope AI  ·  CP020003 Artificial Intelligence  ·  Group ___</a:t>
+                <a:latin typeface="Leelawadee UI" pitchFamily="34" charset="0"/>
+                <a:ea typeface="Leelawadee UI" pitchFamily="34" charset="-122"/>
+                <a:cs typeface="Leelawadee UI" pitchFamily="34" charset="-120"/>
+              </a:rPr>
+              <a:t>Stockscope AI  ·  CP020003 ปัญญาประดิษฐ์  ·  กลุ่ม ___</a:t>
             </a:r>
             <a:endParaRPr lang="en-US" sz="1200" dirty="0"/>
           </a:p>
@@ -7391,9 +7393,9 @@
                 <a:solidFill>
                   <a:srgbClr val="5B6B7C"/>
                 </a:solidFill>
-                <a:latin typeface="Calibri" pitchFamily="34" charset="0"/>
-                <a:ea typeface="Calibri" pitchFamily="34" charset="-122"/>
-                <a:cs typeface="Calibri" pitchFamily="34" charset="-120"/>
+                <a:latin typeface="Leelawadee UI" pitchFamily="34" charset="0"/>
+                <a:ea typeface="Leelawadee UI" pitchFamily="34" charset="-122"/>
+                <a:cs typeface="Leelawadee UI" pitchFamily="34" charset="-120"/>
               </a:rPr>
               <a:t>2</a:t>
             </a:r>
@@ -7430,9 +7432,9 @@
                 <a:solidFill>
                   <a:srgbClr val="5B6B7C"/>
                 </a:solidFill>
-                <a:latin typeface="Calibri" pitchFamily="34" charset="0"/>
-                <a:ea typeface="Calibri" pitchFamily="34" charset="-122"/>
-                <a:cs typeface="Calibri" pitchFamily="34" charset="-120"/>
+                <a:latin typeface="Leelawadee UI" pitchFamily="34" charset="0"/>
+                <a:ea typeface="Leelawadee UI" pitchFamily="34" charset="-122"/>
+                <a:cs typeface="Leelawadee UI" pitchFamily="34" charset="-120"/>
               </a:rPr>
               <a:t>Stockscope AI · CP020003</a:t>
             </a:r>
@@ -7469,11 +7471,11 @@
                 <a:solidFill>
                   <a:srgbClr val="A3E635"/>
                 </a:solidFill>
-                <a:latin typeface="Calibri" pitchFamily="34" charset="0"/>
-                <a:ea typeface="Calibri" pitchFamily="34" charset="-122"/>
-                <a:cs typeface="Calibri" pitchFamily="34" charset="-120"/>
-              </a:rPr>
-              <a:t>OUR TEAM</a:t>
+                <a:latin typeface="Leelawadee UI" pitchFamily="34" charset="0"/>
+                <a:ea typeface="Leelawadee UI" pitchFamily="34" charset="-122"/>
+                <a:cs typeface="Leelawadee UI" pitchFamily="34" charset="-120"/>
+              </a:rPr>
+              <a:t>ทีมของเรา</a:t>
             </a:r>
             <a:endParaRPr lang="en-US" sz="1300" dirty="0"/>
           </a:p>
@@ -7508,11 +7510,11 @@
                 <a:solidFill>
                   <a:srgbClr val="F5F5F5"/>
                 </a:solidFill>
-                <a:latin typeface="Cambria" pitchFamily="34" charset="0"/>
-                <a:ea typeface="Cambria" pitchFamily="34" charset="-122"/>
-                <a:cs typeface="Cambria" pitchFamily="34" charset="-120"/>
-              </a:rPr>
-              <a:t>Group Members</a:t>
+                <a:latin typeface="Leelawadee UI" pitchFamily="34" charset="0"/>
+                <a:ea typeface="Leelawadee UI" pitchFamily="34" charset="-122"/>
+                <a:cs typeface="Leelawadee UI" pitchFamily="34" charset="-120"/>
+              </a:rPr>
+              <a:t>สมาชิกในกลุ่ม</a:t>
             </a:r>
             <a:endParaRPr lang="en-US" sz="3200" dirty="0"/>
           </a:p>
@@ -7576,11 +7578,11 @@
                 <a:solidFill>
                   <a:srgbClr val="9AA5B1"/>
                 </a:solidFill>
-                <a:latin typeface="Calibri" pitchFamily="34" charset="0"/>
-                <a:ea typeface="Calibri" pitchFamily="34" charset="-122"/>
-                <a:cs typeface="Calibri" pitchFamily="34" charset="-120"/>
-              </a:rPr>
-              <a:t>Group No.</a:t>
+                <a:latin typeface="Leelawadee UI" pitchFamily="34" charset="0"/>
+                <a:ea typeface="Leelawadee UI" pitchFamily="34" charset="-122"/>
+                <a:cs typeface="Leelawadee UI" pitchFamily="34" charset="-120"/>
+              </a:rPr>
+              <a:t>กลุ่มที่</a:t>
             </a:r>
             <a:endParaRPr lang="en-US" sz="1200" dirty="0"/>
           </a:p>
@@ -7615,9 +7617,9 @@
                 <a:solidFill>
                   <a:srgbClr val="A3E635"/>
                 </a:solidFill>
-                <a:latin typeface="Cambria" pitchFamily="34" charset="0"/>
-                <a:ea typeface="Cambria" pitchFamily="34" charset="-122"/>
-                <a:cs typeface="Cambria" pitchFamily="34" charset="-120"/>
+                <a:latin typeface="Leelawadee UI" pitchFamily="34" charset="0"/>
+                <a:ea typeface="Leelawadee UI" pitchFamily="34" charset="-122"/>
+                <a:cs typeface="Leelawadee UI" pitchFamily="34" charset="-120"/>
               </a:rPr>
               <a:t>___</a:t>
             </a:r>
@@ -7654,11 +7656,11 @@
                 <a:solidFill>
                   <a:srgbClr val="9AA5B1"/>
                 </a:solidFill>
-                <a:latin typeface="Calibri" pitchFamily="34" charset="0"/>
-                <a:ea typeface="Calibri" pitchFamily="34" charset="-122"/>
-                <a:cs typeface="Calibri" pitchFamily="34" charset="-120"/>
-              </a:rPr>
-              <a:t>Group Name</a:t>
+                <a:latin typeface="Leelawadee UI" pitchFamily="34" charset="0"/>
+                <a:ea typeface="Leelawadee UI" pitchFamily="34" charset="-122"/>
+                <a:cs typeface="Leelawadee UI" pitchFamily="34" charset="-120"/>
+              </a:rPr>
+              <a:t>ชื่อกลุ่ม</a:t>
             </a:r>
             <a:endParaRPr lang="en-US" sz="1200" dirty="0"/>
           </a:p>
@@ -7693,11 +7695,11 @@
                 <a:solidFill>
                   <a:srgbClr val="F5F5F5"/>
                 </a:solidFill>
-                <a:latin typeface="Cambria" pitchFamily="34" charset="0"/>
-                <a:ea typeface="Cambria" pitchFamily="34" charset="-122"/>
-                <a:cs typeface="Cambria" pitchFamily="34" charset="-120"/>
-              </a:rPr>
-              <a:t>[Team Name Here]</a:t>
+                <a:latin typeface="Leelawadee UI" pitchFamily="34" charset="0"/>
+                <a:ea typeface="Leelawadee UI" pitchFamily="34" charset="-122"/>
+                <a:cs typeface="Leelawadee UI" pitchFamily="34" charset="-120"/>
+              </a:rPr>
+              <a:t>[ชื่อทีมที่นี่]</a:t>
             </a:r>
             <a:endParaRPr lang="en-US" sz="2000" dirty="0"/>
           </a:p>
@@ -7744,16 +7746,16 @@
                           <a:solidFill>
                             <a:srgbClr val="A3E635"/>
                           </a:solidFill>
-                          <a:latin typeface="Calibri" pitchFamily="34" charset="0"/>
-                          <a:ea typeface="Calibri" pitchFamily="34" charset="-122"/>
-                          <a:cs typeface="Calibri" pitchFamily="34" charset="-120"/>
+                          <a:latin typeface="Leelawadee UI" pitchFamily="34" charset="0"/>
+                          <a:ea typeface="Leelawadee UI" pitchFamily="34" charset="-122"/>
+                          <a:cs typeface="Leelawadee UI" pitchFamily="34" charset="-120"/>
                         </a:rPr>
                         <a:t>#</a:t>
                       </a:r>
                       <a:endParaRPr lang="en-US" sz="1300" dirty="0">
-                        <a:latin typeface="Calibri" charset="0"/>
-                        <a:ea typeface="Calibri" charset="0"/>
-                        <a:cs typeface="Calibri" charset="0"/>
+                        <a:latin typeface="Leelawadee UI" charset="0"/>
+                        <a:ea typeface="Leelawadee UI" charset="0"/>
+                        <a:cs typeface="Leelawadee UI" charset="0"/>
                       </a:endParaRPr>
                     </a:p>
                   </a:txBody>
@@ -7788,16 +7790,16 @@
                           <a:solidFill>
                             <a:srgbClr val="A3E635"/>
                           </a:solidFill>
-                          <a:latin typeface="Calibri" pitchFamily="34" charset="0"/>
-                          <a:ea typeface="Calibri" pitchFamily="34" charset="-122"/>
-                          <a:cs typeface="Calibri" pitchFamily="34" charset="-120"/>
+                          <a:latin typeface="Leelawadee UI" pitchFamily="34" charset="0"/>
+                          <a:ea typeface="Leelawadee UI" pitchFamily="34" charset="-122"/>
+                          <a:cs typeface="Leelawadee UI" pitchFamily="34" charset="-120"/>
                         </a:rPr>
-                        <a:t>Student Name</a:t>
+                        <a:t>ชื่อนักศึกษา</a:t>
                       </a:r>
                       <a:endParaRPr lang="en-US" sz="1300" dirty="0">
-                        <a:latin typeface="Calibri" charset="0"/>
-                        <a:ea typeface="Calibri" charset="0"/>
-                        <a:cs typeface="Calibri" charset="0"/>
+                        <a:latin typeface="Leelawadee UI" charset="0"/>
+                        <a:ea typeface="Leelawadee UI" charset="0"/>
+                        <a:cs typeface="Leelawadee UI" charset="0"/>
                       </a:endParaRPr>
                     </a:p>
                   </a:txBody>
@@ -7832,16 +7834,16 @@
                           <a:solidFill>
                             <a:srgbClr val="A3E635"/>
                           </a:solidFill>
-                          <a:latin typeface="Calibri" pitchFamily="34" charset="0"/>
-                          <a:ea typeface="Calibri" pitchFamily="34" charset="-122"/>
-                          <a:cs typeface="Calibri" pitchFamily="34" charset="-120"/>
+                          <a:latin typeface="Leelawadee UI" pitchFamily="34" charset="0"/>
+                          <a:ea typeface="Leelawadee UI" pitchFamily="34" charset="-122"/>
+                          <a:cs typeface="Leelawadee UI" pitchFamily="34" charset="-120"/>
                         </a:rPr>
-                        <a:t>Student ID</a:t>
+                        <a:t>รหัสนักศึกษา</a:t>
                       </a:r>
                       <a:endParaRPr lang="en-US" sz="1300" dirty="0">
-                        <a:latin typeface="Calibri" charset="0"/>
-                        <a:ea typeface="Calibri" charset="0"/>
-                        <a:cs typeface="Calibri" charset="0"/>
+                        <a:latin typeface="Leelawadee UI" charset="0"/>
+                        <a:ea typeface="Leelawadee UI" charset="0"/>
+                        <a:cs typeface="Leelawadee UI" charset="0"/>
                       </a:endParaRPr>
                     </a:p>
                   </a:txBody>
@@ -7878,16 +7880,16 @@
                           <a:solidFill>
                             <a:srgbClr val="F5F5F5"/>
                           </a:solidFill>
-                          <a:latin typeface="Calibri" pitchFamily="34" charset="0"/>
-                          <a:ea typeface="Calibri" pitchFamily="34" charset="-122"/>
-                          <a:cs typeface="Calibri" pitchFamily="34" charset="-120"/>
+                          <a:latin typeface="Leelawadee UI" pitchFamily="34" charset="0"/>
+                          <a:ea typeface="Leelawadee UI" pitchFamily="34" charset="-122"/>
+                          <a:cs typeface="Leelawadee UI" pitchFamily="34" charset="-120"/>
                         </a:rPr>
                         <a:t>1</a:t>
                       </a:r>
                       <a:endParaRPr lang="en-US" sz="1300" dirty="0">
-                        <a:latin typeface="Calibri" charset="0"/>
-                        <a:ea typeface="Calibri" charset="0"/>
-                        <a:cs typeface="Calibri" charset="0"/>
+                        <a:latin typeface="Leelawadee UI" charset="0"/>
+                        <a:ea typeface="Leelawadee UI" charset="0"/>
+                        <a:cs typeface="Leelawadee UI" charset="0"/>
                       </a:endParaRPr>
                     </a:p>
                   </a:txBody>
@@ -7922,16 +7924,16 @@
                           <a:solidFill>
                             <a:srgbClr val="F5F5F5"/>
                           </a:solidFill>
-                          <a:latin typeface="Calibri" pitchFamily="34" charset="0"/>
-                          <a:ea typeface="Calibri" pitchFamily="34" charset="-122"/>
-                          <a:cs typeface="Calibri" pitchFamily="34" charset="-120"/>
+                          <a:latin typeface="Leelawadee UI" pitchFamily="34" charset="0"/>
+                          <a:ea typeface="Leelawadee UI" pitchFamily="34" charset="-122"/>
+                          <a:cs typeface="Leelawadee UI" pitchFamily="34" charset="-120"/>
                         </a:rPr>
                         <a:t>_______________________</a:t>
                       </a:r>
                       <a:endParaRPr lang="en-US" sz="1300" dirty="0">
-                        <a:latin typeface="Calibri" charset="0"/>
-                        <a:ea typeface="Calibri" charset="0"/>
-                        <a:cs typeface="Calibri" charset="0"/>
+                        <a:latin typeface="Leelawadee UI" charset="0"/>
+                        <a:ea typeface="Leelawadee UI" charset="0"/>
+                        <a:cs typeface="Leelawadee UI" charset="0"/>
                       </a:endParaRPr>
                     </a:p>
                   </a:txBody>
@@ -7966,16 +7968,16 @@
                           <a:solidFill>
                             <a:srgbClr val="F5F5F5"/>
                           </a:solidFill>
-                          <a:latin typeface="Calibri" pitchFamily="34" charset="0"/>
-                          <a:ea typeface="Calibri" pitchFamily="34" charset="-122"/>
-                          <a:cs typeface="Calibri" pitchFamily="34" charset="-120"/>
+                          <a:latin typeface="Leelawadee UI" pitchFamily="34" charset="0"/>
+                          <a:ea typeface="Leelawadee UI" pitchFamily="34" charset="-122"/>
+                          <a:cs typeface="Leelawadee UI" pitchFamily="34" charset="-120"/>
                         </a:rPr>
                         <a:t>_______________</a:t>
                       </a:r>
                       <a:endParaRPr lang="en-US" sz="1300" dirty="0">
-                        <a:latin typeface="Calibri" charset="0"/>
-                        <a:ea typeface="Calibri" charset="0"/>
-                        <a:cs typeface="Calibri" charset="0"/>
+                        <a:latin typeface="Leelawadee UI" charset="0"/>
+                        <a:ea typeface="Leelawadee UI" charset="0"/>
+                        <a:cs typeface="Leelawadee UI" charset="0"/>
                       </a:endParaRPr>
                     </a:p>
                   </a:txBody>
@@ -8012,16 +8014,16 @@
                           <a:solidFill>
                             <a:srgbClr val="F5F5F5"/>
                           </a:solidFill>
-                          <a:latin typeface="Calibri" pitchFamily="34" charset="0"/>
-                          <a:ea typeface="Calibri" pitchFamily="34" charset="-122"/>
-                          <a:cs typeface="Calibri" pitchFamily="34" charset="-120"/>
+                          <a:latin typeface="Leelawadee UI" pitchFamily="34" charset="0"/>
+                          <a:ea typeface="Leelawadee UI" pitchFamily="34" charset="-122"/>
+                          <a:cs typeface="Leelawadee UI" pitchFamily="34" charset="-120"/>
                         </a:rPr>
                         <a:t>2</a:t>
                       </a:r>
                       <a:endParaRPr lang="en-US" sz="1300" dirty="0">
-                        <a:latin typeface="Calibri" charset="0"/>
-                        <a:ea typeface="Calibri" charset="0"/>
-                        <a:cs typeface="Calibri" charset="0"/>
+                        <a:latin typeface="Leelawadee UI" charset="0"/>
+                        <a:ea typeface="Leelawadee UI" charset="0"/>
+                        <a:cs typeface="Leelawadee UI" charset="0"/>
                       </a:endParaRPr>
                     </a:p>
                   </a:txBody>
@@ -8056,16 +8058,16 @@
                           <a:solidFill>
                             <a:srgbClr val="F5F5F5"/>
                           </a:solidFill>
-                          <a:latin typeface="Calibri" pitchFamily="34" charset="0"/>
-                          <a:ea typeface="Calibri" pitchFamily="34" charset="-122"/>
-                          <a:cs typeface="Calibri" pitchFamily="34" charset="-120"/>
+                          <a:latin typeface="Leelawadee UI" pitchFamily="34" charset="0"/>
+                          <a:ea typeface="Leelawadee UI" pitchFamily="34" charset="-122"/>
+                          <a:cs typeface="Leelawadee UI" pitchFamily="34" charset="-120"/>
                         </a:rPr>
                         <a:t>_______________________</a:t>
                       </a:r>
                       <a:endParaRPr lang="en-US" sz="1300" dirty="0">
-                        <a:latin typeface="Calibri" charset="0"/>
-                        <a:ea typeface="Calibri" charset="0"/>
-                        <a:cs typeface="Calibri" charset="0"/>
+                        <a:latin typeface="Leelawadee UI" charset="0"/>
+                        <a:ea typeface="Leelawadee UI" charset="0"/>
+                        <a:cs typeface="Leelawadee UI" charset="0"/>
                       </a:endParaRPr>
                     </a:p>
                   </a:txBody>
@@ -8100,16 +8102,16 @@
                           <a:solidFill>
                             <a:srgbClr val="F5F5F5"/>
                           </a:solidFill>
-                          <a:latin typeface="Calibri" pitchFamily="34" charset="0"/>
-                          <a:ea typeface="Calibri" pitchFamily="34" charset="-122"/>
-                          <a:cs typeface="Calibri" pitchFamily="34" charset="-120"/>
+                          <a:latin typeface="Leelawadee UI" pitchFamily="34" charset="0"/>
+                          <a:ea typeface="Leelawadee UI" pitchFamily="34" charset="-122"/>
+                          <a:cs typeface="Leelawadee UI" pitchFamily="34" charset="-120"/>
                         </a:rPr>
                         <a:t>_______________</a:t>
                       </a:r>
                       <a:endParaRPr lang="en-US" sz="1300" dirty="0">
-                        <a:latin typeface="Calibri" charset="0"/>
-                        <a:ea typeface="Calibri" charset="0"/>
-                        <a:cs typeface="Calibri" charset="0"/>
+                        <a:latin typeface="Leelawadee UI" charset="0"/>
+                        <a:ea typeface="Leelawadee UI" charset="0"/>
+                        <a:cs typeface="Leelawadee UI" charset="0"/>
                       </a:endParaRPr>
                     </a:p>
                   </a:txBody>
@@ -8146,16 +8148,16 @@
                           <a:solidFill>
                             <a:srgbClr val="F5F5F5"/>
                           </a:solidFill>
-                          <a:latin typeface="Calibri" pitchFamily="34" charset="0"/>
-                          <a:ea typeface="Calibri" pitchFamily="34" charset="-122"/>
-                          <a:cs typeface="Calibri" pitchFamily="34" charset="-120"/>
+                          <a:latin typeface="Leelawadee UI" pitchFamily="34" charset="0"/>
+                          <a:ea typeface="Leelawadee UI" pitchFamily="34" charset="-122"/>
+                          <a:cs typeface="Leelawadee UI" pitchFamily="34" charset="-120"/>
                         </a:rPr>
                         <a:t>3</a:t>
                       </a:r>
                       <a:endParaRPr lang="en-US" sz="1300" dirty="0">
-                        <a:latin typeface="Calibri" charset="0"/>
-                        <a:ea typeface="Calibri" charset="0"/>
-                        <a:cs typeface="Calibri" charset="0"/>
+                        <a:latin typeface="Leelawadee UI" charset="0"/>
+                        <a:ea typeface="Leelawadee UI" charset="0"/>
+                        <a:cs typeface="Leelawadee UI" charset="0"/>
                       </a:endParaRPr>
                     </a:p>
                   </a:txBody>
@@ -8190,16 +8192,16 @@
                           <a:solidFill>
                             <a:srgbClr val="F5F5F5"/>
                           </a:solidFill>
-                          <a:latin typeface="Calibri" pitchFamily="34" charset="0"/>
-                          <a:ea typeface="Calibri" pitchFamily="34" charset="-122"/>
-                          <a:cs typeface="Calibri" pitchFamily="34" charset="-120"/>
+                          <a:latin typeface="Leelawadee UI" pitchFamily="34" charset="0"/>
+                          <a:ea typeface="Leelawadee UI" pitchFamily="34" charset="-122"/>
+                          <a:cs typeface="Leelawadee UI" pitchFamily="34" charset="-120"/>
                         </a:rPr>
                         <a:t>_______________________</a:t>
                       </a:r>
                       <a:endParaRPr lang="en-US" sz="1300" dirty="0">
-                        <a:latin typeface="Calibri" charset="0"/>
-                        <a:ea typeface="Calibri" charset="0"/>
-                        <a:cs typeface="Calibri" charset="0"/>
+                        <a:latin typeface="Leelawadee UI" charset="0"/>
+                        <a:ea typeface="Leelawadee UI" charset="0"/>
+                        <a:cs typeface="Leelawadee UI" charset="0"/>
                       </a:endParaRPr>
                     </a:p>
                   </a:txBody>
@@ -8234,16 +8236,16 @@
                           <a:solidFill>
                             <a:srgbClr val="F5F5F5"/>
                           </a:solidFill>
-                          <a:latin typeface="Calibri" pitchFamily="34" charset="0"/>
-                          <a:ea typeface="Calibri" pitchFamily="34" charset="-122"/>
-                          <a:cs typeface="Calibri" pitchFamily="34" charset="-120"/>
+                          <a:latin typeface="Leelawadee UI" pitchFamily="34" charset="0"/>
+                          <a:ea typeface="Leelawadee UI" pitchFamily="34" charset="-122"/>
+                          <a:cs typeface="Leelawadee UI" pitchFamily="34" charset="-120"/>
                         </a:rPr>
                         <a:t>_______________</a:t>
                       </a:r>
                       <a:endParaRPr lang="en-US" sz="1300" dirty="0">
-                        <a:latin typeface="Calibri" charset="0"/>
-                        <a:ea typeface="Calibri" charset="0"/>
-                        <a:cs typeface="Calibri" charset="0"/>
+                        <a:latin typeface="Leelawadee UI" charset="0"/>
+                        <a:ea typeface="Leelawadee UI" charset="0"/>
+                        <a:cs typeface="Leelawadee UI" charset="0"/>
                       </a:endParaRPr>
                     </a:p>
                   </a:txBody>
@@ -8280,16 +8282,16 @@
                           <a:solidFill>
                             <a:srgbClr val="F5F5F5"/>
                           </a:solidFill>
-                          <a:latin typeface="Calibri" pitchFamily="34" charset="0"/>
-                          <a:ea typeface="Calibri" pitchFamily="34" charset="-122"/>
-                          <a:cs typeface="Calibri" pitchFamily="34" charset="-120"/>
+                          <a:latin typeface="Leelawadee UI" pitchFamily="34" charset="0"/>
+                          <a:ea typeface="Leelawadee UI" pitchFamily="34" charset="-122"/>
+                          <a:cs typeface="Leelawadee UI" pitchFamily="34" charset="-120"/>
                         </a:rPr>
                         <a:t>4</a:t>
                       </a:r>
                       <a:endParaRPr lang="en-US" sz="1300" dirty="0">
-                        <a:latin typeface="Calibri" charset="0"/>
-                        <a:ea typeface="Calibri" charset="0"/>
-                        <a:cs typeface="Calibri" charset="0"/>
+                        <a:latin typeface="Leelawadee UI" charset="0"/>
+                        <a:ea typeface="Leelawadee UI" charset="0"/>
+                        <a:cs typeface="Leelawadee UI" charset="0"/>
                       </a:endParaRPr>
                     </a:p>
                   </a:txBody>
@@ -8324,16 +8326,16 @@
                           <a:solidFill>
                             <a:srgbClr val="F5F5F5"/>
                           </a:solidFill>
-                          <a:latin typeface="Calibri" pitchFamily="34" charset="0"/>
-                          <a:ea typeface="Calibri" pitchFamily="34" charset="-122"/>
-                          <a:cs typeface="Calibri" pitchFamily="34" charset="-120"/>
+                          <a:latin typeface="Leelawadee UI" pitchFamily="34" charset="0"/>
+                          <a:ea typeface="Leelawadee UI" pitchFamily="34" charset="-122"/>
+                          <a:cs typeface="Leelawadee UI" pitchFamily="34" charset="-120"/>
                         </a:rPr>
                         <a:t>_______________________</a:t>
                       </a:r>
                       <a:endParaRPr lang="en-US" sz="1300" dirty="0">
-                        <a:latin typeface="Calibri" charset="0"/>
-                        <a:ea typeface="Calibri" charset="0"/>
-                        <a:cs typeface="Calibri" charset="0"/>
+                        <a:latin typeface="Leelawadee UI" charset="0"/>
+                        <a:ea typeface="Leelawadee UI" charset="0"/>
+                        <a:cs typeface="Leelawadee UI" charset="0"/>
                       </a:endParaRPr>
                     </a:p>
                   </a:txBody>
@@ -8368,16 +8370,16 @@
                           <a:solidFill>
                             <a:srgbClr val="F5F5F5"/>
                           </a:solidFill>
-                          <a:latin typeface="Calibri" pitchFamily="34" charset="0"/>
-                          <a:ea typeface="Calibri" pitchFamily="34" charset="-122"/>
-                          <a:cs typeface="Calibri" pitchFamily="34" charset="-120"/>
+                          <a:latin typeface="Leelawadee UI" pitchFamily="34" charset="0"/>
+                          <a:ea typeface="Leelawadee UI" pitchFamily="34" charset="-122"/>
+                          <a:cs typeface="Leelawadee UI" pitchFamily="34" charset="-120"/>
                         </a:rPr>
                         <a:t>_______________</a:t>
                       </a:r>
                       <a:endParaRPr lang="en-US" sz="1300" dirty="0">
-                        <a:latin typeface="Calibri" charset="0"/>
-                        <a:ea typeface="Calibri" charset="0"/>
-                        <a:cs typeface="Calibri" charset="0"/>
+                        <a:latin typeface="Leelawadee UI" charset="0"/>
+                        <a:ea typeface="Leelawadee UI" charset="0"/>
+                        <a:cs typeface="Leelawadee UI" charset="0"/>
                       </a:endParaRPr>
                     </a:p>
                   </a:txBody>
@@ -8414,16 +8416,16 @@
                           <a:solidFill>
                             <a:srgbClr val="F5F5F5"/>
                           </a:solidFill>
-                          <a:latin typeface="Calibri" pitchFamily="34" charset="0"/>
-                          <a:ea typeface="Calibri" pitchFamily="34" charset="-122"/>
-                          <a:cs typeface="Calibri" pitchFamily="34" charset="-120"/>
+                          <a:latin typeface="Leelawadee UI" pitchFamily="34" charset="0"/>
+                          <a:ea typeface="Leelawadee UI" pitchFamily="34" charset="-122"/>
+                          <a:cs typeface="Leelawadee UI" pitchFamily="34" charset="-120"/>
                         </a:rPr>
                         <a:t>5</a:t>
                       </a:r>
                       <a:endParaRPr lang="en-US" sz="1300" dirty="0">
-                        <a:latin typeface="Calibri" charset="0"/>
-                        <a:ea typeface="Calibri" charset="0"/>
-                        <a:cs typeface="Calibri" charset="0"/>
+                        <a:latin typeface="Leelawadee UI" charset="0"/>
+                        <a:ea typeface="Leelawadee UI" charset="0"/>
+                        <a:cs typeface="Leelawadee UI" charset="0"/>
                       </a:endParaRPr>
                     </a:p>
                   </a:txBody>
@@ -8458,16 +8460,16 @@
                           <a:solidFill>
                             <a:srgbClr val="F5F5F5"/>
                           </a:solidFill>
-                          <a:latin typeface="Calibri" pitchFamily="34" charset="0"/>
-                          <a:ea typeface="Calibri" pitchFamily="34" charset="-122"/>
-                          <a:cs typeface="Calibri" pitchFamily="34" charset="-120"/>
+                          <a:latin typeface="Leelawadee UI" pitchFamily="34" charset="0"/>
+                          <a:ea typeface="Leelawadee UI" pitchFamily="34" charset="-122"/>
+                          <a:cs typeface="Leelawadee UI" pitchFamily="34" charset="-120"/>
                         </a:rPr>
                         <a:t>_______________________</a:t>
                       </a:r>
                       <a:endParaRPr lang="en-US" sz="1300" dirty="0">
-                        <a:latin typeface="Calibri" charset="0"/>
-                        <a:ea typeface="Calibri" charset="0"/>
-                        <a:cs typeface="Calibri" charset="0"/>
+                        <a:latin typeface="Leelawadee UI" charset="0"/>
+                        <a:ea typeface="Leelawadee UI" charset="0"/>
+                        <a:cs typeface="Leelawadee UI" charset="0"/>
                       </a:endParaRPr>
                     </a:p>
                   </a:txBody>
@@ -8502,16 +8504,16 @@
                           <a:solidFill>
                             <a:srgbClr val="F5F5F5"/>
                           </a:solidFill>
-                          <a:latin typeface="Calibri" pitchFamily="34" charset="0"/>
-                          <a:ea typeface="Calibri" pitchFamily="34" charset="-122"/>
-                          <a:cs typeface="Calibri" pitchFamily="34" charset="-120"/>
+                          <a:latin typeface="Leelawadee UI" pitchFamily="34" charset="0"/>
+                          <a:ea typeface="Leelawadee UI" pitchFamily="34" charset="-122"/>
+                          <a:cs typeface="Leelawadee UI" pitchFamily="34" charset="-120"/>
                         </a:rPr>
                         <a:t>_______________</a:t>
                       </a:r>
                       <a:endParaRPr lang="en-US" sz="1300" dirty="0">
-                        <a:latin typeface="Calibri" charset="0"/>
-                        <a:ea typeface="Calibri" charset="0"/>
-                        <a:cs typeface="Calibri" charset="0"/>
+                        <a:latin typeface="Leelawadee UI" charset="0"/>
+                        <a:ea typeface="Leelawadee UI" charset="0"/>
+                        <a:cs typeface="Leelawadee UI" charset="0"/>
                       </a:endParaRPr>
                     </a:p>
                   </a:txBody>
@@ -8599,9 +8601,9 @@
                 <a:solidFill>
                   <a:srgbClr val="5B6B7C"/>
                 </a:solidFill>
-                <a:latin typeface="Calibri" pitchFamily="34" charset="0"/>
-                <a:ea typeface="Calibri" pitchFamily="34" charset="-122"/>
-                <a:cs typeface="Calibri" pitchFamily="34" charset="-120"/>
+                <a:latin typeface="Leelawadee UI" pitchFamily="34" charset="0"/>
+                <a:ea typeface="Leelawadee UI" pitchFamily="34" charset="-122"/>
+                <a:cs typeface="Leelawadee UI" pitchFamily="34" charset="-120"/>
               </a:rPr>
               <a:t>3</a:t>
             </a:r>
@@ -8638,9 +8640,9 @@
                 <a:solidFill>
                   <a:srgbClr val="5B6B7C"/>
                 </a:solidFill>
-                <a:latin typeface="Calibri" pitchFamily="34" charset="0"/>
-                <a:ea typeface="Calibri" pitchFamily="34" charset="-122"/>
-                <a:cs typeface="Calibri" pitchFamily="34" charset="-120"/>
+                <a:latin typeface="Leelawadee UI" pitchFamily="34" charset="0"/>
+                <a:ea typeface="Leelawadee UI" pitchFamily="34" charset="-122"/>
+                <a:cs typeface="Leelawadee UI" pitchFamily="34" charset="-120"/>
               </a:rPr>
               <a:t>Stockscope AI · CP020003</a:t>
             </a:r>
@@ -8677,11 +8679,11 @@
                 <a:solidFill>
                   <a:srgbClr val="A3E635"/>
                 </a:solidFill>
-                <a:latin typeface="Calibri" pitchFamily="34" charset="0"/>
-                <a:ea typeface="Calibri" pitchFamily="34" charset="-122"/>
-                <a:cs typeface="Calibri" pitchFamily="34" charset="-120"/>
-              </a:rPr>
-              <a:t>MOTIVATION &amp; TOPIC</a:t>
+                <a:latin typeface="Leelawadee UI" pitchFamily="34" charset="0"/>
+                <a:ea typeface="Leelawadee UI" pitchFamily="34" charset="-122"/>
+                <a:cs typeface="Leelawadee UI" pitchFamily="34" charset="-120"/>
+              </a:rPr>
+              <a:t>ที่มาและหัวข้อ</a:t>
             </a:r>
             <a:endParaRPr lang="en-US" sz="1300" dirty="0"/>
           </a:p>
@@ -8716,11 +8718,11 @@
                 <a:solidFill>
                   <a:srgbClr val="F5F5F5"/>
                 </a:solidFill>
-                <a:latin typeface="Cambria" pitchFamily="34" charset="0"/>
-                <a:ea typeface="Cambria" pitchFamily="34" charset="-122"/>
-                <a:cs typeface="Cambria" pitchFamily="34" charset="-120"/>
-              </a:rPr>
-              <a:t>Why This Project?</a:t>
+                <a:latin typeface="Leelawadee UI" pitchFamily="34" charset="0"/>
+                <a:ea typeface="Leelawadee UI" pitchFamily="34" charset="-122"/>
+                <a:cs typeface="Leelawadee UI" pitchFamily="34" charset="-120"/>
+              </a:rPr>
+              <a:t>ทำไมถึงทำโปรเจกต์นี้?</a:t>
             </a:r>
             <a:endParaRPr lang="en-US" sz="3200" dirty="0"/>
           </a:p>
@@ -8755,11 +8757,11 @@
                 <a:solidFill>
                   <a:srgbClr val="F5F5F5"/>
                 </a:solidFill>
-                <a:latin typeface="Calibri" pitchFamily="34" charset="0"/>
-                <a:ea typeface="Calibri" pitchFamily="34" charset="-122"/>
-                <a:cs typeface="Calibri" pitchFamily="34" charset="-120"/>
-              </a:rPr>
-              <a:t>We already built Stockscope — a live dashboard that computes RSI, MACD, moving averages, and support/resistance zones for any stock, in real time.</a:t>
+                <a:latin typeface="Leelawadee UI" pitchFamily="34" charset="0"/>
+                <a:ea typeface="Leelawadee UI" pitchFamily="34" charset="-122"/>
+                <a:cs typeface="Leelawadee UI" pitchFamily="34" charset="-120"/>
+              </a:rPr>
+              <a:t>เราสร้าง Stockscope ไว้แล้ว — แดชบอร์ดที่คำนวณ RSI, MACD, ค่าเฉลี่ยเคลื่อนที่ และโซนแนวรับ-แนวต้าน ให้หุ้นทุกตัวแบบเรียลไทม์</a:t>
             </a:r>
             <a:endParaRPr lang="en-US" sz="1600" dirty="0"/>
           </a:p>
@@ -8794,11 +8796,11 @@
                 <a:solidFill>
                   <a:srgbClr val="9AA5B1"/>
                 </a:solidFill>
-                <a:latin typeface="Calibri" pitchFamily="34" charset="0"/>
-                <a:ea typeface="Calibri" pitchFamily="34" charset="-122"/>
-                <a:cs typeface="Calibri" pitchFamily="34" charset="-120"/>
-              </a:rPr>
-              <a:t>That raised a natural question we could actually test with data we already had:</a:t>
+                <a:latin typeface="Leelawadee UI" pitchFamily="34" charset="0"/>
+                <a:ea typeface="Leelawadee UI" pitchFamily="34" charset="-122"/>
+                <a:cs typeface="Leelawadee UI" pitchFamily="34" charset="-120"/>
+              </a:rPr>
+              <a:t>คำถามที่ตามมาคือสิ่งที่เราทดสอบได้จริงด้วยข้อมูลที่มีอยู่แล้ว:</a:t>
             </a:r>
             <a:endParaRPr lang="en-US" sz="1400" dirty="0"/>
           </a:p>
@@ -8858,17 +8860,17 @@
               <a:buNone/>
             </a:pPr>
             <a:r>
-              <a:rPr lang="en-US" sz="2000" i="1" dirty="0">
+              <a:rPr lang="en-US" sz="1900" i="1" dirty="0">
                 <a:solidFill>
                   <a:srgbClr val="A3E635"/>
                 </a:solidFill>
-                <a:latin typeface="Cambria" pitchFamily="34" charset="0"/>
-                <a:ea typeface="Cambria" pitchFamily="34" charset="-122"/>
-                <a:cs typeface="Cambria" pitchFamily="34" charset="-120"/>
-              </a:rPr>
-              <a:t>“Can the same indicators predict where the price goes next?”</a:t>
-            </a:r>
-            <a:endParaRPr lang="en-US" sz="2000" dirty="0"/>
+                <a:latin typeface="Leelawadee UI" pitchFamily="34" charset="0"/>
+                <a:ea typeface="Leelawadee UI" pitchFamily="34" charset="-122"/>
+                <a:cs typeface="Leelawadee UI" pitchFamily="34" charset="-120"/>
+              </a:rPr>
+              <a:t>“อินดิเคเตอร์เดียวกันนี้ ทำนายทิศทางราคาถัดไปได้ไหม?”</a:t>
+            </a:r>
+            <a:endParaRPr lang="en-US" sz="1900" dirty="0"/>
           </a:p>
         </p:txBody>
       </p:sp>
@@ -8974,11 +8976,11 @@
                 <a:solidFill>
                   <a:srgbClr val="F5F5F5"/>
                 </a:solidFill>
-                <a:latin typeface="Calibri" pitchFamily="34" charset="0"/>
-                <a:ea typeface="Calibri" pitchFamily="34" charset="-122"/>
-                <a:cs typeface="Calibri" pitchFamily="34" charset="-120"/>
-              </a:rPr>
-              <a:t>Live Dashboard</a:t>
+                <a:latin typeface="Leelawadee UI" pitchFamily="34" charset="0"/>
+                <a:ea typeface="Leelawadee UI" pitchFamily="34" charset="-122"/>
+                <a:cs typeface="Leelawadee UI" pitchFamily="34" charset="-120"/>
+              </a:rPr>
+              <a:t>แดชบอร์ดเรียลไทม์</a:t>
             </a:r>
             <a:endParaRPr lang="en-US" sz="1500" dirty="0"/>
           </a:p>
@@ -9013,9 +9015,9 @@
                 <a:solidFill>
                   <a:srgbClr val="9AA5B1"/>
                 </a:solidFill>
-                <a:latin typeface="Calibri" pitchFamily="34" charset="0"/>
-                <a:ea typeface="Calibri" pitchFamily="34" charset="-122"/>
-                <a:cs typeface="Calibri" pitchFamily="34" charset="-120"/>
+                <a:latin typeface="Leelawadee UI" pitchFamily="34" charset="0"/>
+                <a:ea typeface="Leelawadee UI" pitchFamily="34" charset="-122"/>
+                <a:cs typeface="Leelawadee UI" pitchFamily="34" charset="-120"/>
               </a:rPr>
               <a:t>RSI · MACD · SMA · Volume</a:t>
             </a:r>
@@ -9030,11 +9032,11 @@
                 <a:solidFill>
                   <a:srgbClr val="9AA5B1"/>
                 </a:solidFill>
-                <a:latin typeface="Calibri" pitchFamily="34" charset="0"/>
-                <a:ea typeface="Calibri" pitchFamily="34" charset="-122"/>
-                <a:cs typeface="Calibri" pitchFamily="34" charset="-120"/>
-              </a:rPr>
-              <a:t>computed today</a:t>
+                <a:latin typeface="Leelawadee UI" pitchFamily="34" charset="0"/>
+                <a:ea typeface="Leelawadee UI" pitchFamily="34" charset="-122"/>
+                <a:cs typeface="Leelawadee UI" pitchFamily="34" charset="-120"/>
+              </a:rPr>
+              <a:t>คำนวณแบบวันต่อวัน</a:t>
             </a:r>
             <a:endParaRPr lang="en-US" sz="1100" dirty="0"/>
           </a:p>
@@ -9166,11 +9168,11 @@
                 <a:solidFill>
                   <a:srgbClr val="F5F5F5"/>
                 </a:solidFill>
-                <a:latin typeface="Calibri" pitchFamily="34" charset="0"/>
-                <a:ea typeface="Calibri" pitchFamily="34" charset="-122"/>
-                <a:cs typeface="Calibri" pitchFamily="34" charset="-120"/>
-              </a:rPr>
-              <a:t>The Question</a:t>
+                <a:latin typeface="Leelawadee UI" pitchFamily="34" charset="0"/>
+                <a:ea typeface="Leelawadee UI" pitchFamily="34" charset="-122"/>
+                <a:cs typeface="Leelawadee UI" pitchFamily="34" charset="-120"/>
+              </a:rPr>
+              <a:t>คำถามหลัก</a:t>
             </a:r>
             <a:endParaRPr lang="en-US" sz="1500" dirty="0"/>
           </a:p>
@@ -9205,11 +9207,11 @@
                 <a:solidFill>
                   <a:srgbClr val="9AA5B1"/>
                 </a:solidFill>
-                <a:latin typeface="Calibri" pitchFamily="34" charset="0"/>
-                <a:ea typeface="Calibri" pitchFamily="34" charset="-122"/>
-                <a:cs typeface="Calibri" pitchFamily="34" charset="-120"/>
-              </a:rPr>
-              <a:t>Up or down over</a:t>
+                <a:latin typeface="Leelawadee UI" pitchFamily="34" charset="0"/>
+                <a:ea typeface="Leelawadee UI" pitchFamily="34" charset="-122"/>
+                <a:cs typeface="Leelawadee UI" pitchFamily="34" charset="-120"/>
+              </a:rPr>
+              <a:t>ขึ้นหรือลง</a:t>
             </a:r>
             <a:endParaRPr lang="en-US" sz="1100" dirty="0"/>
           </a:p>
@@ -9222,11 +9224,11 @@
                 <a:solidFill>
                   <a:srgbClr val="9AA5B1"/>
                 </a:solidFill>
-                <a:latin typeface="Calibri" pitchFamily="34" charset="0"/>
-                <a:ea typeface="Calibri" pitchFamily="34" charset="-122"/>
-                <a:cs typeface="Calibri" pitchFamily="34" charset="-120"/>
-              </a:rPr>
-              <a:t>the next N days?</a:t>
+                <a:latin typeface="Leelawadee UI" pitchFamily="34" charset="0"/>
+                <a:ea typeface="Leelawadee UI" pitchFamily="34" charset="-122"/>
+                <a:cs typeface="Leelawadee UI" pitchFamily="34" charset="-120"/>
+              </a:rPr>
+              <a:t>ในอีก N วันข้างหน้า?</a:t>
             </a:r>
             <a:endParaRPr lang="en-US" sz="1100" dirty="0"/>
           </a:p>
@@ -9358,11 +9360,11 @@
                 <a:solidFill>
                   <a:srgbClr val="F5F5F5"/>
                 </a:solidFill>
-                <a:latin typeface="Calibri" pitchFamily="34" charset="0"/>
-                <a:ea typeface="Calibri" pitchFamily="34" charset="-122"/>
-                <a:cs typeface="Calibri" pitchFamily="34" charset="-120"/>
-              </a:rPr>
-              <a:t>ML Model</a:t>
+                <a:latin typeface="Leelawadee UI" pitchFamily="34" charset="0"/>
+                <a:ea typeface="Leelawadee UI" pitchFamily="34" charset="-122"/>
+                <a:cs typeface="Leelawadee UI" pitchFamily="34" charset="-120"/>
+              </a:rPr>
+              <a:t>โมเดล ML</a:t>
             </a:r>
             <a:endParaRPr lang="en-US" sz="1500" dirty="0"/>
           </a:p>
@@ -9397,11 +9399,11 @@
                 <a:solidFill>
                   <a:srgbClr val="9AA5B1"/>
                 </a:solidFill>
-                <a:latin typeface="Calibri" pitchFamily="34" charset="0"/>
-                <a:ea typeface="Calibri" pitchFamily="34" charset="-122"/>
-                <a:cs typeface="Calibri" pitchFamily="34" charset="-120"/>
-              </a:rPr>
-              <a:t>Binary classification</a:t>
+                <a:latin typeface="Leelawadee UI" pitchFamily="34" charset="0"/>
+                <a:ea typeface="Leelawadee UI" pitchFamily="34" charset="-122"/>
+                <a:cs typeface="Leelawadee UI" pitchFamily="34" charset="-120"/>
+              </a:rPr>
+              <a:t>จำแนกสองกลุ่ม</a:t>
             </a:r>
             <a:endParaRPr lang="en-US" sz="1100" dirty="0"/>
           </a:p>
@@ -9414,11 +9416,11 @@
                 <a:solidFill>
                   <a:srgbClr val="9AA5B1"/>
                 </a:solidFill>
-                <a:latin typeface="Calibri" pitchFamily="34" charset="0"/>
-                <a:ea typeface="Calibri" pitchFamily="34" charset="-122"/>
-                <a:cs typeface="Calibri" pitchFamily="34" charset="-120"/>
-              </a:rPr>
-              <a:t>trained on history</a:t>
+                <a:latin typeface="Leelawadee UI" pitchFamily="34" charset="0"/>
+                <a:ea typeface="Leelawadee UI" pitchFamily="34" charset="-122"/>
+                <a:cs typeface="Leelawadee UI" pitchFamily="34" charset="-120"/>
+              </a:rPr>
+              <a:t>เทรนจากข้อมูลย้อนหลัง</a:t>
             </a:r>
             <a:endParaRPr lang="en-US" sz="1100" dirty="0"/>
           </a:p>
@@ -9485,9 +9487,9 @@
                 <a:solidFill>
                   <a:srgbClr val="5B6B7C"/>
                 </a:solidFill>
-                <a:latin typeface="Calibri" pitchFamily="34" charset="0"/>
-                <a:ea typeface="Calibri" pitchFamily="34" charset="-122"/>
-                <a:cs typeface="Calibri" pitchFamily="34" charset="-120"/>
+                <a:latin typeface="Leelawadee UI" pitchFamily="34" charset="0"/>
+                <a:ea typeface="Leelawadee UI" pitchFamily="34" charset="-122"/>
+                <a:cs typeface="Leelawadee UI" pitchFamily="34" charset="-120"/>
               </a:rPr>
               <a:t>4</a:t>
             </a:r>
@@ -9524,9 +9526,9 @@
                 <a:solidFill>
                   <a:srgbClr val="5B6B7C"/>
                 </a:solidFill>
-                <a:latin typeface="Calibri" pitchFamily="34" charset="0"/>
-                <a:ea typeface="Calibri" pitchFamily="34" charset="-122"/>
-                <a:cs typeface="Calibri" pitchFamily="34" charset="-120"/>
+                <a:latin typeface="Leelawadee UI" pitchFamily="34" charset="0"/>
+                <a:ea typeface="Leelawadee UI" pitchFamily="34" charset="-122"/>
+                <a:cs typeface="Leelawadee UI" pitchFamily="34" charset="-120"/>
               </a:rPr>
               <a:t>Stockscope AI · CP020003</a:t>
             </a:r>
@@ -9563,11 +9565,11 @@
                 <a:solidFill>
                   <a:srgbClr val="A3E635"/>
                 </a:solidFill>
-                <a:latin typeface="Calibri" pitchFamily="34" charset="0"/>
-                <a:ea typeface="Calibri" pitchFamily="34" charset="-122"/>
-                <a:cs typeface="Calibri" pitchFamily="34" charset="-120"/>
-              </a:rPr>
-              <a:t>THE AI TASK</a:t>
+                <a:latin typeface="Leelawadee UI" pitchFamily="34" charset="0"/>
+                <a:ea typeface="Leelawadee UI" pitchFamily="34" charset="-122"/>
+                <a:cs typeface="Leelawadee UI" pitchFamily="34" charset="-120"/>
+              </a:rPr>
+              <a:t>โจทย์ AI</a:t>
             </a:r>
             <a:endParaRPr lang="en-US" sz="1300" dirty="0"/>
           </a:p>
@@ -9602,11 +9604,11 @@
                 <a:solidFill>
                   <a:srgbClr val="F5F5F5"/>
                 </a:solidFill>
-                <a:latin typeface="Cambria" pitchFamily="34" charset="0"/>
-                <a:ea typeface="Cambria" pitchFamily="34" charset="-122"/>
-                <a:cs typeface="Cambria" pitchFamily="34" charset="-120"/>
-              </a:rPr>
-              <a:t>Framing It as Machine Learning</a:t>
+                <a:latin typeface="Leelawadee UI" pitchFamily="34" charset="0"/>
+                <a:ea typeface="Leelawadee UI" pitchFamily="34" charset="-122"/>
+                <a:cs typeface="Leelawadee UI" pitchFamily="34" charset="-120"/>
+              </a:rPr>
+              <a:t>มองเป็นปัญหา Machine Learning</a:t>
             </a:r>
             <a:endParaRPr lang="en-US" sz="3200" dirty="0"/>
           </a:p>
@@ -9666,17 +9668,17 @@
               <a:buNone/>
             </a:pPr>
             <a:r>
-              <a:rPr lang="en-US" sz="2000" b="1" dirty="0">
+              <a:rPr lang="en-US" sz="1900" b="1" dirty="0">
                 <a:solidFill>
                   <a:srgbClr val="A3E635"/>
                 </a:solidFill>
-                <a:latin typeface="Cambria" pitchFamily="34" charset="0"/>
-                <a:ea typeface="Cambria" pitchFamily="34" charset="-122"/>
-                <a:cs typeface="Cambria" pitchFamily="34" charset="-120"/>
-              </a:rPr>
-              <a:t>Binary Classification</a:t>
-            </a:r>
-            <a:endParaRPr lang="en-US" sz="2000" dirty="0"/>
+                <a:latin typeface="Leelawadee UI" pitchFamily="34" charset="0"/>
+                <a:ea typeface="Leelawadee UI" pitchFamily="34" charset="-122"/>
+                <a:cs typeface="Leelawadee UI" pitchFamily="34" charset="-120"/>
+              </a:rPr>
+              <a:t>การจำแนกแบบสองกลุ่ม</a:t>
+            </a:r>
+            <a:endParaRPr lang="en-US" sz="1900" dirty="0"/>
           </a:p>
         </p:txBody>
       </p:sp>
@@ -9765,11 +9767,11 @@
                 <a:solidFill>
                   <a:srgbClr val="9AA5B1"/>
                 </a:solidFill>
-                <a:latin typeface="Calibri" pitchFamily="34" charset="0"/>
-                <a:ea typeface="Calibri" pitchFamily="34" charset="-122"/>
-                <a:cs typeface="Calibri" pitchFamily="34" charset="-120"/>
-              </a:rPr>
-              <a:t>Input features: technical indicators up to day t</a:t>
+                <a:latin typeface="Leelawadee UI" pitchFamily="34" charset="0"/>
+                <a:ea typeface="Leelawadee UI" pitchFamily="34" charset="-122"/>
+                <a:cs typeface="Leelawadee UI" pitchFamily="34" charset="-120"/>
+              </a:rPr>
+              <a:t>Input: อินดิเคเตอร์ทางเทคนิคจนถึงวันที่ t</a:t>
             </a:r>
             <a:endParaRPr lang="en-US" sz="1300" dirty="0"/>
           </a:p>
@@ -9782,11 +9784,11 @@
                 <a:solidFill>
                   <a:srgbClr val="9AA5B1"/>
                 </a:solidFill>
-                <a:latin typeface="Calibri" pitchFamily="34" charset="0"/>
-                <a:ea typeface="Calibri" pitchFamily="34" charset="-122"/>
-                <a:cs typeface="Calibri" pitchFamily="34" charset="-120"/>
-              </a:rPr>
-              <a:t>Output: probability price is higher N trading days later</a:t>
+                <a:latin typeface="Leelawadee UI" pitchFamily="34" charset="0"/>
+                <a:ea typeface="Leelawadee UI" pitchFamily="34" charset="-122"/>
+                <a:cs typeface="Leelawadee UI" pitchFamily="34" charset="-120"/>
+              </a:rPr>
+              <a:t>Output: ความน่าจะเป็นที่ราคาจะสูงขึ้นในอีก N วัน</a:t>
             </a:r>
             <a:endParaRPr lang="en-US" sz="1300" dirty="0"/>
           </a:p>
@@ -9845,11 +9847,11 @@
                 <a:solidFill>
                   <a:srgbClr val="F5F5F5"/>
                 </a:solidFill>
-                <a:latin typeface="Calibri" pitchFamily="34" charset="0"/>
-                <a:ea typeface="Calibri" pitchFamily="34" charset="-122"/>
-                <a:cs typeface="Calibri" pitchFamily="34" charset="-120"/>
-              </a:rPr>
-              <a:t>Fast to train</a:t>
+                <a:latin typeface="Leelawadee UI" pitchFamily="34" charset="0"/>
+                <a:ea typeface="Leelawadee UI" pitchFamily="34" charset="-122"/>
+                <a:cs typeface="Leelawadee UI" pitchFamily="34" charset="-120"/>
+              </a:rPr>
+              <a:t>เทรนเร็ว</a:t>
             </a:r>
             <a:endParaRPr lang="en-US" sz="1300" dirty="0"/>
           </a:p>
@@ -9884,11 +9886,11 @@
                 <a:solidFill>
                   <a:srgbClr val="9AA5B1"/>
                 </a:solidFill>
-                <a:latin typeface="Calibri" pitchFamily="34" charset="0"/>
-                <a:ea typeface="Calibri" pitchFamily="34" charset="-122"/>
-                <a:cs typeface="Calibri" pitchFamily="34" charset="-120"/>
-              </a:rPr>
-              <a:t>Iterates in seconds on a laptop or free Colab CPU</a:t>
+                <a:latin typeface="Leelawadee UI" pitchFamily="34" charset="0"/>
+                <a:ea typeface="Leelawadee UI" pitchFamily="34" charset="-122"/>
+                <a:cs typeface="Leelawadee UI" pitchFamily="34" charset="-120"/>
+              </a:rPr>
+              <a:t>รันจบในไม่กี่วินาที บนโน้ตบุ๊กหรือ Colab ฟรี</a:t>
             </a:r>
             <a:endParaRPr lang="en-US" sz="1100" dirty="0"/>
           </a:p>
@@ -9947,11 +9949,11 @@
                 <a:solidFill>
                   <a:srgbClr val="F5F5F5"/>
                 </a:solidFill>
-                <a:latin typeface="Calibri" pitchFamily="34" charset="0"/>
-                <a:ea typeface="Calibri" pitchFamily="34" charset="-122"/>
-                <a:cs typeface="Calibri" pitchFamily="34" charset="-120"/>
-              </a:rPr>
-              <a:t>Tabular-native</a:t>
+                <a:latin typeface="Leelawadee UI" pitchFamily="34" charset="0"/>
+                <a:ea typeface="Leelawadee UI" pitchFamily="34" charset="-122"/>
+                <a:cs typeface="Leelawadee UI" pitchFamily="34" charset="-120"/>
+              </a:rPr>
+              <a:t>เหมาะกับข้อมูลตาราง</a:t>
             </a:r>
             <a:endParaRPr lang="en-US" sz="1300" dirty="0"/>
           </a:p>
@@ -9986,11 +9988,11 @@
                 <a:solidFill>
                   <a:srgbClr val="9AA5B1"/>
                 </a:solidFill>
-                <a:latin typeface="Calibri" pitchFamily="34" charset="0"/>
-                <a:ea typeface="Calibri" pitchFamily="34" charset="-122"/>
-                <a:cs typeface="Calibri" pitchFamily="34" charset="-120"/>
-              </a:rPr>
-              <a:t>Our features are indicator numbers, not images or text</a:t>
+                <a:latin typeface="Leelawadee UI" pitchFamily="34" charset="0"/>
+                <a:ea typeface="Leelawadee UI" pitchFamily="34" charset="-122"/>
+                <a:cs typeface="Leelawadee UI" pitchFamily="34" charset="-120"/>
+              </a:rPr>
+              <a:t>ฟีเจอร์ของเราคือตัวเลขอินดิเคเตอร์ ไม่ใช่รูปภาพหรือข้อความ</a:t>
             </a:r>
             <a:endParaRPr lang="en-US" sz="1100" dirty="0"/>
           </a:p>
@@ -10049,11 +10051,11 @@
                 <a:solidFill>
                   <a:srgbClr val="F5F5F5"/>
                 </a:solidFill>
-                <a:latin typeface="Calibri" pitchFamily="34" charset="0"/>
-                <a:ea typeface="Calibri" pitchFamily="34" charset="-122"/>
-                <a:cs typeface="Calibri" pitchFamily="34" charset="-120"/>
-              </a:rPr>
-              <a:t>Explainable</a:t>
+                <a:latin typeface="Leelawadee UI" pitchFamily="34" charset="0"/>
+                <a:ea typeface="Leelawadee UI" pitchFamily="34" charset="-122"/>
+                <a:cs typeface="Leelawadee UI" pitchFamily="34" charset="-120"/>
+              </a:rPr>
+              <a:t>อธิบายได้</a:t>
             </a:r>
             <a:endParaRPr lang="en-US" sz="1300" dirty="0"/>
           </a:p>
@@ -10088,11 +10090,11 @@
                 <a:solidFill>
                   <a:srgbClr val="9AA5B1"/>
                 </a:solidFill>
-                <a:latin typeface="Calibri" pitchFamily="34" charset="0"/>
-                <a:ea typeface="Calibri" pitchFamily="34" charset="-122"/>
-                <a:cs typeface="Calibri" pitchFamily="34" charset="-120"/>
-              </a:rPr>
-              <a:t>Feature importance shows *why*, not just a number</a:t>
+                <a:latin typeface="Leelawadee UI" pitchFamily="34" charset="0"/>
+                <a:ea typeface="Leelawadee UI" pitchFamily="34" charset="-122"/>
+                <a:cs typeface="Leelawadee UI" pitchFamily="34" charset="-120"/>
+              </a:rPr>
+              <a:t>Feature Importance บอกได้ว่า “ทำไม” ไม่ใช่แค่ตัวเลข</a:t>
             </a:r>
             <a:endParaRPr lang="en-US" sz="1100" dirty="0"/>
           </a:p>
@@ -10176,11 +10178,11 @@
                 <a:solidFill>
                   <a:srgbClr val="F5F5F5"/>
                 </a:solidFill>
-                <a:latin typeface="Calibri" pitchFamily="34" charset="0"/>
-                <a:ea typeface="Calibri" pitchFamily="34" charset="-122"/>
-                <a:cs typeface="Calibri" pitchFamily="34" charset="-120"/>
-              </a:rPr>
-              <a:t>Data</a:t>
+                <a:latin typeface="Leelawadee UI" pitchFamily="34" charset="0"/>
+                <a:ea typeface="Leelawadee UI" pitchFamily="34" charset="-122"/>
+                <a:cs typeface="Leelawadee UI" pitchFamily="34" charset="-120"/>
+              </a:rPr>
+              <a:t>ข้อมูล</a:t>
             </a:r>
             <a:endParaRPr lang="en-US" sz="1400" dirty="0"/>
           </a:p>
@@ -10215,11 +10217,11 @@
                 <a:solidFill>
                   <a:srgbClr val="9AA5B1"/>
                 </a:solidFill>
-                <a:latin typeface="Calibri" pitchFamily="34" charset="0"/>
-                <a:ea typeface="Calibri" pitchFamily="34" charset="-122"/>
-                <a:cs typeface="Calibri" pitchFamily="34" charset="-120"/>
-              </a:rPr>
-              <a:t>5y OHLCV, 20 tickers</a:t>
+                <a:latin typeface="Leelawadee UI" pitchFamily="34" charset="0"/>
+                <a:ea typeface="Leelawadee UI" pitchFamily="34" charset="-122"/>
+                <a:cs typeface="Leelawadee UI" pitchFamily="34" charset="-120"/>
+              </a:rPr>
+              <a:t>OHLCV 5 ปี, 20 หุ้น</a:t>
             </a:r>
             <a:endParaRPr lang="en-US" sz="1100" dirty="0"/>
           </a:p>
@@ -10326,11 +10328,11 @@
                 <a:solidFill>
                   <a:srgbClr val="F5F5F5"/>
                 </a:solidFill>
-                <a:latin typeface="Calibri" pitchFamily="34" charset="0"/>
-                <a:ea typeface="Calibri" pitchFamily="34" charset="-122"/>
-                <a:cs typeface="Calibri" pitchFamily="34" charset="-120"/>
-              </a:rPr>
-              <a:t>Features</a:t>
+                <a:latin typeface="Leelawadee UI" pitchFamily="34" charset="0"/>
+                <a:ea typeface="Leelawadee UI" pitchFamily="34" charset="-122"/>
+                <a:cs typeface="Leelawadee UI" pitchFamily="34" charset="-120"/>
+              </a:rPr>
+              <a:t>ฟีเจอร์</a:t>
             </a:r>
             <a:endParaRPr lang="en-US" sz="1400" dirty="0"/>
           </a:p>
@@ -10365,9 +10367,9 @@
                 <a:solidFill>
                   <a:srgbClr val="9AA5B1"/>
                 </a:solidFill>
-                <a:latin typeface="Calibri" pitchFamily="34" charset="0"/>
-                <a:ea typeface="Calibri" pitchFamily="34" charset="-122"/>
-                <a:cs typeface="Calibri" pitchFamily="34" charset="-120"/>
+                <a:latin typeface="Leelawadee UI" pitchFamily="34" charset="0"/>
+                <a:ea typeface="Leelawadee UI" pitchFamily="34" charset="-122"/>
+                <a:cs typeface="Leelawadee UI" pitchFamily="34" charset="-120"/>
               </a:rPr>
               <a:t>RSI · MACD · SMA · Vol</a:t>
             </a:r>
@@ -10476,11 +10478,11 @@
                 <a:solidFill>
                   <a:srgbClr val="F5F5F5"/>
                 </a:solidFill>
-                <a:latin typeface="Calibri" pitchFamily="34" charset="0"/>
-                <a:ea typeface="Calibri" pitchFamily="34" charset="-122"/>
-                <a:cs typeface="Calibri" pitchFamily="34" charset="-120"/>
-              </a:rPr>
-              <a:t>Model</a:t>
+                <a:latin typeface="Leelawadee UI" pitchFamily="34" charset="0"/>
+                <a:ea typeface="Leelawadee UI" pitchFamily="34" charset="-122"/>
+                <a:cs typeface="Leelawadee UI" pitchFamily="34" charset="-120"/>
+              </a:rPr>
+              <a:t>โมเดล</a:t>
             </a:r>
             <a:endParaRPr lang="en-US" sz="1400" dirty="0"/>
           </a:p>
@@ -10515,9 +10517,9 @@
                 <a:solidFill>
                   <a:srgbClr val="9AA5B1"/>
                 </a:solidFill>
-                <a:latin typeface="Calibri" pitchFamily="34" charset="0"/>
-                <a:ea typeface="Calibri" pitchFamily="34" charset="-122"/>
-                <a:cs typeface="Calibri" pitchFamily="34" charset="-120"/>
+                <a:latin typeface="Leelawadee UI" pitchFamily="34" charset="0"/>
+                <a:ea typeface="Leelawadee UI" pitchFamily="34" charset="-122"/>
+                <a:cs typeface="Leelawadee UI" pitchFamily="34" charset="-120"/>
               </a:rPr>
               <a:t>XGBoost classifier</a:t>
             </a:r>
@@ -10626,11 +10628,11 @@
                 <a:solidFill>
                   <a:srgbClr val="F5F5F5"/>
                 </a:solidFill>
-                <a:latin typeface="Calibri" pitchFamily="34" charset="0"/>
-                <a:ea typeface="Calibri" pitchFamily="34" charset="-122"/>
-                <a:cs typeface="Calibri" pitchFamily="34" charset="-120"/>
-              </a:rPr>
-              <a:t>Prediction</a:t>
+                <a:latin typeface="Leelawadee UI" pitchFamily="34" charset="0"/>
+                <a:ea typeface="Leelawadee UI" pitchFamily="34" charset="-122"/>
+                <a:cs typeface="Leelawadee UI" pitchFamily="34" charset="-120"/>
+              </a:rPr>
+              <a:t>ผลทำนาย</a:t>
             </a:r>
             <a:endParaRPr lang="en-US" sz="1400" dirty="0"/>
           </a:p>
@@ -10665,11 +10667,11 @@
                 <a:solidFill>
                   <a:srgbClr val="9AA5B1"/>
                 </a:solidFill>
-                <a:latin typeface="Calibri" pitchFamily="34" charset="0"/>
-                <a:ea typeface="Calibri" pitchFamily="34" charset="-122"/>
-                <a:cs typeface="Calibri" pitchFamily="34" charset="-120"/>
-              </a:rPr>
-              <a:t>P(up) in N days</a:t>
+                <a:latin typeface="Leelawadee UI" pitchFamily="34" charset="0"/>
+                <a:ea typeface="Leelawadee UI" pitchFamily="34" charset="-122"/>
+                <a:cs typeface="Leelawadee UI" pitchFamily="34" charset="-120"/>
+              </a:rPr>
+              <a:t>P(ขึ้น) ใน N วัน</a:t>
             </a:r>
             <a:endParaRPr lang="en-US" sz="1100" dirty="0"/>
           </a:p>
@@ -10736,9 +10738,9 @@
                 <a:solidFill>
                   <a:srgbClr val="5B6B7C"/>
                 </a:solidFill>
-                <a:latin typeface="Calibri" pitchFamily="34" charset="0"/>
-                <a:ea typeface="Calibri" pitchFamily="34" charset="-122"/>
-                <a:cs typeface="Calibri" pitchFamily="34" charset="-120"/>
+                <a:latin typeface="Leelawadee UI" pitchFamily="34" charset="0"/>
+                <a:ea typeface="Leelawadee UI" pitchFamily="34" charset="-122"/>
+                <a:cs typeface="Leelawadee UI" pitchFamily="34" charset="-120"/>
               </a:rPr>
               <a:t>5</a:t>
             </a:r>
@@ -10775,9 +10777,9 @@
                 <a:solidFill>
                   <a:srgbClr val="5B6B7C"/>
                 </a:solidFill>
-                <a:latin typeface="Calibri" pitchFamily="34" charset="0"/>
-                <a:ea typeface="Calibri" pitchFamily="34" charset="-122"/>
-                <a:cs typeface="Calibri" pitchFamily="34" charset="-120"/>
+                <a:latin typeface="Leelawadee UI" pitchFamily="34" charset="0"/>
+                <a:ea typeface="Leelawadee UI" pitchFamily="34" charset="-122"/>
+                <a:cs typeface="Leelawadee UI" pitchFamily="34" charset="-120"/>
               </a:rPr>
               <a:t>Stockscope AI · CP020003</a:t>
             </a:r>
@@ -10814,11 +10816,11 @@
                 <a:solidFill>
                   <a:srgbClr val="A3E635"/>
                 </a:solidFill>
-                <a:latin typeface="Calibri" pitchFamily="34" charset="0"/>
-                <a:ea typeface="Calibri" pitchFamily="34" charset="-122"/>
-                <a:cs typeface="Calibri" pitchFamily="34" charset="-120"/>
-              </a:rPr>
-              <a:t>DATASET &amp; EDA</a:t>
+                <a:latin typeface="Leelawadee UI" pitchFamily="34" charset="0"/>
+                <a:ea typeface="Leelawadee UI" pitchFamily="34" charset="-122"/>
+                <a:cs typeface="Leelawadee UI" pitchFamily="34" charset="-120"/>
+              </a:rPr>
+              <a:t>ชุดข้อมูลและ EDA</a:t>
             </a:r>
             <a:endParaRPr lang="en-US" sz="1300" dirty="0"/>
           </a:p>
@@ -10853,11 +10855,11 @@
                 <a:solidFill>
                   <a:srgbClr val="F5F5F5"/>
                 </a:solidFill>
-                <a:latin typeface="Cambria" pitchFamily="34" charset="0"/>
-                <a:ea typeface="Cambria" pitchFamily="34" charset="-122"/>
-                <a:cs typeface="Cambria" pitchFamily="34" charset="-120"/>
-              </a:rPr>
-              <a:t>Dataset</a:t>
+                <a:latin typeface="Leelawadee UI" pitchFamily="34" charset="0"/>
+                <a:ea typeface="Leelawadee UI" pitchFamily="34" charset="-122"/>
+                <a:cs typeface="Leelawadee UI" pitchFamily="34" charset="-120"/>
+              </a:rPr>
+              <a:t>ชุดข้อมูล (Dataset)</a:t>
             </a:r>
             <a:endParaRPr lang="en-US" sz="3200" dirty="0"/>
           </a:p>
@@ -10921,9 +10923,9 @@
                 <a:solidFill>
                   <a:srgbClr val="A3E635"/>
                 </a:solidFill>
-                <a:latin typeface="Cambria" pitchFamily="34" charset="0"/>
-                <a:ea typeface="Cambria" pitchFamily="34" charset="-122"/>
-                <a:cs typeface="Cambria" pitchFamily="34" charset="-120"/>
+                <a:latin typeface="Leelawadee UI" pitchFamily="34" charset="0"/>
+                <a:ea typeface="Leelawadee UI" pitchFamily="34" charset="-122"/>
+                <a:cs typeface="Leelawadee UI" pitchFamily="34" charset="-120"/>
               </a:rPr>
               <a:t>20</a:t>
             </a:r>
@@ -10960,11 +10962,11 @@
                 <a:solidFill>
                   <a:srgbClr val="9AA5B1"/>
                 </a:solidFill>
-                <a:latin typeface="Calibri" pitchFamily="34" charset="0"/>
-                <a:ea typeface="Calibri" pitchFamily="34" charset="-122"/>
-                <a:cs typeface="Calibri" pitchFamily="34" charset="-120"/>
-              </a:rPr>
-              <a:t>TICKERS</a:t>
+                <a:latin typeface="Leelawadee UI" pitchFamily="34" charset="0"/>
+                <a:ea typeface="Leelawadee UI" pitchFamily="34" charset="-122"/>
+                <a:cs typeface="Leelawadee UI" pitchFamily="34" charset="-120"/>
+              </a:rPr>
+              <a:t>จำนวนหุ้น</a:t>
             </a:r>
             <a:endParaRPr lang="en-US" sz="1200" dirty="0"/>
           </a:p>
@@ -11028,11 +11030,11 @@
                 <a:solidFill>
                   <a:srgbClr val="A3E635"/>
                 </a:solidFill>
-                <a:latin typeface="Cambria" pitchFamily="34" charset="0"/>
-                <a:ea typeface="Cambria" pitchFamily="34" charset="-122"/>
-                <a:cs typeface="Cambria" pitchFamily="34" charset="-120"/>
-              </a:rPr>
-              <a:t>5 yrs</a:t>
+                <a:latin typeface="Leelawadee UI" pitchFamily="34" charset="0"/>
+                <a:ea typeface="Leelawadee UI" pitchFamily="34" charset="-122"/>
+                <a:cs typeface="Leelawadee UI" pitchFamily="34" charset="-120"/>
+              </a:rPr>
+              <a:t>5 ปี</a:t>
             </a:r>
             <a:endParaRPr lang="en-US" sz="3000" dirty="0"/>
           </a:p>
@@ -11067,11 +11069,11 @@
                 <a:solidFill>
                   <a:srgbClr val="9AA5B1"/>
                 </a:solidFill>
-                <a:latin typeface="Calibri" pitchFamily="34" charset="0"/>
-                <a:ea typeface="Calibri" pitchFamily="34" charset="-122"/>
-                <a:cs typeface="Calibri" pitchFamily="34" charset="-120"/>
-              </a:rPr>
-              <a:t>DAILY HISTORY</a:t>
+                <a:latin typeface="Leelawadee UI" pitchFamily="34" charset="0"/>
+                <a:ea typeface="Leelawadee UI" pitchFamily="34" charset="-122"/>
+                <a:cs typeface="Leelawadee UI" pitchFamily="34" charset="-120"/>
+              </a:rPr>
+              <a:t>ข้อมูลรายวัน</a:t>
             </a:r>
             <a:endParaRPr lang="en-US" sz="1200" dirty="0"/>
           </a:p>
@@ -11135,9 +11137,9 @@
                 <a:solidFill>
                   <a:srgbClr val="A3E635"/>
                 </a:solidFill>
-                <a:latin typeface="Cambria" pitchFamily="34" charset="0"/>
-                <a:ea typeface="Cambria" pitchFamily="34" charset="-122"/>
-                <a:cs typeface="Cambria" pitchFamily="34" charset="-120"/>
+                <a:latin typeface="Leelawadee UI" pitchFamily="34" charset="0"/>
+                <a:ea typeface="Leelawadee UI" pitchFamily="34" charset="-122"/>
+                <a:cs typeface="Leelawadee UI" pitchFamily="34" charset="-120"/>
               </a:rPr>
               <a:t>25,100</a:t>
             </a:r>
@@ -11174,11 +11176,11 @@
                 <a:solidFill>
                   <a:srgbClr val="9AA5B1"/>
                 </a:solidFill>
-                <a:latin typeface="Calibri" pitchFamily="34" charset="0"/>
-                <a:ea typeface="Calibri" pitchFamily="34" charset="-122"/>
-                <a:cs typeface="Calibri" pitchFamily="34" charset="-120"/>
-              </a:rPr>
-              <a:t>TOTAL ROWS</a:t>
+                <a:latin typeface="Leelawadee UI" pitchFamily="34" charset="0"/>
+                <a:ea typeface="Leelawadee UI" pitchFamily="34" charset="-122"/>
+                <a:cs typeface="Leelawadee UI" pitchFamily="34" charset="-120"/>
+              </a:rPr>
+              <a:t>แถวข้อมูลทั้งหมด</a:t>
             </a:r>
             <a:endParaRPr lang="en-US" sz="1200" dirty="0"/>
           </a:p>
@@ -11242,9 +11244,9 @@
                 <a:solidFill>
                   <a:srgbClr val="A3E635"/>
                 </a:solidFill>
-                <a:latin typeface="Cambria" pitchFamily="34" charset="0"/>
-                <a:ea typeface="Cambria" pitchFamily="34" charset="-122"/>
-                <a:cs typeface="Cambria" pitchFamily="34" charset="-120"/>
+                <a:latin typeface="Leelawadee UI" pitchFamily="34" charset="0"/>
+                <a:ea typeface="Leelawadee UI" pitchFamily="34" charset="-122"/>
+                <a:cs typeface="Leelawadee UI" pitchFamily="34" charset="-120"/>
               </a:rPr>
               <a:t>0</a:t>
             </a:r>
@@ -11281,11 +11283,11 @@
                 <a:solidFill>
                   <a:srgbClr val="9AA5B1"/>
                 </a:solidFill>
-                <a:latin typeface="Calibri" pitchFamily="34" charset="0"/>
-                <a:ea typeface="Calibri" pitchFamily="34" charset="-122"/>
-                <a:cs typeface="Calibri" pitchFamily="34" charset="-120"/>
-              </a:rPr>
-              <a:t>MISSING VALUES</a:t>
+                <a:latin typeface="Leelawadee UI" pitchFamily="34" charset="0"/>
+                <a:ea typeface="Leelawadee UI" pitchFamily="34" charset="-122"/>
+                <a:cs typeface="Leelawadee UI" pitchFamily="34" charset="-120"/>
+              </a:rPr>
+              <a:t>ข้อมูลขาดหาย</a:t>
             </a:r>
             <a:endParaRPr lang="en-US" sz="1200" dirty="0"/>
           </a:p>
@@ -11320,11 +11322,11 @@
                 <a:solidFill>
                   <a:srgbClr val="A3E635"/>
                 </a:solidFill>
-                <a:latin typeface="Calibri" pitchFamily="34" charset="0"/>
-                <a:ea typeface="Calibri" pitchFamily="34" charset="-122"/>
-                <a:cs typeface="Calibri" pitchFamily="34" charset="-120"/>
-              </a:rPr>
-              <a:t>Same data source that powers Stockscope live: Yahoo Finance via yfinance.</a:t>
+                <a:latin typeface="Leelawadee UI" pitchFamily="34" charset="0"/>
+                <a:ea typeface="Leelawadee UI" pitchFamily="34" charset="-122"/>
+                <a:cs typeface="Leelawadee UI" pitchFamily="34" charset="-120"/>
+              </a:rPr>
+              <a:t>แหล่งข้อมูลเดียวกับที่ Stockscope ใช้งานจริง: Yahoo Finance ผ่าน yfinance</a:t>
             </a:r>
             <a:endParaRPr lang="en-US" sz="1400" dirty="0"/>
           </a:p>
@@ -11339,7 +11341,7 @@
         <p:spPr>
           <a:xfrm>
             <a:off x="548640" y="3703320"/>
-            <a:ext cx="5486400" cy="365760"/>
+            <a:ext cx="6400800" cy="365760"/>
           </a:xfrm>
           <a:prstGeom prst="rect">
             <a:avLst/>
@@ -11359,11 +11361,11 @@
                 <a:solidFill>
                   <a:srgbClr val="9AA5B1"/>
                 </a:solidFill>
-                <a:latin typeface="Calibri" pitchFamily="34" charset="0"/>
-                <a:ea typeface="Calibri" pitchFamily="34" charset="-122"/>
-                <a:cs typeface="Calibri" pitchFamily="34" charset="-120"/>
-              </a:rPr>
-              <a:t>2021-09-27  →  2026-09-25</a:t>
+                <a:latin typeface="Leelawadee UI" pitchFamily="34" charset="0"/>
+                <a:ea typeface="Leelawadee UI" pitchFamily="34" charset="-122"/>
+                <a:cs typeface="Leelawadee UI" pitchFamily="34" charset="-120"/>
+              </a:rPr>
+              <a:t>ช่วงข้อมูล: 2021-09-27  →  2026-09-25</a:t>
             </a:r>
             <a:endParaRPr lang="en-US" sz="1300" dirty="0"/>
           </a:p>
@@ -11398,11 +11400,11 @@
                 <a:solidFill>
                   <a:srgbClr val="9AA5B1"/>
                 </a:solidFill>
-                <a:latin typeface="Calibri" pitchFamily="34" charset="0"/>
-                <a:ea typeface="Calibri" pitchFamily="34" charset="-122"/>
-                <a:cs typeface="Calibri" pitchFamily="34" charset="-120"/>
-              </a:rPr>
-              <a:t>SECTORS COVERED</a:t>
+                <a:latin typeface="Leelawadee UI" pitchFamily="34" charset="0"/>
+                <a:ea typeface="Leelawadee UI" pitchFamily="34" charset="-122"/>
+                <a:cs typeface="Leelawadee UI" pitchFamily="34" charset="-120"/>
+              </a:rPr>
+              <a:t>กลุ่มอุตสาหกรรมที่ครอบคลุม</a:t>
             </a:r>
             <a:endParaRPr lang="en-US" sz="1200" dirty="0"/>
           </a:p>
@@ -11417,7 +11419,7 @@
         <p:spPr>
           <a:xfrm>
             <a:off x="548640" y="4572000"/>
-            <a:ext cx="1325880" cy="411480"/>
+            <a:ext cx="1527048" cy="411480"/>
           </a:xfrm>
           <a:prstGeom prst="roundRect">
             <a:avLst>
@@ -11439,7 +11441,7 @@
         <p:spPr>
           <a:xfrm>
             <a:off x="548640" y="4572000"/>
-            <a:ext cx="1325880" cy="411480"/>
+            <a:ext cx="1527048" cy="411480"/>
           </a:xfrm>
           <a:prstGeom prst="rect">
             <a:avLst/>
@@ -11459,11 +11461,11 @@
                 <a:solidFill>
                   <a:srgbClr val="F5F5F5"/>
                 </a:solidFill>
-                <a:latin typeface="Calibri" pitchFamily="34" charset="0"/>
-                <a:ea typeface="Calibri" pitchFamily="34" charset="-122"/>
-                <a:cs typeface="Calibri" pitchFamily="34" charset="-120"/>
-              </a:rPr>
-              <a:t>Technology</a:t>
+                <a:latin typeface="Leelawadee UI" pitchFamily="34" charset="0"/>
+                <a:ea typeface="Leelawadee UI" pitchFamily="34" charset="-122"/>
+                <a:cs typeface="Leelawadee UI" pitchFamily="34" charset="-120"/>
+              </a:rPr>
+              <a:t>เทคโนโลยี</a:t>
             </a:r>
             <a:endParaRPr lang="en-US" sz="1200" dirty="0"/>
           </a:p>
@@ -11477,8 +11479,8 @@
         </p:nvSpPr>
         <p:spPr>
           <a:xfrm>
-            <a:off x="2057400" y="4572000"/>
-            <a:ext cx="1024128" cy="411480"/>
+            <a:off x="2258568" y="4572000"/>
+            <a:ext cx="1289304" cy="411480"/>
           </a:xfrm>
           <a:prstGeom prst="roundRect">
             <a:avLst>
@@ -11499,8 +11501,8 @@
         </p:nvSpPr>
         <p:spPr>
           <a:xfrm>
-            <a:off x="2057400" y="4572000"/>
-            <a:ext cx="1024128" cy="411480"/>
+            <a:off x="2258568" y="4572000"/>
+            <a:ext cx="1289304" cy="411480"/>
           </a:xfrm>
           <a:prstGeom prst="rect">
             <a:avLst/>
@@ -11520,11 +11522,11 @@
                 <a:solidFill>
                   <a:srgbClr val="F5F5F5"/>
                 </a:solidFill>
-                <a:latin typeface="Calibri" pitchFamily="34" charset="0"/>
-                <a:ea typeface="Calibri" pitchFamily="34" charset="-122"/>
-                <a:cs typeface="Calibri" pitchFamily="34" charset="-120"/>
-              </a:rPr>
-              <a:t>Finance</a:t>
+                <a:latin typeface="Leelawadee UI" pitchFamily="34" charset="0"/>
+                <a:ea typeface="Leelawadee UI" pitchFamily="34" charset="-122"/>
+                <a:cs typeface="Leelawadee UI" pitchFamily="34" charset="-120"/>
+              </a:rPr>
+              <a:t>การเงิน</a:t>
             </a:r>
             <a:endParaRPr lang="en-US" sz="1200" dirty="0"/>
           </a:p>
@@ -11538,8 +11540,8 @@
         </p:nvSpPr>
         <p:spPr>
           <a:xfrm>
-            <a:off x="3264408" y="4572000"/>
-            <a:ext cx="923544" cy="411480"/>
+            <a:off x="3730752" y="4572000"/>
+            <a:ext cx="1289304" cy="411480"/>
           </a:xfrm>
           <a:prstGeom prst="roundRect">
             <a:avLst>
@@ -11560,8 +11562,8 @@
         </p:nvSpPr>
         <p:spPr>
           <a:xfrm>
-            <a:off x="3264408" y="4572000"/>
-            <a:ext cx="923544" cy="411480"/>
+            <a:off x="3730752" y="4572000"/>
+            <a:ext cx="1289304" cy="411480"/>
           </a:xfrm>
           <a:prstGeom prst="rect">
             <a:avLst/>
@@ -11581,11 +11583,11 @@
                 <a:solidFill>
                   <a:srgbClr val="F5F5F5"/>
                 </a:solidFill>
-                <a:latin typeface="Calibri" pitchFamily="34" charset="0"/>
-                <a:ea typeface="Calibri" pitchFamily="34" charset="-122"/>
-                <a:cs typeface="Calibri" pitchFamily="34" charset="-120"/>
-              </a:rPr>
-              <a:t>Energy</a:t>
+                <a:latin typeface="Leelawadee UI" pitchFamily="34" charset="0"/>
+                <a:ea typeface="Leelawadee UI" pitchFamily="34" charset="-122"/>
+                <a:cs typeface="Leelawadee UI" pitchFamily="34" charset="-120"/>
+              </a:rPr>
+              <a:t>พลังงาน</a:t>
             </a:r>
             <a:endParaRPr lang="en-US" sz="1200" dirty="0"/>
           </a:p>
@@ -11599,8 +11601,8 @@
         </p:nvSpPr>
         <p:spPr>
           <a:xfrm>
-            <a:off x="4370832" y="4572000"/>
-            <a:ext cx="1325880" cy="411480"/>
+            <a:off x="5202936" y="4572000"/>
+            <a:ext cx="1170432" cy="411480"/>
           </a:xfrm>
           <a:prstGeom prst="roundRect">
             <a:avLst>
@@ -11621,8 +11623,8 @@
         </p:nvSpPr>
         <p:spPr>
           <a:xfrm>
-            <a:off x="4370832" y="4572000"/>
-            <a:ext cx="1325880" cy="411480"/>
+            <a:off x="5202936" y="4572000"/>
+            <a:ext cx="1170432" cy="411480"/>
           </a:xfrm>
           <a:prstGeom prst="rect">
             <a:avLst/>
@@ -11642,11 +11644,11 @@
                 <a:solidFill>
                   <a:srgbClr val="F5F5F5"/>
                 </a:solidFill>
-                <a:latin typeface="Calibri" pitchFamily="34" charset="0"/>
-                <a:ea typeface="Calibri" pitchFamily="34" charset="-122"/>
-                <a:cs typeface="Calibri" pitchFamily="34" charset="-120"/>
-              </a:rPr>
-              <a:t>Healthcare</a:t>
+                <a:latin typeface="Leelawadee UI" pitchFamily="34" charset="0"/>
+                <a:ea typeface="Leelawadee UI" pitchFamily="34" charset="-122"/>
+                <a:cs typeface="Leelawadee UI" pitchFamily="34" charset="-120"/>
+              </a:rPr>
+              <a:t>สุขภาพ</a:t>
             </a:r>
             <a:endParaRPr lang="en-US" sz="1200" dirty="0"/>
           </a:p>
@@ -11661,7 +11663,7 @@
         <p:spPr>
           <a:xfrm>
             <a:off x="548640" y="5120640"/>
-            <a:ext cx="1124712" cy="411480"/>
+            <a:ext cx="2596896" cy="411480"/>
           </a:xfrm>
           <a:prstGeom prst="roundRect">
             <a:avLst>
@@ -11683,7 +11685,7 @@
         <p:spPr>
           <a:xfrm>
             <a:off x="548640" y="5120640"/>
-            <a:ext cx="1124712" cy="411480"/>
+            <a:ext cx="2596896" cy="411480"/>
           </a:xfrm>
           <a:prstGeom prst="rect">
             <a:avLst/>
@@ -11703,11 +11705,11 @@
                 <a:solidFill>
                   <a:srgbClr val="F5F5F5"/>
                 </a:solidFill>
-                <a:latin typeface="Calibri" pitchFamily="34" charset="0"/>
-                <a:ea typeface="Calibri" pitchFamily="34" charset="-122"/>
-                <a:cs typeface="Calibri" pitchFamily="34" charset="-120"/>
-              </a:rPr>
-              <a:t>Consumer</a:t>
+                <a:latin typeface="Leelawadee UI" pitchFamily="34" charset="0"/>
+                <a:ea typeface="Leelawadee UI" pitchFamily="34" charset="-122"/>
+                <a:cs typeface="Leelawadee UI" pitchFamily="34" charset="-120"/>
+              </a:rPr>
+              <a:t>สินค้าอุปโภคบริโภค</a:t>
             </a:r>
             <a:endParaRPr lang="en-US" sz="1200" dirty="0"/>
           </a:p>
@@ -11721,8 +11723,8 @@
         </p:nvSpPr>
         <p:spPr>
           <a:xfrm>
-            <a:off x="1856232" y="5120640"/>
-            <a:ext cx="822960" cy="411480"/>
+            <a:off x="3328416" y="5120640"/>
+            <a:ext cx="1883664" cy="411480"/>
           </a:xfrm>
           <a:prstGeom prst="roundRect">
             <a:avLst>
@@ -11743,8 +11745,8 @@
         </p:nvSpPr>
         <p:spPr>
           <a:xfrm>
-            <a:off x="1856232" y="5120640"/>
-            <a:ext cx="822960" cy="411480"/>
+            <a:off x="3328416" y="5120640"/>
+            <a:ext cx="1883664" cy="411480"/>
           </a:xfrm>
           <a:prstGeom prst="rect">
             <a:avLst/>
@@ -11764,11 +11766,11 @@
                 <a:solidFill>
                   <a:srgbClr val="F5F5F5"/>
                 </a:solidFill>
-                <a:latin typeface="Calibri" pitchFamily="34" charset="0"/>
-                <a:ea typeface="Calibri" pitchFamily="34" charset="-122"/>
-                <a:cs typeface="Calibri" pitchFamily="34" charset="-120"/>
-              </a:rPr>
-              <a:t>Media</a:t>
+                <a:latin typeface="Leelawadee UI" pitchFamily="34" charset="0"/>
+                <a:ea typeface="Leelawadee UI" pitchFamily="34" charset="-122"/>
+                <a:cs typeface="Leelawadee UI" pitchFamily="34" charset="-120"/>
+              </a:rPr>
+              <a:t>สื่อ/บันเทิง</a:t>
             </a:r>
             <a:endParaRPr lang="en-US" sz="1200" dirty="0"/>
           </a:p>
@@ -11832,11 +11834,11 @@
                 <a:solidFill>
                   <a:srgbClr val="9AA5B1"/>
                 </a:solidFill>
-                <a:latin typeface="Calibri" pitchFamily="34" charset="0"/>
-                <a:ea typeface="Calibri" pitchFamily="34" charset="-122"/>
-                <a:cs typeface="Calibri" pitchFamily="34" charset="-120"/>
-              </a:rPr>
-              <a:t>EXAMPLE TICKERS</a:t>
+                <a:latin typeface="Leelawadee UI" pitchFamily="34" charset="0"/>
+                <a:ea typeface="Leelawadee UI" pitchFamily="34" charset="-122"/>
+                <a:cs typeface="Leelawadee UI" pitchFamily="34" charset="-120"/>
+              </a:rPr>
+              <a:t>ตัวอย่างหุ้นที่ใช้</a:t>
             </a:r>
             <a:endParaRPr lang="en-US" sz="1100" dirty="0"/>
           </a:p>
@@ -11973,11 +11975,11 @@
                 <a:solidFill>
                   <a:srgbClr val="9AA5B1"/>
                 </a:solidFill>
-                <a:latin typeface="Calibri" pitchFamily="34" charset="0"/>
-                <a:ea typeface="Calibri" pitchFamily="34" charset="-122"/>
-                <a:cs typeface="Calibri" pitchFamily="34" charset="-120"/>
-              </a:rPr>
-              <a:t>Multiple sectors, not one stock — reduces the risk of learning one company's quirks instead of general indicator behavior.</a:t>
+                <a:latin typeface="Leelawadee UI" pitchFamily="34" charset="0"/>
+                <a:ea typeface="Leelawadee UI" pitchFamily="34" charset="-122"/>
+                <a:cs typeface="Leelawadee UI" pitchFamily="34" charset="-120"/>
+              </a:rPr>
+              <a:t>หลายอุตสาหกรรม ไม่ใช่หุ้นเดียว — ลดความเสี่ยงที่โมเดลจะเรียนรู้พฤติกรรมเฉพาะของบริษัทเดียว แทนที่จะเป็นพฤติกรรมทั่วไปของอินดิเคเตอร์</a:t>
             </a:r>
             <a:endParaRPr lang="en-US" sz="1200" dirty="0"/>
           </a:p>
@@ -12044,9 +12046,9 @@
                 <a:solidFill>
                   <a:srgbClr val="5B6B7C"/>
                 </a:solidFill>
-                <a:latin typeface="Calibri" pitchFamily="34" charset="0"/>
-                <a:ea typeface="Calibri" pitchFamily="34" charset="-122"/>
-                <a:cs typeface="Calibri" pitchFamily="34" charset="-120"/>
+                <a:latin typeface="Leelawadee UI" pitchFamily="34" charset="0"/>
+                <a:ea typeface="Leelawadee UI" pitchFamily="34" charset="-122"/>
+                <a:cs typeface="Leelawadee UI" pitchFamily="34" charset="-120"/>
               </a:rPr>
               <a:t>6</a:t>
             </a:r>
@@ -12083,9 +12085,9 @@
                 <a:solidFill>
                   <a:srgbClr val="5B6B7C"/>
                 </a:solidFill>
-                <a:latin typeface="Calibri" pitchFamily="34" charset="0"/>
-                <a:ea typeface="Calibri" pitchFamily="34" charset="-122"/>
-                <a:cs typeface="Calibri" pitchFamily="34" charset="-120"/>
+                <a:latin typeface="Leelawadee UI" pitchFamily="34" charset="0"/>
+                <a:ea typeface="Leelawadee UI" pitchFamily="34" charset="-122"/>
+                <a:cs typeface="Leelawadee UI" pitchFamily="34" charset="-120"/>
               </a:rPr>
               <a:t>Stockscope AI · CP020003</a:t>
             </a:r>
@@ -12122,11 +12124,11 @@
                 <a:solidFill>
                   <a:srgbClr val="A3E635"/>
                 </a:solidFill>
-                <a:latin typeface="Calibri" pitchFamily="34" charset="0"/>
-                <a:ea typeface="Calibri" pitchFamily="34" charset="-122"/>
-                <a:cs typeface="Calibri" pitchFamily="34" charset="-120"/>
-              </a:rPr>
-              <a:t>METHODOLOGY</a:t>
+                <a:latin typeface="Leelawadee UI" pitchFamily="34" charset="0"/>
+                <a:ea typeface="Leelawadee UI" pitchFamily="34" charset="-122"/>
+                <a:cs typeface="Leelawadee UI" pitchFamily="34" charset="-120"/>
+              </a:rPr>
+              <a:t>ระเบียบวิธี</a:t>
             </a:r>
             <a:endParaRPr lang="en-US" sz="1300" dirty="0"/>
           </a:p>
@@ -12161,11 +12163,11 @@
                 <a:solidFill>
                   <a:srgbClr val="F5F5F5"/>
                 </a:solidFill>
-                <a:latin typeface="Cambria" pitchFamily="34" charset="0"/>
-                <a:ea typeface="Cambria" pitchFamily="34" charset="-122"/>
-                <a:cs typeface="Cambria" pitchFamily="34" charset="-120"/>
-              </a:rPr>
-              <a:t>Features — What the Model Sees</a:t>
+                <a:latin typeface="Leelawadee UI" pitchFamily="34" charset="0"/>
+                <a:ea typeface="Leelawadee UI" pitchFamily="34" charset="-122"/>
+                <a:cs typeface="Leelawadee UI" pitchFamily="34" charset="-120"/>
+              </a:rPr>
+              <a:t>ฟีเจอร์ — สิ่งที่โมเดลมองเห็น</a:t>
             </a:r>
             <a:endParaRPr lang="en-US" sz="3200" dirty="0"/>
           </a:p>
@@ -12273,9 +12275,9 @@
                 <a:solidFill>
                   <a:srgbClr val="F5F5F5"/>
                 </a:solidFill>
-                <a:latin typeface="Calibri" pitchFamily="34" charset="0"/>
-                <a:ea typeface="Calibri" pitchFamily="34" charset="-122"/>
-                <a:cs typeface="Calibri" pitchFamily="34" charset="-120"/>
+                <a:latin typeface="Leelawadee UI" pitchFamily="34" charset="0"/>
+                <a:ea typeface="Leelawadee UI" pitchFamily="34" charset="-122"/>
+                <a:cs typeface="Leelawadee UI" pitchFamily="34" charset="-120"/>
               </a:rPr>
               <a:t>ret_1d / 5d / 10d / 21d</a:t>
             </a:r>
@@ -12312,11 +12314,11 @@
                 <a:solidFill>
                   <a:srgbClr val="9AA5B1"/>
                 </a:solidFill>
-                <a:latin typeface="Calibri" pitchFamily="34" charset="0"/>
-                <a:ea typeface="Calibri" pitchFamily="34" charset="-122"/>
-                <a:cs typeface="Calibri" pitchFamily="34" charset="-120"/>
-              </a:rPr>
-              <a:t>Past return, 1–21 trading days (momentum)</a:t>
+                <a:latin typeface="Leelawadee UI" pitchFamily="34" charset="0"/>
+                <a:ea typeface="Leelawadee UI" pitchFamily="34" charset="-122"/>
+                <a:cs typeface="Leelawadee UI" pitchFamily="34" charset="-120"/>
+              </a:rPr>
+              <a:t>ผลตอบแทนย้อนหลัง 1–21 วันทำการ (โมเมนตัม)</a:t>
             </a:r>
             <a:endParaRPr lang="en-US" sz="1100" dirty="0"/>
           </a:p>
@@ -12424,9 +12426,9 @@
                 <a:solidFill>
                   <a:srgbClr val="F5F5F5"/>
                 </a:solidFill>
-                <a:latin typeface="Calibri" pitchFamily="34" charset="0"/>
-                <a:ea typeface="Calibri" pitchFamily="34" charset="-122"/>
-                <a:cs typeface="Calibri" pitchFamily="34" charset="-120"/>
+                <a:latin typeface="Leelawadee UI" pitchFamily="34" charset="0"/>
+                <a:ea typeface="Leelawadee UI" pitchFamily="34" charset="-122"/>
+                <a:cs typeface="Leelawadee UI" pitchFamily="34" charset="-120"/>
               </a:rPr>
               <a:t>rsi14</a:t>
             </a:r>
@@ -12463,11 +12465,11 @@
                 <a:solidFill>
                   <a:srgbClr val="9AA5B1"/>
                 </a:solidFill>
-                <a:latin typeface="Calibri" pitchFamily="34" charset="0"/>
-                <a:ea typeface="Calibri" pitchFamily="34" charset="-122"/>
-                <a:cs typeface="Calibri" pitchFamily="34" charset="-120"/>
-              </a:rPr>
-              <a:t>14-day RSI — overbought vs. oversold</a:t>
+                <a:latin typeface="Leelawadee UI" pitchFamily="34" charset="0"/>
+                <a:ea typeface="Leelawadee UI" pitchFamily="34" charset="-122"/>
+                <a:cs typeface="Leelawadee UI" pitchFamily="34" charset="-120"/>
+              </a:rPr>
+              <a:t>RSI 14 วัน — ซื้อมากไปหรือขายมากไป</a:t>
             </a:r>
             <a:endParaRPr lang="en-US" sz="1100" dirty="0"/>
           </a:p>
@@ -12575,9 +12577,9 @@
                 <a:solidFill>
                   <a:srgbClr val="F5F5F5"/>
                 </a:solidFill>
-                <a:latin typeface="Calibri" pitchFamily="34" charset="0"/>
-                <a:ea typeface="Calibri" pitchFamily="34" charset="-122"/>
-                <a:cs typeface="Calibri" pitchFamily="34" charset="-120"/>
+                <a:latin typeface="Leelawadee UI" pitchFamily="34" charset="0"/>
+                <a:ea typeface="Leelawadee UI" pitchFamily="34" charset="-122"/>
+                <a:cs typeface="Leelawadee UI" pitchFamily="34" charset="-120"/>
               </a:rPr>
               <a:t>macd_hist</a:t>
             </a:r>
@@ -12614,11 +12616,11 @@
                 <a:solidFill>
                   <a:srgbClr val="9AA5B1"/>
                 </a:solidFill>
-                <a:latin typeface="Calibri" pitchFamily="34" charset="0"/>
-                <a:ea typeface="Calibri" pitchFamily="34" charset="-122"/>
-                <a:cs typeface="Calibri" pitchFamily="34" charset="-120"/>
-              </a:rPr>
-              <a:t>MACD histogram (trend strength &amp; direction)</a:t>
+                <a:latin typeface="Leelawadee UI" pitchFamily="34" charset="0"/>
+                <a:ea typeface="Leelawadee UI" pitchFamily="34" charset="-122"/>
+                <a:cs typeface="Leelawadee UI" pitchFamily="34" charset="-120"/>
+              </a:rPr>
+              <a:t>MACD Histogram (ความแรง &amp; ทิศทางเทรนด์)</a:t>
             </a:r>
             <a:endParaRPr lang="en-US" sz="1100" dirty="0"/>
           </a:p>
@@ -12726,9 +12728,9 @@
                 <a:solidFill>
                   <a:srgbClr val="F5F5F5"/>
                 </a:solidFill>
-                <a:latin typeface="Calibri" pitchFamily="34" charset="0"/>
-                <a:ea typeface="Calibri" pitchFamily="34" charset="-122"/>
-                <a:cs typeface="Calibri" pitchFamily="34" charset="-120"/>
+                <a:latin typeface="Leelawadee UI" pitchFamily="34" charset="0"/>
+                <a:ea typeface="Leelawadee UI" pitchFamily="34" charset="-122"/>
+                <a:cs typeface="Leelawadee UI" pitchFamily="34" charset="-120"/>
               </a:rPr>
               <a:t>dist_sma20 / dist_sma50</a:t>
             </a:r>
@@ -12765,11 +12767,11 @@
                 <a:solidFill>
                   <a:srgbClr val="9AA5B1"/>
                 </a:solidFill>
-                <a:latin typeface="Calibri" pitchFamily="34" charset="0"/>
-                <a:ea typeface="Calibri" pitchFamily="34" charset="-122"/>
-                <a:cs typeface="Calibri" pitchFamily="34" charset="-120"/>
-              </a:rPr>
-              <a:t>% distance from the 20/50-day moving average</a:t>
+                <a:latin typeface="Leelawadee UI" pitchFamily="34" charset="0"/>
+                <a:ea typeface="Leelawadee UI" pitchFamily="34" charset="-122"/>
+                <a:cs typeface="Leelawadee UI" pitchFamily="34" charset="-120"/>
+              </a:rPr>
+              <a:t>% ระยะห่างจากเส้นค่าเฉลี่ย 20/50 วัน</a:t>
             </a:r>
             <a:endParaRPr lang="en-US" sz="1100" dirty="0"/>
           </a:p>
@@ -12877,9 +12879,9 @@
                 <a:solidFill>
                   <a:srgbClr val="F5F5F5"/>
                 </a:solidFill>
-                <a:latin typeface="Calibri" pitchFamily="34" charset="0"/>
-                <a:ea typeface="Calibri" pitchFamily="34" charset="-122"/>
-                <a:cs typeface="Calibri" pitchFamily="34" charset="-120"/>
+                <a:latin typeface="Leelawadee UI" pitchFamily="34" charset="0"/>
+                <a:ea typeface="Leelawadee UI" pitchFamily="34" charset="-122"/>
+                <a:cs typeface="Leelawadee UI" pitchFamily="34" charset="-120"/>
               </a:rPr>
               <a:t>vol_ratio</a:t>
             </a:r>
@@ -12916,11 +12918,11 @@
                 <a:solidFill>
                   <a:srgbClr val="9AA5B1"/>
                 </a:solidFill>
-                <a:latin typeface="Calibri" pitchFamily="34" charset="0"/>
-                <a:ea typeface="Calibri" pitchFamily="34" charset="-122"/>
-                <a:cs typeface="Calibri" pitchFamily="34" charset="-120"/>
-              </a:rPr>
-              <a:t>Today's volume vs. its 20-day average</a:t>
+                <a:latin typeface="Leelawadee UI" pitchFamily="34" charset="0"/>
+                <a:ea typeface="Leelawadee UI" pitchFamily="34" charset="-122"/>
+                <a:cs typeface="Leelawadee UI" pitchFamily="34" charset="-120"/>
+              </a:rPr>
+              <a:t>ปริมาณซื้อขายวันนี้ เทียบค่าเฉลี่ย 20 วัน</a:t>
             </a:r>
             <a:endParaRPr lang="en-US" sz="1100" dirty="0"/>
           </a:p>
@@ -13028,9 +13030,9 @@
                 <a:solidFill>
                   <a:srgbClr val="F5F5F5"/>
                 </a:solidFill>
-                <a:latin typeface="Calibri" pitchFamily="34" charset="0"/>
-                <a:ea typeface="Calibri" pitchFamily="34" charset="-122"/>
-                <a:cs typeface="Calibri" pitchFamily="34" charset="-120"/>
+                <a:latin typeface="Leelawadee UI" pitchFamily="34" charset="0"/>
+                <a:ea typeface="Leelawadee UI" pitchFamily="34" charset="-122"/>
+                <a:cs typeface="Leelawadee UI" pitchFamily="34" charset="-120"/>
               </a:rPr>
               <a:t>volatility_20d</a:t>
             </a:r>
@@ -13067,11 +13069,11 @@
                 <a:solidFill>
                   <a:srgbClr val="9AA5B1"/>
                 </a:solidFill>
-                <a:latin typeface="Calibri" pitchFamily="34" charset="0"/>
-                <a:ea typeface="Calibri" pitchFamily="34" charset="-122"/>
-                <a:cs typeface="Calibri" pitchFamily="34" charset="-120"/>
-              </a:rPr>
-              <a:t>Rolling std-dev of daily returns (choppiness)</a:t>
+                <a:latin typeface="Leelawadee UI" pitchFamily="34" charset="0"/>
+                <a:ea typeface="Leelawadee UI" pitchFamily="34" charset="-122"/>
+                <a:cs typeface="Leelawadee UI" pitchFamily="34" charset="-120"/>
+              </a:rPr>
+              <a:t>ส่วนเบี่ยงเบนมาตรฐานผลตอบแทนรายวัน (ความผันผวน)</a:t>
             </a:r>
             <a:endParaRPr lang="en-US" sz="1100" dirty="0"/>
           </a:p>
@@ -13106,11 +13108,11 @@
                 <a:solidFill>
                   <a:srgbClr val="9AA5B1"/>
                 </a:solidFill>
-                <a:latin typeface="Calibri" pitchFamily="34" charset="0"/>
-                <a:ea typeface="Calibri" pitchFamily="34" charset="-122"/>
-                <a:cs typeface="Calibri" pitchFamily="34" charset="-120"/>
-              </a:rPr>
-              <a:t>All computed with rolling / ewm windows that only look backward in time — the anti-leakage design continues on the next slide.</a:t>
+                <a:latin typeface="Leelawadee UI" pitchFamily="34" charset="0"/>
+                <a:ea typeface="Leelawadee UI" pitchFamily="34" charset="-122"/>
+                <a:cs typeface="Leelawadee UI" pitchFamily="34" charset="-120"/>
+              </a:rPr>
+              <a:t>คำนวณด้วยหน้าต่างข้อมูลย้อนหลังเท่านั้น (rolling / ewm) — เรื่องการออกแบบป้องกันข้อมูลรั่วไหลต่อในสไลด์ถัดไป</a:t>
             </a:r>
             <a:endParaRPr lang="en-US" sz="1200" dirty="0"/>
           </a:p>
@@ -13177,9 +13179,9 @@
                 <a:solidFill>
                   <a:srgbClr val="5B6B7C"/>
                 </a:solidFill>
-                <a:latin typeface="Calibri" pitchFamily="34" charset="0"/>
-                <a:ea typeface="Calibri" pitchFamily="34" charset="-122"/>
-                <a:cs typeface="Calibri" pitchFamily="34" charset="-120"/>
+                <a:latin typeface="Leelawadee UI" pitchFamily="34" charset="0"/>
+                <a:ea typeface="Leelawadee UI" pitchFamily="34" charset="-122"/>
+                <a:cs typeface="Leelawadee UI" pitchFamily="34" charset="-120"/>
               </a:rPr>
               <a:t>7</a:t>
             </a:r>
@@ -13216,9 +13218,9 @@
                 <a:solidFill>
                   <a:srgbClr val="5B6B7C"/>
                 </a:solidFill>
-                <a:latin typeface="Calibri" pitchFamily="34" charset="0"/>
-                <a:ea typeface="Calibri" pitchFamily="34" charset="-122"/>
-                <a:cs typeface="Calibri" pitchFamily="34" charset="-120"/>
+                <a:latin typeface="Leelawadee UI" pitchFamily="34" charset="0"/>
+                <a:ea typeface="Leelawadee UI" pitchFamily="34" charset="-122"/>
+                <a:cs typeface="Leelawadee UI" pitchFamily="34" charset="-120"/>
               </a:rPr>
               <a:t>Stockscope AI · CP020003</a:t>
             </a:r>
@@ -13255,11 +13257,11 @@
                 <a:solidFill>
                   <a:srgbClr val="A3E635"/>
                 </a:solidFill>
-                <a:latin typeface="Calibri" pitchFamily="34" charset="0"/>
-                <a:ea typeface="Calibri" pitchFamily="34" charset="-122"/>
-                <a:cs typeface="Calibri" pitchFamily="34" charset="-120"/>
-              </a:rPr>
-              <a:t>METHODOLOGY</a:t>
+                <a:latin typeface="Leelawadee UI" pitchFamily="34" charset="0"/>
+                <a:ea typeface="Leelawadee UI" pitchFamily="34" charset="-122"/>
+                <a:cs typeface="Leelawadee UI" pitchFamily="34" charset="-120"/>
+              </a:rPr>
+              <a:t>ระเบียบวิธี</a:t>
             </a:r>
             <a:endParaRPr lang="en-US" sz="1300" dirty="0"/>
           </a:p>
@@ -13294,11 +13296,11 @@
                 <a:solidFill>
                   <a:srgbClr val="F5F5F5"/>
                 </a:solidFill>
-                <a:latin typeface="Cambria" pitchFamily="34" charset="0"/>
-                <a:ea typeface="Cambria" pitchFamily="34" charset="-122"/>
-                <a:cs typeface="Cambria" pitchFamily="34" charset="-120"/>
-              </a:rPr>
-              <a:t>Avoiding Data Leakage</a:t>
+                <a:latin typeface="Leelawadee UI" pitchFamily="34" charset="0"/>
+                <a:ea typeface="Leelawadee UI" pitchFamily="34" charset="-122"/>
+                <a:cs typeface="Leelawadee UI" pitchFamily="34" charset="-120"/>
+              </a:rPr>
+              <a:t>ป้องกันข้อมูลรั่วไหล (Data Leakage)</a:t>
             </a:r>
             <a:endParaRPr lang="en-US" sz="3200" dirty="0"/>
           </a:p>
@@ -13313,7 +13315,7 @@
         <p:spPr>
           <a:xfrm>
             <a:off x="548640" y="1234440"/>
-            <a:ext cx="10972800" cy="365760"/>
+            <a:ext cx="11064240" cy="365760"/>
           </a:xfrm>
           <a:prstGeom prst="rect">
             <a:avLst/>
@@ -13333,11 +13335,11 @@
                 <a:solidFill>
                   <a:srgbClr val="A3E635"/>
                 </a:solidFill>
-                <a:latin typeface="Calibri" pitchFamily="34" charset="0"/>
-                <a:ea typeface="Calibri" pitchFamily="34" charset="-122"/>
-                <a:cs typeface="Calibri" pitchFamily="34" charset="-120"/>
-              </a:rPr>
-              <a:t>Our core design decision — directly targets “leakage-free, well-justified methodology” in the grading rubric.</a:t>
+                <a:latin typeface="Leelawadee UI" pitchFamily="34" charset="0"/>
+                <a:ea typeface="Leelawadee UI" pitchFamily="34" charset="-122"/>
+                <a:cs typeface="Leelawadee UI" pitchFamily="34" charset="-120"/>
+              </a:rPr>
+              <a:t>การตัดสินใจออกแบบที่สำคัญที่สุด — ตรงกับเกณฑ์ “ระเบียบวิธีไม่รั่วไหลข้อมูล มีเหตุผลรองรับ” ในเกณฑ์การให้คะแนน</a:t>
             </a:r>
             <a:endParaRPr lang="en-US" sz="1300" dirty="0"/>
           </a:p>
@@ -13425,11 +13427,11 @@
                 <a:solidFill>
                   <a:srgbClr val="FF6B6B"/>
                 </a:solidFill>
-                <a:latin typeface="Calibri" pitchFamily="34" charset="0"/>
-                <a:ea typeface="Calibri" pitchFamily="34" charset="-122"/>
-                <a:cs typeface="Calibri" pitchFamily="34" charset="-120"/>
-              </a:rPr>
-              <a:t>Random 80/20 row split</a:t>
+                <a:latin typeface="Leelawadee UI" pitchFamily="34" charset="0"/>
+                <a:ea typeface="Leelawadee UI" pitchFamily="34" charset="-122"/>
+                <a:cs typeface="Leelawadee UI" pitchFamily="34" charset="-120"/>
+              </a:rPr>
+              <a:t>แบ่งข้อมูลแบบสุ่ม 80/20</a:t>
             </a:r>
             <a:endParaRPr lang="en-US" sz="1600" dirty="0"/>
           </a:p>
@@ -13464,11 +13466,11 @@
                 <a:solidFill>
                   <a:srgbClr val="9AA5B1"/>
                 </a:solidFill>
-                <a:latin typeface="Calibri" pitchFamily="34" charset="0"/>
-                <a:ea typeface="Calibri" pitchFamily="34" charset="-122"/>
-                <a:cs typeface="Calibri" pitchFamily="34" charset="-120"/>
-              </a:rPr>
-              <a:t>Rows from the same week end up on both sides. Indicators are autocorrelated — the model partly memorizes the test period instead of generalizing.</a:t>
+                <a:latin typeface="Leelawadee UI" pitchFamily="34" charset="0"/>
+                <a:ea typeface="Leelawadee UI" pitchFamily="34" charset="-122"/>
+                <a:cs typeface="Leelawadee UI" pitchFamily="34" charset="-120"/>
+              </a:rPr>
+              <a:t>ข้อมูลสัปดาห์เดียวกันหลุดไปอยู่ทั้งฝั่ง train และ test อินดิเคเตอร์มีความสัมพันธ์กันในตัวเอง (autocorrelated) — โมเดลจะจำช่วง test แทนที่จะเรียนรู้ภาพรวม</a:t>
             </a:r>
             <a:endParaRPr lang="en-US" sz="1300" dirty="0"/>
           </a:p>
@@ -13556,11 +13558,11 @@
                 <a:solidFill>
                   <a:srgbClr val="A3E635"/>
                 </a:solidFill>
-                <a:latin typeface="Calibri" pitchFamily="34" charset="0"/>
-                <a:ea typeface="Calibri" pitchFamily="34" charset="-122"/>
-                <a:cs typeface="Calibri" pitchFamily="34" charset="-120"/>
-              </a:rPr>
-              <a:t>Single global date cutoff</a:t>
+                <a:latin typeface="Leelawadee UI" pitchFamily="34" charset="0"/>
+                <a:ea typeface="Leelawadee UI" pitchFamily="34" charset="-122"/>
+                <a:cs typeface="Leelawadee UI" pitchFamily="34" charset="-120"/>
+              </a:rPr>
+              <a:t>ตัดข้อมูลตามวันที่เดียวทั้งชุด</a:t>
             </a:r>
             <a:endParaRPr lang="en-US" sz="1600" dirty="0"/>
           </a:p>
@@ -13595,11 +13597,11 @@
                 <a:solidFill>
                   <a:srgbClr val="F5F5F5"/>
                 </a:solidFill>
-                <a:latin typeface="Calibri" pitchFamily="34" charset="0"/>
-                <a:ea typeface="Calibri" pitchFamily="34" charset="-122"/>
-                <a:cs typeface="Calibri" pitchFamily="34" charset="-120"/>
-              </a:rPr>
-              <a:t>Every training row happens strictly before every test row, across all 20 tickers at once — mimicking real deployment: train on the past, evaluate on the unseen future.</a:t>
+                <a:latin typeface="Leelawadee UI" pitchFamily="34" charset="0"/>
+                <a:ea typeface="Leelawadee UI" pitchFamily="34" charset="-122"/>
+                <a:cs typeface="Leelawadee UI" pitchFamily="34" charset="-120"/>
+              </a:rPr>
+              <a:t>ทุกแถวของ train เกิดก่อนทุกแถวของ test เสมอ ทั้ง 20 หุ้นพร้อมกัน — เลียนแบบการใช้งานจริง: เทรนจากอดีต ทดสอบกับอนาคตที่ยังไม่เคยเห็น</a:t>
             </a:r>
             <a:endParaRPr lang="en-US" sz="1300" dirty="0"/>
           </a:p>
@@ -13634,9 +13636,9 @@
                 <a:solidFill>
                   <a:srgbClr val="9AA5B1"/>
                 </a:solidFill>
-                <a:latin typeface="Calibri" pitchFamily="34" charset="0"/>
-                <a:ea typeface="Calibri" pitchFamily="34" charset="-122"/>
-                <a:cs typeface="Calibri" pitchFamily="34" charset="-120"/>
+                <a:latin typeface="Leelawadee UI" pitchFamily="34" charset="0"/>
+                <a:ea typeface="Leelawadee UI" pitchFamily="34" charset="-122"/>
+                <a:cs typeface="Leelawadee UI" pitchFamily="34" charset="-120"/>
               </a:rPr>
               <a:t>2021</a:t>
             </a:r>
@@ -13673,9 +13675,9 @@
                 <a:solidFill>
                   <a:srgbClr val="9AA5B1"/>
                 </a:solidFill>
-                <a:latin typeface="Calibri" pitchFamily="34" charset="0"/>
-                <a:ea typeface="Calibri" pitchFamily="34" charset="-122"/>
-                <a:cs typeface="Calibri" pitchFamily="34" charset="-120"/>
+                <a:latin typeface="Leelawadee UI" pitchFamily="34" charset="0"/>
+                <a:ea typeface="Leelawadee UI" pitchFamily="34" charset="-122"/>
+                <a:cs typeface="Leelawadee UI" pitchFamily="34" charset="-120"/>
               </a:rPr>
               <a:t>2026</a:t>
             </a:r>
@@ -13756,11 +13758,11 @@
                 <a:solidFill>
                   <a:srgbClr val="0A0E14"/>
                 </a:solidFill>
-                <a:latin typeface="Calibri" pitchFamily="34" charset="0"/>
-                <a:ea typeface="Calibri" pitchFamily="34" charset="-122"/>
-                <a:cs typeface="Calibri" pitchFamily="34" charset="-120"/>
-              </a:rPr>
-              <a:t>TRAIN  —  19,280 rows  (2021–10 → 2025–10)</a:t>
+                <a:latin typeface="Leelawadee UI" pitchFamily="34" charset="0"/>
+                <a:ea typeface="Leelawadee UI" pitchFamily="34" charset="-122"/>
+                <a:cs typeface="Leelawadee UI" pitchFamily="34" charset="-120"/>
+              </a:rPr>
+              <a:t>TRAIN  —  19,280 แถว  (ต.ค. 2021 → ต.ค. 2025)</a:t>
             </a:r>
             <a:endParaRPr lang="en-US" sz="1200" dirty="0"/>
           </a:p>
@@ -13795,11 +13797,11 @@
                 <a:solidFill>
                   <a:srgbClr val="0A0E14"/>
                 </a:solidFill>
-                <a:latin typeface="Calibri" pitchFamily="34" charset="0"/>
-                <a:ea typeface="Calibri" pitchFamily="34" charset="-122"/>
-                <a:cs typeface="Calibri" pitchFamily="34" charset="-120"/>
-              </a:rPr>
-              <a:t>TEST  —  4,840 rows</a:t>
+                <a:latin typeface="Leelawadee UI" pitchFamily="34" charset="0"/>
+                <a:ea typeface="Leelawadee UI" pitchFamily="34" charset="-122"/>
+                <a:cs typeface="Leelawadee UI" pitchFamily="34" charset="-120"/>
+              </a:rPr>
+              <a:t>TEST  —  4,840 แถว</a:t>
             </a:r>
             <a:endParaRPr lang="en-US" sz="1200" dirty="0"/>
           </a:p>
@@ -13834,9 +13836,9 @@
                 <a:solidFill>
                   <a:srgbClr val="9AA5B1"/>
                 </a:solidFill>
-                <a:latin typeface="Calibri" pitchFamily="34" charset="0"/>
-                <a:ea typeface="Calibri" pitchFamily="34" charset="-122"/>
-                <a:cs typeface="Calibri" pitchFamily="34" charset="-120"/>
+                <a:latin typeface="Leelawadee UI" pitchFamily="34" charset="0"/>
+                <a:ea typeface="Leelawadee UI" pitchFamily="34" charset="-122"/>
+                <a:cs typeface="Leelawadee UI" pitchFamily="34" charset="-120"/>
               </a:rPr>
               <a:t>cutoff: 2025-10-09</a:t>
             </a:r>
@@ -13905,9 +13907,9 @@
                 <a:solidFill>
                   <a:srgbClr val="5B6B7C"/>
                 </a:solidFill>
-                <a:latin typeface="Calibri" pitchFamily="34" charset="0"/>
-                <a:ea typeface="Calibri" pitchFamily="34" charset="-122"/>
-                <a:cs typeface="Calibri" pitchFamily="34" charset="-120"/>
+                <a:latin typeface="Leelawadee UI" pitchFamily="34" charset="0"/>
+                <a:ea typeface="Leelawadee UI" pitchFamily="34" charset="-122"/>
+                <a:cs typeface="Leelawadee UI" pitchFamily="34" charset="-120"/>
               </a:rPr>
               <a:t>8</a:t>
             </a:r>
@@ -13944,9 +13946,9 @@
                 <a:solidFill>
                   <a:srgbClr val="5B6B7C"/>
                 </a:solidFill>
-                <a:latin typeface="Calibri" pitchFamily="34" charset="0"/>
-                <a:ea typeface="Calibri" pitchFamily="34" charset="-122"/>
-                <a:cs typeface="Calibri" pitchFamily="34" charset="-120"/>
+                <a:latin typeface="Leelawadee UI" pitchFamily="34" charset="0"/>
+                <a:ea typeface="Leelawadee UI" pitchFamily="34" charset="-122"/>
+                <a:cs typeface="Leelawadee UI" pitchFamily="34" charset="-120"/>
               </a:rPr>
               <a:t>Stockscope AI · CP020003</a:t>
             </a:r>
@@ -13983,11 +13985,11 @@
                 <a:solidFill>
                   <a:srgbClr val="A3E635"/>
                 </a:solidFill>
-                <a:latin typeface="Calibri" pitchFamily="34" charset="0"/>
-                <a:ea typeface="Calibri" pitchFamily="34" charset="-122"/>
-                <a:cs typeface="Calibri" pitchFamily="34" charset="-120"/>
-              </a:rPr>
-              <a:t>METHODOLOGY</a:t>
+                <a:latin typeface="Leelawadee UI" pitchFamily="34" charset="0"/>
+                <a:ea typeface="Leelawadee UI" pitchFamily="34" charset="-122"/>
+                <a:cs typeface="Leelawadee UI" pitchFamily="34" charset="-120"/>
+              </a:rPr>
+              <a:t>ระเบียบวิธี</a:t>
             </a:r>
             <a:endParaRPr lang="en-US" sz="1300" dirty="0"/>
           </a:p>
@@ -14018,17 +14020,17 @@
               <a:buNone/>
             </a:pPr>
             <a:r>
-              <a:rPr lang="en-US" sz="3200" b="1" dirty="0">
+              <a:rPr lang="en-US" sz="3000" b="1" dirty="0">
                 <a:solidFill>
                   <a:srgbClr val="F5F5F5"/>
                 </a:solidFill>
-                <a:latin typeface="Cambria" pitchFamily="34" charset="0"/>
-                <a:ea typeface="Cambria" pitchFamily="34" charset="-122"/>
-                <a:cs typeface="Cambria" pitchFamily="34" charset="-120"/>
-              </a:rPr>
-              <a:t>Model Training — Baselines vs. XGBoost</a:t>
-            </a:r>
-            <a:endParaRPr lang="en-US" sz="3200" dirty="0"/>
+                <a:latin typeface="Leelawadee UI" pitchFamily="34" charset="0"/>
+                <a:ea typeface="Leelawadee UI" pitchFamily="34" charset="-122"/>
+                <a:cs typeface="Leelawadee UI" pitchFamily="34" charset="-120"/>
+              </a:rPr>
+              <a:t>การเทรนโมเดล — Baseline เทียบ XGBoost</a:t>
+            </a:r>
+            <a:endParaRPr lang="en-US" sz="3000" dirty="0"/>
           </a:p>
         </p:txBody>
       </p:sp>
@@ -14090,9 +14092,9 @@
                 <a:solidFill>
                   <a:srgbClr val="F5F5F5"/>
                 </a:solidFill>
-                <a:latin typeface="Calibri" pitchFamily="34" charset="0"/>
-                <a:ea typeface="Calibri" pitchFamily="34" charset="-122"/>
-                <a:cs typeface="Calibri" pitchFamily="34" charset="-120"/>
+                <a:latin typeface="Leelawadee UI" pitchFamily="34" charset="0"/>
+                <a:ea typeface="Leelawadee UI" pitchFamily="34" charset="-122"/>
+                <a:cs typeface="Leelawadee UI" pitchFamily="34" charset="-120"/>
               </a:rPr>
               <a:t>Logistic Regression</a:t>
             </a:r>
@@ -14129,11 +14131,11 @@
                 <a:solidFill>
                   <a:srgbClr val="9AA5B1"/>
                 </a:solidFill>
-                <a:latin typeface="Calibri" pitchFamily="34" charset="0"/>
-                <a:ea typeface="Calibri" pitchFamily="34" charset="-122"/>
-                <a:cs typeface="Calibri" pitchFamily="34" charset="-120"/>
-              </a:rPr>
-              <a:t>Simplest linear baseline (features standardized)</a:t>
+                <a:latin typeface="Leelawadee UI" pitchFamily="34" charset="0"/>
+                <a:ea typeface="Leelawadee UI" pitchFamily="34" charset="-122"/>
+                <a:cs typeface="Leelawadee UI" pitchFamily="34" charset="-120"/>
+              </a:rPr>
+              <a:t>โมเดลเชิงเส้นพื้นฐานที่สุด (standardize ฟีเจอร์ก่อน)</a:t>
             </a:r>
             <a:endParaRPr lang="en-US" sz="1200" dirty="0"/>
           </a:p>
@@ -14197,9 +14199,9 @@
                 <a:solidFill>
                   <a:srgbClr val="F5F5F5"/>
                 </a:solidFill>
-                <a:latin typeface="Calibri" pitchFamily="34" charset="0"/>
-                <a:ea typeface="Calibri" pitchFamily="34" charset="-122"/>
-                <a:cs typeface="Calibri" pitchFamily="34" charset="-120"/>
+                <a:latin typeface="Leelawadee UI" pitchFamily="34" charset="0"/>
+                <a:ea typeface="Leelawadee UI" pitchFamily="34" charset="-122"/>
+                <a:cs typeface="Leelawadee UI" pitchFamily="34" charset="-120"/>
               </a:rPr>
               <a:t>Random Forest</a:t>
             </a:r>
@@ -14236,11 +14238,11 @@
                 <a:solidFill>
                   <a:srgbClr val="9AA5B1"/>
                 </a:solidFill>
-                <a:latin typeface="Calibri" pitchFamily="34" charset="0"/>
-                <a:ea typeface="Calibri" pitchFamily="34" charset="-122"/>
-                <a:cs typeface="Calibri" pitchFamily="34" charset="-120"/>
-              </a:rPr>
-              <a:t>Second tree-ensemble baseline, no boosting</a:t>
+                <a:latin typeface="Leelawadee UI" pitchFamily="34" charset="0"/>
+                <a:ea typeface="Leelawadee UI" pitchFamily="34" charset="-122"/>
+                <a:cs typeface="Leelawadee UI" pitchFamily="34" charset="-120"/>
+              </a:rPr>
+              <a:t>โมเดล tree-ensemble อีกตัว ไม่มี boosting</a:t>
             </a:r>
             <a:endParaRPr lang="en-US" sz="1200" dirty="0"/>
           </a:p>
@@ -14304,11 +14306,11 @@
                 <a:solidFill>
                   <a:srgbClr val="A3E635"/>
                 </a:solidFill>
-                <a:latin typeface="Calibri" pitchFamily="34" charset="0"/>
-                <a:ea typeface="Calibri" pitchFamily="34" charset="-122"/>
-                <a:cs typeface="Calibri" pitchFamily="34" charset="-120"/>
-              </a:rPr>
-              <a:t>XGBoost (ours)</a:t>
+                <a:latin typeface="Leelawadee UI" pitchFamily="34" charset="0"/>
+                <a:ea typeface="Leelawadee UI" pitchFamily="34" charset="-122"/>
+                <a:cs typeface="Leelawadee UI" pitchFamily="34" charset="-120"/>
+              </a:rPr>
+              <a:t>XGBoost (ของเรา)</a:t>
             </a:r>
             <a:endParaRPr lang="en-US" sz="1500" dirty="0"/>
           </a:p>
@@ -14343,11 +14345,11 @@
                 <a:solidFill>
                   <a:srgbClr val="9AA5B1"/>
                 </a:solidFill>
-                <a:latin typeface="Calibri" pitchFamily="34" charset="0"/>
-                <a:ea typeface="Calibri" pitchFamily="34" charset="-122"/>
-                <a:cs typeface="Calibri" pitchFamily="34" charset="-120"/>
-              </a:rPr>
-              <a:t>Tuned with TimeSeriesSplit CV — inside training data only</a:t>
+                <a:latin typeface="Leelawadee UI" pitchFamily="34" charset="0"/>
+                <a:ea typeface="Leelawadee UI" pitchFamily="34" charset="-122"/>
+                <a:cs typeface="Leelawadee UI" pitchFamily="34" charset="-120"/>
+              </a:rPr>
+              <a:t>ปรับจูนด้วย TimeSeriesSplit CV — ใช้เฉพาะชุด train</a:t>
             </a:r>
             <a:endParaRPr lang="en-US" sz="1200" dirty="0"/>
           </a:p>
@@ -14382,11 +14384,11 @@
                 <a:solidFill>
                   <a:srgbClr val="9AA5B1"/>
                 </a:solidFill>
-                <a:latin typeface="Calibri" pitchFamily="34" charset="0"/>
-                <a:ea typeface="Calibri" pitchFamily="34" charset="-122"/>
-                <a:cs typeface="Calibri" pitchFamily="34" charset="-120"/>
-              </a:rPr>
-              <a:t>HYPERPARAMETER SEARCH — TimeSeriesSplit (4 folds), training set only</a:t>
+                <a:latin typeface="Leelawadee UI" pitchFamily="34" charset="0"/>
+                <a:ea typeface="Leelawadee UI" pitchFamily="34" charset="-122"/>
+                <a:cs typeface="Leelawadee UI" pitchFamily="34" charset="-120"/>
+              </a:rPr>
+              <a:t>ค้นหาค่า HYPERPARAMETER — TimeSeriesSplit (4 folds) ใช้เฉพาะชุด train</a:t>
             </a:r>
             <a:endParaRPr lang="en-US" sz="1200" dirty="0"/>
           </a:p>
@@ -14482,9 +14484,9 @@
                 <a:solidFill>
                   <a:srgbClr val="9AA5B1"/>
                 </a:solidFill>
-                <a:latin typeface="Calibri" pitchFamily="34" charset="0"/>
-                <a:ea typeface="Calibri" pitchFamily="34" charset="-122"/>
-                <a:cs typeface="Calibri" pitchFamily="34" charset="-120"/>
+                <a:latin typeface="Leelawadee UI" pitchFamily="34" charset="0"/>
+                <a:ea typeface="Leelawadee UI" pitchFamily="34" charset="-122"/>
+                <a:cs typeface="Leelawadee UI" pitchFamily="34" charset="-120"/>
               </a:rPr>
               <a:t>CV AUC 0.499</a:t>
             </a:r>
@@ -14587,11 +14589,11 @@
                 <a:solidFill>
                   <a:srgbClr val="A3E635"/>
                 </a:solidFill>
-                <a:latin typeface="Calibri" pitchFamily="34" charset="0"/>
-                <a:ea typeface="Calibri" pitchFamily="34" charset="-122"/>
-                <a:cs typeface="Calibri" pitchFamily="34" charset="-120"/>
-              </a:rPr>
-              <a:t>CV AUC 0.505  ✓ best</a:t>
+                <a:latin typeface="Leelawadee UI" pitchFamily="34" charset="0"/>
+                <a:ea typeface="Leelawadee UI" pitchFamily="34" charset="-122"/>
+                <a:cs typeface="Leelawadee UI" pitchFamily="34" charset="-120"/>
+              </a:rPr>
+              <a:t>CV AUC 0.505  ✓ ดีที่สุด</a:t>
             </a:r>
             <a:endParaRPr lang="en-US" sz="1200" dirty="0"/>
           </a:p>
@@ -14687,9 +14689,9 @@
                 <a:solidFill>
                   <a:srgbClr val="9AA5B1"/>
                 </a:solidFill>
-                <a:latin typeface="Calibri" pitchFamily="34" charset="0"/>
-                <a:ea typeface="Calibri" pitchFamily="34" charset="-122"/>
-                <a:cs typeface="Calibri" pitchFamily="34" charset="-120"/>
+                <a:latin typeface="Leelawadee UI" pitchFamily="34" charset="0"/>
+                <a:ea typeface="Leelawadee UI" pitchFamily="34" charset="-122"/>
+                <a:cs typeface="Leelawadee UI" pitchFamily="34" charset="-120"/>
               </a:rPr>
               <a:t>CV AUC 0.501</a:t>
             </a:r>
@@ -14755,11 +14757,11 @@
                 <a:solidFill>
                   <a:srgbClr val="9AA5B1"/>
                 </a:solidFill>
-                <a:latin typeface="Calibri" pitchFamily="34" charset="0"/>
-                <a:ea typeface="Calibri" pitchFamily="34" charset="-122"/>
-                <a:cs typeface="Calibri" pitchFamily="34" charset="-120"/>
-              </a:rPr>
-              <a:t>FINAL CONFIG</a:t>
+                <a:latin typeface="Leelawadee UI" pitchFamily="34" charset="0"/>
+                <a:ea typeface="Leelawadee UI" pitchFamily="34" charset="-122"/>
+                <a:cs typeface="Leelawadee UI" pitchFamily="34" charset="-120"/>
+              </a:rPr>
+              <a:t>ค่าที่ใช้จริง</a:t>
             </a:r>
             <a:endParaRPr lang="en-US" sz="1100" dirty="0"/>
           </a:p>
@@ -14928,9 +14930,9 @@
                 <a:solidFill>
                   <a:srgbClr val="5B6B7C"/>
                 </a:solidFill>
-                <a:latin typeface="Calibri" pitchFamily="34" charset="0"/>
-                <a:ea typeface="Calibri" pitchFamily="34" charset="-122"/>
-                <a:cs typeface="Calibri" pitchFamily="34" charset="-120"/>
+                <a:latin typeface="Leelawadee UI" pitchFamily="34" charset="0"/>
+                <a:ea typeface="Leelawadee UI" pitchFamily="34" charset="-122"/>
+                <a:cs typeface="Leelawadee UI" pitchFamily="34" charset="-120"/>
               </a:rPr>
               <a:t>9</a:t>
             </a:r>
@@ -14967,9 +14969,9 @@
                 <a:solidFill>
                   <a:srgbClr val="5B6B7C"/>
                 </a:solidFill>
-                <a:latin typeface="Calibri" pitchFamily="34" charset="0"/>
-                <a:ea typeface="Calibri" pitchFamily="34" charset="-122"/>
-                <a:cs typeface="Calibri" pitchFamily="34" charset="-120"/>
+                <a:latin typeface="Leelawadee UI" pitchFamily="34" charset="0"/>
+                <a:ea typeface="Leelawadee UI" pitchFamily="34" charset="-122"/>
+                <a:cs typeface="Leelawadee UI" pitchFamily="34" charset="-120"/>
               </a:rPr>
               <a:t>Stockscope AI · CP020003</a:t>
             </a:r>
@@ -15006,11 +15008,11 @@
                 <a:solidFill>
                   <a:srgbClr val="A3E635"/>
                 </a:solidFill>
-                <a:latin typeface="Calibri" pitchFamily="34" charset="0"/>
-                <a:ea typeface="Calibri" pitchFamily="34" charset="-122"/>
-                <a:cs typeface="Calibri" pitchFamily="34" charset="-120"/>
-              </a:rPr>
-              <a:t>RESULTS &amp; EVALUATION</a:t>
+                <a:latin typeface="Leelawadee UI" pitchFamily="34" charset="0"/>
+                <a:ea typeface="Leelawadee UI" pitchFamily="34" charset="-122"/>
+                <a:cs typeface="Leelawadee UI" pitchFamily="34" charset="-120"/>
+              </a:rPr>
+              <a:t>ผลลัพธ์และการประเมิน</a:t>
             </a:r>
             <a:endParaRPr lang="en-US" sz="1300" dirty="0"/>
           </a:p>
@@ -15045,11 +15047,11 @@
                 <a:solidFill>
                   <a:srgbClr val="F5F5F5"/>
                 </a:solidFill>
-                <a:latin typeface="Cambria" pitchFamily="34" charset="0"/>
-                <a:ea typeface="Cambria" pitchFamily="34" charset="-122"/>
-                <a:cs typeface="Cambria" pitchFamily="34" charset="-120"/>
-              </a:rPr>
-              <a:t>Model Comparison on the Test Set</a:t>
+                <a:latin typeface="Leelawadee UI" pitchFamily="34" charset="0"/>
+                <a:ea typeface="Leelawadee UI" pitchFamily="34" charset="-122"/>
+                <a:cs typeface="Leelawadee UI" pitchFamily="34" charset="-120"/>
+              </a:rPr>
+              <a:t>เปรียบเทียบโมเดลบนชุดทดสอบ</a:t>
             </a:r>
             <a:endParaRPr lang="en-US" sz="3200" dirty="0"/>
           </a:p>
@@ -15084,11 +15086,11 @@
                 <a:solidFill>
                   <a:srgbClr val="F5F5F5"/>
                 </a:solidFill>
-                <a:latin typeface="Calibri" pitchFamily="34" charset="0"/>
-                <a:ea typeface="Calibri" pitchFamily="34" charset="-122"/>
-                <a:cs typeface="Calibri" pitchFamily="34" charset="-120"/>
-              </a:rPr>
-              <a:t>Accuracy</a:t>
+                <a:latin typeface="Leelawadee UI" pitchFamily="34" charset="0"/>
+                <a:ea typeface="Leelawadee UI" pitchFamily="34" charset="-122"/>
+                <a:cs typeface="Leelawadee UI" pitchFamily="34" charset="-120"/>
+              </a:rPr>
+              <a:t>ความแม่นยำ (Accuracy)</a:t>
             </a:r>
             <a:endParaRPr lang="en-US" sz="1400" dirty="0"/>
           </a:p>
@@ -15139,9 +15141,9 @@
                 <a:solidFill>
                   <a:srgbClr val="F5F5F5"/>
                 </a:solidFill>
-                <a:latin typeface="Calibri" pitchFamily="34" charset="0"/>
-                <a:ea typeface="Calibri" pitchFamily="34" charset="-122"/>
-                <a:cs typeface="Calibri" pitchFamily="34" charset="-120"/>
+                <a:latin typeface="Leelawadee UI" pitchFamily="34" charset="0"/>
+                <a:ea typeface="Leelawadee UI" pitchFamily="34" charset="-122"/>
+                <a:cs typeface="Leelawadee UI" pitchFamily="34" charset="-120"/>
               </a:rPr>
               <a:t>ROC-AUC</a:t>
             </a:r>
@@ -15223,11 +15225,11 @@
                 <a:solidFill>
                   <a:srgbClr val="F5F5F5"/>
                 </a:solidFill>
-                <a:latin typeface="Calibri" pitchFamily="34" charset="0"/>
-                <a:ea typeface="Calibri" pitchFamily="34" charset="-122"/>
-                <a:cs typeface="Calibri" pitchFamily="34" charset="-120"/>
-              </a:rPr>
-              <a:t>XGBoost wins on accuracy (52.5%); Random Forest edges it slightly on ROC-AUC (0.536 vs 0.526). Both tree ensembles clearly beat Logistic Regression and the 50.7% majority-class baseline.</a:t>
+                <a:latin typeface="Leelawadee UI" pitchFamily="34" charset="0"/>
+                <a:ea typeface="Leelawadee UI" pitchFamily="34" charset="-122"/>
+                <a:cs typeface="Leelawadee UI" pitchFamily="34" charset="-120"/>
+              </a:rPr>
+              <a:t>XGBoost แม่นยำที่สุด (52.5%) ส่วน Random Forest ทำ ROC-AUC ได้ดีกว่าเล็กน้อย (0.536 เทียบ 0.526) ทั้งสองโมเดลแบบ tree-ensemble ชนะ Logistic Regression และ baseline ที่ทายกลุ่มมากสุดอย่างเดียว (50.7%) อย่างชัดเจน</a:t>
             </a:r>
             <a:endParaRPr lang="en-US" sz="1400" dirty="0"/>
           </a:p>

</xml_diff>

<commit_message>
Sync notebook and slides to the latest Colab version
The team's Colab notebook ("CP ล่าสุด") improved on the previous
version: label purge by each row's target_date, CV over unique dates,
fixed data snapshot (2021-10-04..2026-10-01), one-day backtest model,
RSI edge cases, softer claims. Its saved outputs differ slightly from
the earlier numbers, so:
- ml/stock_direction_model.ipynb is now the Colab version with saved
  outputs; three stale numbers in its conclusion text (AUC 0.505, CI
  0.488-0.523, $1.068) were corrected to match its own outputs
  (0.500, 0.485-0.516, $1.078).
- Slides 7-14 re-synced to the Colab results and softened where the
  notebook no longer claims market efficiency is proven.
- build_notebook.py marked outdated so it cannot overwrite the notebook.

Co-Authored-By: Claude Sonnet 5.5 <noreply@anthropic.com>
</commit_message>
<xml_diff>
--- a/ml/stock_direction_presentation.pptx
+++ b/ml/stock_direction_presentation.pptx
@@ -257,10 +257,10 @@
                   <c:v>0.516</c:v>
                 </c:pt>
                 <c:pt idx="2">
-                  <c:v>0.5139</c:v>
+                  <c:v>0.5135</c:v>
                 </c:pt>
                 <c:pt idx="3">
-                  <c:v>0.5062</c:v>
+                  <c:v>0.506</c:v>
                 </c:pt>
               </c:numCache>
             </c:numRef>
@@ -536,10 +536,10 @@
                   <c:v>0.5129</c:v>
                 </c:pt>
                 <c:pt idx="2">
-                  <c:v>0.4998</c:v>
+                  <c:v>0.4999</c:v>
                 </c:pt>
                 <c:pt idx="3">
-                  <c:v>0.505</c:v>
+                  <c:v>0.5005</c:v>
                 </c:pt>
               </c:numCache>
             </c:numRef>
@@ -762,13 +762,13 @@
                 <c:formatCode>General</c:formatCode>
                 <c:ptCount val="3"/>
                 <c:pt idx="0">
-                  <c:v>0.5062</c:v>
+                  <c:v>0.506</c:v>
                 </c:pt>
                 <c:pt idx="1">
-                  <c:v>0.5146</c:v>
+                  <c:v>0.5242</c:v>
                 </c:pt>
                 <c:pt idx="2">
-                  <c:v>0.5308</c:v>
+                  <c:v>0.523</c:v>
                 </c:pt>
               </c:numCache>
             </c:numRef>
@@ -1185,34 +1185,34 @@
                 <c:ptCount val="10"/>
                 <c:lvl>
                   <c:pt idx="0">
+                    <c:v>volatility_20d</c:v>
+                  </c:pt>
+                  <c:pt idx="1">
+                    <c:v>macd_hist</c:v>
+                  </c:pt>
+                  <c:pt idx="2">
+                    <c:v>dist_sma50</c:v>
+                  </c:pt>
+                  <c:pt idx="3">
                     <c:v>ret_21d</c:v>
                   </c:pt>
-                  <c:pt idx="1">
-                    <c:v>dist_sma50</c:v>
-                  </c:pt>
-                  <c:pt idx="2">
+                  <c:pt idx="4">
                     <c:v>rsi14</c:v>
-                  </c:pt>
-                  <c:pt idx="3">
-                    <c:v>macd_hist</c:v>
-                  </c:pt>
-                  <c:pt idx="4">
-                    <c:v>volatility_20d</c:v>
                   </c:pt>
                   <c:pt idx="5">
                     <c:v>dist_sma20</c:v>
                   </c:pt>
                   <c:pt idx="6">
+                    <c:v>ret_10d</c:v>
+                  </c:pt>
+                  <c:pt idx="7">
                     <c:v>ret_5d</c:v>
                   </c:pt>
-                  <c:pt idx="7">
-                    <c:v>ret_10d</c:v>
-                  </c:pt>
                   <c:pt idx="8">
-                    <c:v>ret_1d</c:v>
+                    <c:v>vol_ratio</c:v>
                   </c:pt>
                   <c:pt idx="9">
-                    <c:v>vol_ratio</c:v>
+                    <c:v>ret_1d</c:v>
                   </c:pt>
                 </c:lvl>
               </c:multiLvlStrCache>
@@ -1225,34 +1225,34 @@
                 <c:formatCode>General</c:formatCode>
                 <c:ptCount val="10"/>
                 <c:pt idx="0">
-                  <c:v>0.0957</c:v>
+                  <c:v>0.0943</c:v>
                 </c:pt>
                 <c:pt idx="1">
-                  <c:v>0.0979</c:v>
+                  <c:v>0.0948</c:v>
                 </c:pt>
                 <c:pt idx="2">
+                  <c:v>0.095</c:v>
+                </c:pt>
+                <c:pt idx="3">
+                  <c:v>0.0965</c:v>
+                </c:pt>
+                <c:pt idx="4">
+                  <c:v>0.0974</c:v>
+                </c:pt>
+                <c:pt idx="5">
                   <c:v>0.0981</c:v>
                 </c:pt>
-                <c:pt idx="3">
-                  <c:v>0.0992</c:v>
-                </c:pt>
-                <c:pt idx="4">
-                  <c:v>0.1</c:v>
-                </c:pt>
-                <c:pt idx="5">
-                  <c:v>0.1009</c:v>
-                </c:pt>
                 <c:pt idx="6">
-                  <c:v>0.1015</c:v>
+                  <c:v>0.1023</c:v>
                 </c:pt>
                 <c:pt idx="7">
-                  <c:v>0.1021</c:v>
+                  <c:v>0.1034</c:v>
                 </c:pt>
                 <c:pt idx="8">
-                  <c:v>0.1022</c:v>
+                  <c:v>0.1069</c:v>
                 </c:pt>
                 <c:pt idx="9">
-                  <c:v>0.1023</c:v>
+                  <c:v>0.1112</c:v>
                 </c:pt>
               </c:numCache>
             </c:numRef>
@@ -4189,7 +4189,7 @@
                 <a:ea typeface="Leelawadee UI" pitchFamily="34" charset="-122"/>
                 <a:cs typeface="Leelawadee UI" pitchFamily="34" charset="-120"/>
               </a:rPr>
-              <a:t>0.505</a:t>
+              <a:t>0.5005</a:t>
             </a:r>
             <a:endParaRPr lang="en-US" sz="1800" dirty="0"/>
           </a:p>
@@ -4228,7 +4228,7 @@
                 <a:ea typeface="Leelawadee UI" pitchFamily="34" charset="-122"/>
                 <a:cs typeface="Leelawadee UI" pitchFamily="34" charset="-120"/>
               </a:rPr>
-              <a:t>ช่วงความเชื่อมั่น 95%: 0.488 – 0.521</a:t>
+              <a:t>ช่วงความเชื่อมั่น 95%: 0.485 – 0.516</a:t>
             </a:r>
             <a:endParaRPr lang="en-US" sz="1000" dirty="0"/>
           </a:p>
@@ -4306,7 +4306,7 @@
                 <a:ea typeface="Leelawadee UI" pitchFamily="34" charset="-122"/>
                 <a:cs typeface="Leelawadee UI" pitchFamily="34" charset="-120"/>
               </a:rPr>
-              <a:t>0.506</a:t>
+              <a:t>0.5076</a:t>
             </a:r>
             <a:endParaRPr lang="en-US" sz="1800" dirty="0"/>
           </a:p>
@@ -4345,7 +4345,7 @@
                 <a:ea typeface="Leelawadee UI" pitchFamily="34" charset="-122"/>
                 <a:cs typeface="Leelawadee UI" pitchFamily="34" charset="-120"/>
               </a:rPr>
-              <a:t>ช่วงความเชื่อมั่น 95%: 0.484 – 0.533</a:t>
+              <a:t>ช่วงความเชื่อมั่น 95%: 0.485 – 0.534</a:t>
             </a:r>
             <a:endParaRPr lang="en-US" sz="1000" dirty="0"/>
           </a:p>
@@ -4423,7 +4423,7 @@
                 <a:ea typeface="Leelawadee UI" pitchFamily="34" charset="-122"/>
                 <a:cs typeface="Leelawadee UI" pitchFamily="34" charset="-120"/>
               </a:rPr>
-              <a:t>0.519</a:t>
+              <a:t>0.5225</a:t>
             </a:r>
             <a:endParaRPr lang="en-US" sz="1800" dirty="0"/>
           </a:p>
@@ -4462,7 +4462,7 @@
                 <a:ea typeface="Leelawadee UI" pitchFamily="34" charset="-122"/>
                 <a:cs typeface="Leelawadee UI" pitchFamily="34" charset="-120"/>
               </a:rPr>
-              <a:t>ช่วงความเชื่อมั่น 95%: 0.489 – 0.550</a:t>
+              <a:t>ช่วงความเชื่อมั่น 95%: 0.492 – 0.556</a:t>
             </a:r>
             <a:endParaRPr lang="en-US" sz="1000" dirty="0"/>
           </a:p>
@@ -4540,7 +4540,7 @@
                 <a:ea typeface="Leelawadee UI" pitchFamily="34" charset="-122"/>
                 <a:cs typeface="Leelawadee UI" pitchFamily="34" charset="-120"/>
               </a:rPr>
-              <a:t>ทุกระยะเวลา ช่วงความเชื่อมั่นครอบคลุม 0.5 — ไม่พบสัญญาณที่แยกจากการสุ่มได้ ตรงกับทฤษฎีตลาดมีประสิทธิภาพ (Market Efficiency)</a:t>
+              <a:t>ทุกระยะเวลา ช่วงความเชื่อมั่นครอบคลุม 0.5 — ยังไม่พบสัญญาณที่ดีกว่าการสุ่ม สอดคล้องกับทฤษฎีตลาดมีประสิทธิภาพ (แต่ไม่ได้พิสูจน์)</a:t>
             </a:r>
             <a:endParaRPr lang="en-US" sz="1200" dirty="0"/>
           </a:p>
@@ -4878,7 +4878,7 @@
                 <a:ea typeface="Leelawadee UI" pitchFamily="34" charset="-122"/>
                 <a:cs typeface="Leelawadee UI" pitchFamily="34" charset="-120"/>
               </a:rPr>
-              <a:t>ความสำคัญของทุกฟีเจอร์ใกล้เคียงกันหมด (0.096–0.102) ไม่มีฟีเจอร์ไหนโดดเด่น</a:t>
+              <a:t>ความสำคัญของทุกฟีเจอร์อยู่ในช่วงแคบ (0.094–0.111) ไม่มีฟีเจอร์ไหนโดดเด่นชัดเจน</a:t>
             </a:r>
             <a:endParaRPr lang="en-US" sz="1300" dirty="0"/>
           </a:p>
@@ -4907,7 +4907,7 @@
                 <a:ea typeface="Leelawadee UI" pitchFamily="34" charset="-122"/>
                 <a:cs typeface="Leelawadee UI" pitchFamily="34" charset="-120"/>
               </a:rPr>
-              <a:t>สอดคล้องกับผลก่อนหน้า: ถ้ามีสัญญาณจริง เราควรเห็นฟีเจอร์ 1–2 ตัวสูงกว่าตัวอื่นชัดเจน แต่นี่ต้นไม้กำลังแบ่งตาม noise</a:t>
+              <a:t>ค่านี้แค่อธิบายว่าโมเดลใช้อะไร ไม่ได้พิสูจน์ว่าฟีเจอร์ใดทำให้ราคาขยับ — หลักฐานหลักมาจากการทดสอบบนชุด test</a:t>
             </a:r>
             <a:endParaRPr lang="en-US" sz="1300" dirty="0"/>
           </a:p>
@@ -5224,7 +5224,7 @@
                 <a:ea typeface="Leelawadee UI" pitchFamily="34" charset="-122"/>
                 <a:cs typeface="Leelawadee UI" pitchFamily="34" charset="-120"/>
               </a:rPr>
-              <a:t>กติกา: ถือหุ้นวันถัดไปเมื่อ P(ขึ้น) &gt; 0.55 นอกนั้นถือเงินสด น้ำหนักเท่ากันทั้ง 20 หุ้น เฉพาะช่วง test ไม่รวมค่าธรรมเนียม</a:t>
+              <a:t>กติกา: ใช้โมเดล 1 วัน ถือหุ้นวันถัดไปเมื่อ P(ขึ้น) &gt; 0.55 นอกนั้นถือเงินสด น้ำหนักเท่ากันทั้ง 20 หุ้น ช่วง test ไม่รวมค่าธรรมเนียม และใช้ราคาปิดวันเดียวกัน (ผลจริงน่าจะแย่กว่านี้)</a:t>
             </a:r>
             <a:endParaRPr lang="en-US" sz="1300" dirty="0"/>
           </a:p>
@@ -5292,7 +5292,7 @@
                 <a:ea typeface="Leelawadee UI" pitchFamily="34" charset="-122"/>
                 <a:cs typeface="Leelawadee UI" pitchFamily="34" charset="-120"/>
               </a:rPr>
-              <a:t>1.13x</a:t>
+              <a:t>1.08x</a:t>
             </a:r>
             <a:endParaRPr lang="en-US" sz="4400" dirty="0"/>
           </a:p>
@@ -5647,7 +5647,7 @@
                 <a:ea typeface="Leelawadee UI" pitchFamily="34" charset="-122"/>
                 <a:cs typeface="Leelawadee UI" pitchFamily="34" charset="-120"/>
               </a:rPr>
-              <a:t>โมเดลถือหุ้นเพียง ~31% ของเวลา ขณะที่ช่วง test ตลาดโดยรวมขึ้น การอยู่ในเงินสดทำให้พลาดวันขึ้นไปหลายวัน และโมเดลไม่มีความได้เปรียบทางสถิติมาชดเชย — ความได้เปรียบทางสถิติเล็กน้อยไม่เท่ากับกลยุทธ์ที่ทำกำไรได้จริง</a:t>
+              <a:t>โมเดลถือหุ้นเพียง ~20% ของเวลา ขณะที่ช่วง test ตลาดโดยรวมขึ้น การอยู่ในเงินสดทำให้พลาดวันขึ้นไปหลายวัน และโมเดลไม่มีความได้เปรียบทางสถิติมาชดเชย — ความได้เปรียบทางสถิติเล็กน้อยไม่เท่ากับกลยุทธ์ที่ทำกำไรได้จริง</a:t>
             </a:r>
             <a:endParaRPr lang="en-US" sz="1300" dirty="0"/>
           </a:p>
@@ -6760,7 +6760,7 @@
                 <a:ea typeface="Leelawadee UI" pitchFamily="34" charset="-122"/>
                 <a:cs typeface="Leelawadee UI" pitchFamily="34" charset="-120"/>
               </a:rPr>
-              <a:t>ไปป์ไลน์ไม่รั่วไหลข้อมูล: label แยกจากฟีเจอร์ มี embargo และเลือก horizon/hyperparameter จากชุด train เท่านั้น</a:t>
+              <a:t>ไปป์ไลน์ไม่รั่วไหลข้อมูล: label แยกจากฟีเจอร์ มี purge และเลือก horizon/hyperparameter จากชุด train เท่านั้น</a:t>
             </a:r>
             <a:endParaRPr lang="en-US" sz="1300" dirty="0"/>
           </a:p>
@@ -6819,7 +6819,7 @@
                 <a:ea typeface="Leelawadee UI" pitchFamily="34" charset="-122"/>
                 <a:cs typeface="Leelawadee UI" pitchFamily="34" charset="-120"/>
               </a:rPr>
-              <a:t>ไม่มีโมเดลไหน (รวม XGBoost) แยกจากการเดาสุ่มได้ — ช่วงความเชื่อมั่นของ AUC ครอบคลุม 0.5 ทุก horizon</a:t>
+              <a:t>ยังไม่พบว่าโมเดลไหน (รวม XGBoost) ดีกว่าการเดาสุ่ม — ช่วงความเชื่อมั่นของ AUC ครอบคลุม 0.5 ทุก horizon</a:t>
             </a:r>
             <a:endParaRPr lang="en-US" sz="1300" dirty="0"/>
           </a:p>
@@ -6878,7 +6878,7 @@
                 <a:ea typeface="Leelawadee UI" pitchFamily="34" charset="-122"/>
                 <a:cs typeface="Leelawadee UI" pitchFamily="34" charset="-120"/>
               </a:rPr>
-              <a:t>ความสำคัญของฟีเจอร์เกือบเท่ากันหมด ไม่มีสัญญาณเด่น — สอดคล้องกับทฤษฎีตลาดมีประสิทธิภาพ</a:t>
+              <a:t>ความสำคัญของฟีเจอร์อยู่ในช่วงแคบ ไม่มีตัวเด่น — สอดคล้องกับ (แต่ไม่ได้พิสูจน์) ทฤษฎีตลาดมีประสิทธิภาพ</a:t>
             </a:r>
             <a:endParaRPr lang="en-US" sz="1300" dirty="0"/>
           </a:p>
@@ -13735,7 +13735,7 @@
                 <a:ea typeface="Leelawadee UI" pitchFamily="34" charset="-122"/>
                 <a:cs typeface="Leelawadee UI" pitchFamily="34" charset="-120"/>
               </a:rPr>
-              <a:t>ทุกแถวของ train เกิดก่อนทุกแถวของ test ทั้ง 20 หุ้นพร้อมกัน และเว้นช่วงกัน (embargo) เท่ากับ horizon ก่อน cutoff เพื่อไม่ให้ label ของ train ไปแตะช่วง test — เทรนจากอดีต ทดสอบกับอนาคตที่ไม่เคยเห็น</a:t>
+              <a:t>ทุกแถวของ train เกิดก่อนทุกแถวของ test ทั้ง 20 หุ้นพร้อมกัน และตัดแถว train ที่ label (วันที่เป้าหมาย) ไปถึงช่วง test ออก (purge) — เทรนจากอดีต ทดสอบกับอนาคตที่ไม่เคยเห็น</a:t>
             </a:r>
             <a:endParaRPr lang="en-US" sz="1300" dirty="0"/>
           </a:p>
@@ -14483,7 +14483,7 @@
                 <a:ea typeface="Leelawadee UI" pitchFamily="34" charset="-122"/>
                 <a:cs typeface="Leelawadee UI" pitchFamily="34" charset="-120"/>
               </a:rPr>
-              <a:t>เลือก horizon + hyperparameter ด้วย CV แบบเรียงตามเวลา — ใช้เฉพาะชุด train</a:t>
+              <a:t>เลือก horizon + hyperparameter ด้วย CV ตามวันที่ + purge — ใช้เฉพาะชุด train</a:t>
             </a:r>
             <a:endParaRPr lang="en-US" sz="1200" dirty="0"/>
           </a:p>
@@ -14522,7 +14522,7 @@
                 <a:ea typeface="Leelawadee UI" pitchFamily="34" charset="-122"/>
                 <a:cs typeface="Leelawadee UI" pitchFamily="34" charset="-120"/>
               </a:rPr>
-              <a:t>เลือก HORIZON — TimeSeriesSplit (4 folds + gap) บนชุด train เท่านั้น</a:t>
+              <a:t>เลือก HORIZON — TimeSeriesSplit (4 folds ตามวันที่ + purge) บนชุด train เท่านั้น</a:t>
             </a:r>
             <a:endParaRPr lang="en-US" sz="1200" dirty="0"/>
           </a:p>
@@ -14588,7 +14588,7 @@
                 <a:ea typeface="Courier New" pitchFamily="34" charset="-122"/>
                 <a:cs typeface="Courier New" pitchFamily="34" charset="-120"/>
               </a:rPr>
-              <a:t>horizon = 1d  · max_depth=4</a:t>
+              <a:t>horizon = 1d  · max_depth=3</a:t>
             </a:r>
             <a:endParaRPr lang="en-US" sz="1200" dirty="0"/>
           </a:p>
@@ -14727,7 +14727,7 @@
                 <a:ea typeface="Leelawadee UI" pitchFamily="34" charset="-122"/>
                 <a:cs typeface="Leelawadee UI" pitchFamily="34" charset="-120"/>
               </a:rPr>
-              <a:t>CV AUC 0.494</a:t>
+              <a:t>CV AUC 0.496</a:t>
             </a:r>
             <a:endParaRPr lang="en-US" sz="1200" dirty="0"/>
           </a:p>
@@ -14827,7 +14827,7 @@
                 <a:ea typeface="Leelawadee UI" pitchFamily="34" charset="-122"/>
                 <a:cs typeface="Leelawadee UI" pitchFamily="34" charset="-120"/>
               </a:rPr>
-              <a:t>CV AUC 0.483</a:t>
+              <a:t>CV AUC 0.482</a:t>
             </a:r>
             <a:endParaRPr lang="en-US" sz="1200" dirty="0"/>
           </a:p>
@@ -14957,7 +14957,7 @@
                 <a:ea typeface="Courier New" pitchFamily="34" charset="-122"/>
                 <a:cs typeface="Courier New" pitchFamily="34" charset="-120"/>
               </a:rPr>
-              <a:t>max_depth: 4</a:t>
+              <a:t>max_depth: 3</a:t>
             </a:r>
             <a:endParaRPr lang="en-US" sz="1400" dirty="0"/>
           </a:p>
@@ -14997,7 +14997,7 @@
                 <a:ea typeface="Courier New" pitchFamily="34" charset="-122"/>
                 <a:cs typeface="Courier New" pitchFamily="34" charset="-120"/>
               </a:rPr>
-              <a:t>n_estimators: 300</a:t>
+              <a:t>n_estimators: 200</a:t>
             </a:r>
             <a:endParaRPr lang="en-US" sz="1400" dirty="0"/>
           </a:p>
@@ -15383,7 +15383,7 @@
                 <a:ea typeface="Leelawadee UI" pitchFamily="34" charset="-122"/>
                 <a:cs typeface="Leelawadee UI" pitchFamily="34" charset="-120"/>
               </a:rPr>
-              <a:t>ทุกโมเดลใกล้เคียง baseline ที่ทายกลุ่มมากสุดอย่างเดียว (51.3%) — ไม่มีโมเดลไหนชนะชัดเจน ช่วงความเชื่อมั่น 95% ของ ROC-AUC ของ XGBoost คือ 0.488–0.520 ซึ่งครอบคลุม 0.5 จึงยังแยกจากการเดาสุ่มไม่ได้</a:t>
+              <a:t>ทุกโมเดลใกล้เคียง baseline ที่ทายกลุ่มมากสุดอย่างเดียว (51.3%) — ไม่มีโมเดลไหนชนะชัดเจน ช่วงความเชื่อมั่น 95% ของ ROC-AUC ของ XGBoost คือ 0.485–0.516 ครอบคลุม 0.5 จึงยังไม่พบว่าดีกว่าการเดาสุ่ม (แต่ไม่ได้พิสูจน์ว่าเท่ากับ 0.5 พอดี)</a:t>
             </a:r>
             <a:endParaRPr lang="en-US" sz="1400" dirty="0"/>
           </a:p>

</xml_diff>

<commit_message>
Use the verified Colab run as the notebook; merge careful wording into slides
- ml/stock_direction_model.ipynb: Colab_ready version executed on Colab
  (19/19 code cells, no errors). Its final summary is now a code cell
  that prints the real numbers, and it records library versions, so the
  text can no longer disagree with the outputs.
- Verified every number on slides 5-14 against that run (ROC-AUC
  0.5005, 95% CI 0.485-0.516, strategy 1.078x vs 1.276x, 20% held).
- Slides: add "what the data shows" box (slide 5), concrete accuracy vs
  baseline on slide 9, remove unsupported claims (training time, feature
  importance as explanation), note same-close execution and that results
  can differ slightly across machines.
- README documents the Colab-vs-PC difference (AUC 0.5005 vs ~0.505).

Co-Authored-By: Claude Sonnet 5.5 <noreply@anthropic.com>
</commit_message>
<xml_diff>
--- a/ml/stock_direction_presentation.pptx
+++ b/ml/stock_direction_presentation.pptx
@@ -4546,6 +4546,45 @@
           </a:p>
         </p:txBody>
       </p:sp>
+      <p:sp>
+        <p:nvSpPr>
+          <p:cNvPr id="21" name="Text 18"/>
+          <p:cNvSpPr txBox="1"/>
+          <p:nvPr/>
+        </p:nvSpPr>
+        <p:spPr>
+          <a:xfrm>
+            <a:off x="548640" y="5943600"/>
+            <a:ext cx="11064240" cy="274320"/>
+          </a:xfrm>
+          <a:prstGeom prst="rect">
+            <a:avLst/>
+          </a:prstGeom>
+          <a:noFill/>
+          <a:ln/>
+        </p:spPr>
+        <p:txBody>
+          <a:bodyPr wrap="square" lIns="0" tIns="0" rIns="0" bIns="0" rtlCol="0" anchor="ctr"/>
+          <a:lstStyle/>
+          <a:p>
+            <a:pPr indent="0" marL="0">
+              <a:buNone/>
+            </a:pPr>
+            <a:r>
+              <a:rPr lang="en-US" sz="1000" i="1" dirty="0">
+                <a:solidFill>
+                  <a:srgbClr val="5B6B7C"/>
+                </a:solidFill>
+                <a:latin typeface="Leelawadee UI" pitchFamily="34" charset="0"/>
+                <a:ea typeface="Leelawadee UI" pitchFamily="34" charset="-122"/>
+                <a:cs typeface="Leelawadee UI" pitchFamily="34" charset="-120"/>
+              </a:rPr>
+              <a:t>หมายเหตุ: ตัวเลขทั้งหมดมาจากการรันบน Colab (ข้อมูล 2021-10-04 ถึง 2026-10-01) · รันต่างเครื่องหรือต่างเวอร์ชันไลบรารีอาจต่างกันเล็กน้อย (ที่เจอไม่เกิน ~0.005 ของ AUC) ข้อสรุปไม่เปลี่ยน</a:t>
+            </a:r>
+            <a:endParaRPr lang="en-US" sz="1000" dirty="0"/>
+          </a:p>
+        </p:txBody>
+      </p:sp>
     </p:spTree>
   </p:cSld>
   <p:clrMapOvr>
@@ -5647,7 +5686,7 @@
                 <a:ea typeface="Leelawadee UI" pitchFamily="34" charset="-122"/>
                 <a:cs typeface="Leelawadee UI" pitchFamily="34" charset="-120"/>
               </a:rPr>
-              <a:t>โมเดลถือหุ้นเพียง ~20% ของเวลา ขณะที่ช่วง test ตลาดโดยรวมขึ้น การอยู่ในเงินสดทำให้พลาดวันขึ้นไปหลายวัน และโมเดลไม่มีความได้เปรียบทางสถิติมาชดเชย — ความได้เปรียบทางสถิติเล็กน้อยไม่เท่ากับกลยุทธ์ที่ทำกำไรได้จริง</a:t>
+              <a:t>กลยุทธ์ถือหุ้นเฉลี่ยราว 20% ของโอกาสทั้งหมดและได้ผลต่ำกว่าซื้อแล้วถือ ช่วง test ตลาดโดยรวมขึ้น การอยู่ในเงินสดจึงพลาดวันขึ้นไปหลายวัน การจำลองนี้ไม่รวมต้นทุนและซื้อที่ราคาปิดวันเดียวกับสัญญาณ ซึ่งทำจริงไม่ได้เป๊ะ — ความได้เปรียบทางสถิติเล็กน้อยไม่เท่ากับกลยุทธ์ที่ทำกำไรได้จริง</a:t>
             </a:r>
             <a:endParaRPr lang="en-US" sz="1300" dirty="0"/>
           </a:p>
@@ -6323,7 +6362,7 @@
                 <a:ea typeface="Leelawadee UI" pitchFamily="34" charset="-122"/>
                 <a:cs typeface="Leelawadee UI" pitchFamily="34" charset="-120"/>
               </a:rPr>
-              <a:t>การทดสอบย้อนหลังไม่ได้รวมค่าธรรมเนียม ส่วนต่างราคา หรือภาษี</a:t>
+              <a:t>ไม่รวมค่าธรรมเนียม ส่วนต่างราคา หรือภาษี และสมมติซื้อที่ราคาปิดวันเดียวกับที่ได้สัญญาณ</a:t>
             </a:r>
             <a:endParaRPr lang="en-US" sz="1200" dirty="0"/>
           </a:p>
@@ -6878,7 +6917,7 @@
                 <a:ea typeface="Leelawadee UI" pitchFamily="34" charset="-122"/>
                 <a:cs typeface="Leelawadee UI" pitchFamily="34" charset="-120"/>
               </a:rPr>
-              <a:t>ความสำคัญของฟีเจอร์อยู่ในช่วงแคบ ไม่มีตัวเด่น — สอดคล้องกับ (แต่ไม่ได้พิสูจน์) ทฤษฎีตลาดมีประสิทธิภาพ</a:t>
+              <a:t>Feature Importance บอกว่าโมเดลใช้ฟีเจอร์ใด แต่ต้องดูผลทดสอบเพื่อประเมินความสามารถทำนาย</a:t>
             </a:r>
             <a:endParaRPr lang="en-US" sz="1300" dirty="0"/>
           </a:p>
@@ -10024,7 +10063,7 @@
                 <a:ea typeface="Leelawadee UI" pitchFamily="34" charset="-122"/>
                 <a:cs typeface="Leelawadee UI" pitchFamily="34" charset="-120"/>
               </a:rPr>
-              <a:t>รันจบในไม่กี่วินาที บนโน้ตบุ๊กหรือ Colab ฟรี</a:t>
+              <a:t>ฝึกบน CPU ได้ และตรวจผลซ้ำได้ใน Notebook</a:t>
             </a:r>
             <a:endParaRPr lang="en-US" sz="1100" dirty="0"/>
           </a:p>
@@ -10228,7 +10267,7 @@
                 <a:ea typeface="Leelawadee UI" pitchFamily="34" charset="-122"/>
                 <a:cs typeface="Leelawadee UI" pitchFamily="34" charset="-120"/>
               </a:rPr>
-              <a:t>Feature Importance บอกได้ว่า “ทำไม” ไม่ใช่แค่ตัวเลข</a:t>
+              <a:t>Feature Importance ช่วยดูว่าโมเดลใช้ฟีเจอร์ใด</a:t>
             </a:r>
             <a:endParaRPr lang="en-US" sz="1100" dirty="0"/>
           </a:p>
@@ -12088,17 +12127,56 @@
         </p:nvSpPr>
         <p:spPr>
           <a:xfrm>
-            <a:off x="7635240" y="4343400"/>
-            <a:ext cx="3703320" cy="1645920"/>
-          </a:xfrm>
-          <a:prstGeom prst="rect">
-            <a:avLst/>
-          </a:prstGeom>
-          <a:noFill/>
-          <a:ln/>
-        </p:spPr>
-        <p:txBody>
-          <a:bodyPr wrap="square" lIns="0" tIns="0" rIns="0" bIns="0" rtlCol="0" anchor="t"/>
+            <a:off x="7635240" y="4297680"/>
+            <a:ext cx="3703320" cy="274320"/>
+          </a:xfrm>
+          <a:prstGeom prst="rect">
+            <a:avLst/>
+          </a:prstGeom>
+          <a:noFill/>
+          <a:ln/>
+        </p:spPr>
+        <p:txBody>
+          <a:bodyPr wrap="square" lIns="0" tIns="0" rIns="0" bIns="0" rtlCol="0" anchor="ctr"/>
+          <a:lstStyle/>
+          <a:p>
+            <a:pPr indent="0" marL="0">
+              <a:buNone/>
+            </a:pPr>
+            <a:r>
+              <a:rPr lang="en-US" sz="1200" b="1" dirty="0">
+                <a:solidFill>
+                  <a:srgbClr val="A3E635"/>
+                </a:solidFill>
+                <a:latin typeface="Leelawadee UI" pitchFamily="34" charset="0"/>
+                <a:ea typeface="Leelawadee UI" pitchFamily="34" charset="-122"/>
+                <a:cs typeface="Leelawadee UI" pitchFamily="34" charset="-120"/>
+              </a:rPr>
+              <a:t>สิ่งที่เห็นจากข้อมูล</a:t>
+            </a:r>
+            <a:endParaRPr lang="en-US" sz="1200" dirty="0"/>
+          </a:p>
+        </p:txBody>
+      </p:sp>
+      <p:sp>
+        <p:nvSpPr>
+          <p:cNvPr id="37" name="Text 35"/>
+          <p:cNvSpPr txBox="1"/>
+          <p:nvPr/>
+        </p:nvSpPr>
+        <p:spPr>
+          <a:xfrm>
+            <a:off x="7635240" y="4663440"/>
+            <a:ext cx="3703320" cy="320040"/>
+          </a:xfrm>
+          <a:prstGeom prst="rect">
+            <a:avLst/>
+          </a:prstGeom>
+          <a:noFill/>
+          <a:ln/>
+        </p:spPr>
+        <p:txBody>
+          <a:bodyPr wrap="square" lIns="0" tIns="0" rIns="0" bIns="0" rtlCol="0" anchor="ctr"/>
           <a:lstStyle/>
           <a:p>
             <a:pPr indent="0" marL="0">
@@ -12107,15 +12185,132 @@
             <a:r>
               <a:rPr lang="en-US" sz="1200" dirty="0">
                 <a:solidFill>
+                  <a:srgbClr val="F5F5F5"/>
+                </a:solidFill>
+                <a:latin typeface="Leelawadee UI" pitchFamily="34" charset="0"/>
+                <a:ea typeface="Leelawadee UI" pitchFamily="34" charset="-122"/>
+                <a:cs typeface="Leelawadee UI" pitchFamily="34" charset="-120"/>
+              </a:rPr>
+              <a:t>Train: วันขึ้น 52.0%  ·  Test: วันขึ้น 51.3%</a:t>
+            </a:r>
+            <a:endParaRPr lang="en-US" sz="1200" dirty="0"/>
+          </a:p>
+        </p:txBody>
+      </p:sp>
+      <p:sp>
+        <p:nvSpPr>
+          <p:cNvPr id="38" name="Text 36"/>
+          <p:cNvSpPr txBox="1"/>
+          <p:nvPr/>
+        </p:nvSpPr>
+        <p:spPr>
+          <a:xfrm>
+            <a:off x="7635240" y="5029200"/>
+            <a:ext cx="3703320" cy="320040"/>
+          </a:xfrm>
+          <a:prstGeom prst="rect">
+            <a:avLst/>
+          </a:prstGeom>
+          <a:noFill/>
+          <a:ln/>
+        </p:spPr>
+        <p:txBody>
+          <a:bodyPr wrap="square" lIns="0" tIns="0" rIns="0" bIns="0" rtlCol="0" anchor="ctr"/>
+          <a:lstStyle/>
+          <a:p>
+            <a:pPr indent="0" marL="0">
+              <a:buNone/>
+            </a:pPr>
+            <a:r>
+              <a:rPr lang="en-US" sz="1200" dirty="0">
+                <a:solidFill>
+                  <a:srgbClr val="F5F5F5"/>
+                </a:solidFill>
+                <a:latin typeface="Leelawadee UI" pitchFamily="34" charset="0"/>
+                <a:ea typeface="Leelawadee UI" pitchFamily="34" charset="-122"/>
+                <a:cs typeface="Leelawadee UI" pitchFamily="34" charset="-120"/>
+              </a:rPr>
+              <a:t>ข้อมูล OHLCV ขาดหาย 0 ค่า</a:t>
+            </a:r>
+            <a:endParaRPr lang="en-US" sz="1200" dirty="0"/>
+          </a:p>
+        </p:txBody>
+      </p:sp>
+      <p:sp>
+        <p:nvSpPr>
+          <p:cNvPr id="39" name="Text 37"/>
+          <p:cNvSpPr txBox="1"/>
+          <p:nvPr/>
+        </p:nvSpPr>
+        <p:spPr>
+          <a:xfrm>
+            <a:off x="7635240" y="5394960"/>
+            <a:ext cx="3703320" cy="320040"/>
+          </a:xfrm>
+          <a:prstGeom prst="rect">
+            <a:avLst/>
+          </a:prstGeom>
+          <a:noFill/>
+          <a:ln/>
+        </p:spPr>
+        <p:txBody>
+          <a:bodyPr wrap="square" lIns="0" tIns="0" rIns="0" bIns="0" rtlCol="0" anchor="ctr"/>
+          <a:lstStyle/>
+          <a:p>
+            <a:pPr indent="0" marL="0">
+              <a:buNone/>
+            </a:pPr>
+            <a:r>
+              <a:rPr lang="en-US" sz="1200" dirty="0">
+                <a:solidFill>
                   <a:srgbClr val="9AA5B1"/>
                 </a:solidFill>
                 <a:latin typeface="Leelawadee UI" pitchFamily="34" charset="0"/>
                 <a:ea typeface="Leelawadee UI" pitchFamily="34" charset="-122"/>
                 <a:cs typeface="Leelawadee UI" pitchFamily="34" charset="-120"/>
               </a:rPr>
-              <a:t>หลายอุตสาหกรรม ไม่ใช่หุ้นเดียว — ลดความเสี่ยงที่โมเดลจะเรียนรู้พฤติกรรมเฉพาะของบริษัทเดียว แทนที่จะเป็นพฤติกรรมทั่วไปของอินดิเคเตอร์</a:t>
+              <a:t>ข้อจำกัด: เฉพาะหุ้นที่ยังจดทะเบียนอยู่</a:t>
             </a:r>
             <a:endParaRPr lang="en-US" sz="1200" dirty="0"/>
+          </a:p>
+        </p:txBody>
+      </p:sp>
+      <p:sp>
+        <p:nvSpPr>
+          <p:cNvPr id="40" name="Text 38"/>
+          <p:cNvSpPr txBox="1"/>
+          <p:nvPr/>
+        </p:nvSpPr>
+        <p:spPr>
+          <a:xfrm>
+            <a:off x="548640" y="5760720"/>
+            <a:ext cx="6400800" cy="274320"/>
+          </a:xfrm>
+          <a:prstGeom prst="rect">
+            <a:avLst/>
+          </a:prstGeom>
+          <a:noFill/>
+          <a:ln/>
+        </p:spPr>
+        <p:txBody>
+          <a:bodyPr wrap="square" lIns="0" tIns="0" rIns="0" bIns="0" rtlCol="0" anchor="ctr"/>
+          <a:lstStyle/>
+          <a:p>
+            <a:pPr indent="0" marL="0">
+              <a:buNone/>
+            </a:pPr>
+            <a:r>
+              <a:rPr lang="en-US" sz="1100" i="1" dirty="0">
+                <a:solidFill>
+                  <a:srgbClr val="9AA5B1"/>
+                </a:solidFill>
+                <a:latin typeface="Leelawadee UI" pitchFamily="34" charset="0"/>
+                <a:ea typeface="Leelawadee UI" pitchFamily="34" charset="-122"/>
+                <a:cs typeface="Leelawadee UI" pitchFamily="34" charset="-120"/>
+              </a:rPr>
+              <a:t>หลายอุตสาหกรรม ไม่ใช่หุ้นเดียว — ลดความเสี่ยงที่โมเดลเรียนรู้เฉพาะบริษัทเดียว</a:t>
+            </a:r>
+            <a:endParaRPr lang="en-US" sz="1100" dirty="0"/>
           </a:p>
         </p:txBody>
       </p:sp>
@@ -13735,7 +13930,7 @@
                 <a:ea typeface="Leelawadee UI" pitchFamily="34" charset="-122"/>
                 <a:cs typeface="Leelawadee UI" pitchFamily="34" charset="-120"/>
               </a:rPr>
-              <a:t>ทุกแถวของ train เกิดก่อนทุกแถวของ test ทั้ง 20 หุ้นพร้อมกัน และตัดแถว train ที่ label (วันที่เป้าหมาย) ไปถึงช่วง test ออก (purge) — เทรนจากอดีต ทดสอบกับอนาคตที่ไม่เคยเห็น</a:t>
+              <a:t>ทุกแถวของ train เกิดก่อนทุกแถวของ test ทั้ง 20 หุ้นพร้อมกัน และตัดแถว train ที่ label (วันที่เป้าหมาย) ไปถึงช่วง test ออก (purge) การทำ CV ก็แบ่งตามวันที่และ purge เช่นกัน — เทรนจากอดีต ทดสอบกับอนาคตที่ไม่เคยเห็น</a:t>
             </a:r>
             <a:endParaRPr lang="en-US" sz="1300" dirty="0"/>
           </a:p>
@@ -15383,7 +15578,7 @@
                 <a:ea typeface="Leelawadee UI" pitchFamily="34" charset="-122"/>
                 <a:cs typeface="Leelawadee UI" pitchFamily="34" charset="-120"/>
               </a:rPr>
-              <a:t>ทุกโมเดลใกล้เคียง baseline ที่ทายกลุ่มมากสุดอย่างเดียว (51.3%) — ไม่มีโมเดลไหนชนะชัดเจน ช่วงความเชื่อมั่น 95% ของ ROC-AUC ของ XGBoost คือ 0.485–0.516 ครอบคลุม 0.5 จึงยังไม่พบว่าดีกว่าการเดาสุ่ม (แต่ไม่ได้พิสูจน์ว่าเท่ากับ 0.5 พอดี)</a:t>
+              <a:t>XGBoost: accuracy 50.6% เทียบ baseline ที่ทายกลุ่มมากสุด 51.3% · ROC-AUC 0.5005 (ช่วงความเชื่อมั่น 95% คือ 0.485–0.516 ครอบคลุม 0.5) จึงยังไม่พบว่าดีกว่าการเดาสุ่ม แต่ไม่ได้พิสูจน์ว่าเท่ากับ 0.5 พอดี · Logistic Regression และ Random Forest อยู่ในระดับใกล้เคียงกัน</a:t>
             </a:r>
             <a:endParaRPr lang="en-US" sz="1400" dirty="0"/>
           </a:p>

</xml_diff>